<commit_message>
Update documentation with SSL, system tray, and Clear All Records sections
Co-Authored-By: Claude Sonnet 4.6 <noreply@anthropic.com>
</commit_message>
<xml_diff>
--- a/AssetManager_Presentation.pptx
+++ b/AssetManager_Presentation.pptx
@@ -3261,7 +3261,7 @@
                 </a:solidFill>
                 <a:latin typeface="Calibri"/>
               </a:rPr>
-              <a:t>IT Department — Your Organization</a:t>
+              <a:t>IT Department — </a:t>
             </a:r>
           </a:p>
         </p:txBody>
@@ -7112,7 +7112,7 @@
                 </a:solidFill>
                 <a:latin typeface="Calibri"/>
               </a:rPr>
-              <a:t>AssetManager — IT Department, Your Organization</a:t>
+              <a:t>AssetManager — IT Department, </a:t>
             </a:r>
           </a:p>
         </p:txBody>

</xml_diff>

<commit_message>
Fix PPTX: resize screenshots to right half of slide -- screenshots were 9x6 covering all content, resized to 4.16x2.87 and repositioned to right half on slides 3,5,6,7,10,11 -- Co-Authored-By: Claude Sonnet 4.6 <noreply@anthropic.com>
</commit_message>
<xml_diff>
--- a/AssetManager_Presentation.pptx
+++ b/AssetManager_Presentation.pptx
@@ -4368,8 +4368,8 @@
         </p:blipFill>
         <p:spPr>
           <a:xfrm>
-            <a:off x="457200" y="1131570"/>
-            <a:ext cx="8229600" cy="5673610"/>
+            <a:off x="5029200" y="950000"/>
+            <a:ext cx="3800000" cy="2621000"/>
           </a:xfrm>
           <a:prstGeom prst="rect">
             <a:avLst/>
@@ -5139,8 +5139,8 @@
         </p:blipFill>
         <p:spPr>
           <a:xfrm>
-            <a:off x="2560320" y="1388745"/>
-            <a:ext cx="4023360" cy="1978214"/>
+            <a:off x="5074920" y="1024128"/>
+            <a:ext cx="3566160" cy="1756000"/>
           </a:xfrm>
           <a:prstGeom prst="rect">
             <a:avLst/>
@@ -9022,8 +9022,8 @@
         </p:blipFill>
         <p:spPr>
           <a:xfrm>
-            <a:off x="2651760" y="1543050"/>
-            <a:ext cx="6400800" cy="4412808"/>
+            <a:off x="5029200" y="950000"/>
+            <a:ext cx="3800000" cy="2621000"/>
           </a:xfrm>
           <a:prstGeom prst="rect">
             <a:avLst/>
@@ -10931,8 +10931,8 @@
         </p:blipFill>
         <p:spPr>
           <a:xfrm>
-            <a:off x="457200" y="1388745"/>
-            <a:ext cx="8229600" cy="5673610"/>
+            <a:off x="5029200" y="950000"/>
+            <a:ext cx="3800000" cy="2621000"/>
           </a:xfrm>
           <a:prstGeom prst="rect">
             <a:avLst/>
@@ -11422,8 +11422,8 @@
         </p:blipFill>
         <p:spPr>
           <a:xfrm>
-            <a:off x="457200" y="1388745"/>
-            <a:ext cx="8229600" cy="5673610"/>
+            <a:off x="5029200" y="950000"/>
+            <a:ext cx="3800000" cy="2621000"/>
           </a:xfrm>
           <a:prstGeom prst="rect">
             <a:avLst/>
@@ -12211,8 +12211,8 @@
         </p:blipFill>
         <p:spPr>
           <a:xfrm>
-            <a:off x="457200" y="1388745"/>
-            <a:ext cx="8229600" cy="5673610"/>
+            <a:off x="5029200" y="950000"/>
+            <a:ext cx="3800000" cy="2621000"/>
           </a:xfrm>
           <a:prstGeom prst="rect">
             <a:avLst/>

</xml_diff>

<commit_message>
Redesign PPTX: integrate screenshots into slides as big clear visuals -- Slide 3: each app screenshot framed inside its card. Slides 5/6/7: reflowed to two-column with large framed screenshot. Slides 10/11: screenshot fitted into reserved area, enlarged, framed. -- Co-Authored-By: Claude Opus 4.8 <noreply@anthropic.com>
</commit_message>
<xml_diff>
--- a/AssetManager_Presentation.pptx
+++ b/AssetManager_Presentation.pptx
@@ -4282,8 +4282,8 @@
         </p:nvSpPr>
         <p:spPr>
           <a:xfrm>
-            <a:off x="5074920" y="1024128"/>
-            <a:ext cx="3566160" cy="3767328"/>
+            <a:off x="4873752" y="1517904"/>
+            <a:ext cx="4151376" cy="2935224"/>
           </a:xfrm>
           <a:prstGeom prst="roundRect">
             <a:avLst/>
@@ -4347,7 +4347,7 @@
                 </a:solidFill>
                 <a:latin typeface="Calibri"/>
               </a:rPr>
-              <a:t>[ Demo / Screenshot here ]</a:t>
+              <a:t/>
             </a:r>
           </a:p>
         </p:txBody>
@@ -4368,12 +4368,24 @@
         </p:blipFill>
         <p:spPr>
           <a:xfrm>
-            <a:off x="5029200" y="950000"/>
-            <a:ext cx="3800000" cy="2621000"/>
-          </a:xfrm>
-          <a:prstGeom prst="rect">
-            <a:avLst/>
-          </a:prstGeom>
+            <a:off x="4983480" y="1627632"/>
+            <a:ext cx="3931920" cy="2715948"/>
+          </a:xfrm>
+          <a:prstGeom prst="rect">
+            <a:avLst/>
+          </a:prstGeom>
+          <a:ln w="9525">
+            <a:solidFill>
+              <a:srgbClr val="C8CDD2"/>
+            </a:solidFill>
+          </a:ln>
+          <a:effectLst>
+            <a:outerShdw blurRad="38100" dist="19050" dir="5400000" rotWithShape="0">
+              <a:srgbClr val="000000">
+                <a:alpha val="24000"/>
+              </a:srgbClr>
+            </a:outerShdw>
+          </a:effectLst>
         </p:spPr>
       </p:pic>
     </p:spTree>
@@ -5059,9 +5071,7 @@
           <a:prstGeom prst="roundRect">
             <a:avLst/>
           </a:prstGeom>
-          <a:solidFill>
-            <a:srgbClr val="E8E8E8"/>
-          </a:solidFill>
+          <a:noFill/>
           <a:ln>
             <a:noFill/>
           </a:ln>
@@ -5118,7 +5128,7 @@
                 </a:solidFill>
                 <a:latin typeface="Calibri"/>
               </a:rPr>
-              <a:t>[ Demo / Screenshot here ]</a:t>
+              <a:t/>
             </a:r>
           </a:p>
         </p:txBody>
@@ -5139,12 +5149,24 @@
         </p:blipFill>
         <p:spPr>
           <a:xfrm>
-            <a:off x="5074920" y="1024128"/>
-            <a:ext cx="3566160" cy="1756000"/>
-          </a:xfrm>
-          <a:prstGeom prst="rect">
-            <a:avLst/>
-          </a:prstGeom>
+            <a:off x="4983480" y="2002536"/>
+            <a:ext cx="3931920" cy="1938528"/>
+          </a:xfrm>
+          <a:prstGeom prst="rect">
+            <a:avLst/>
+          </a:prstGeom>
+          <a:ln w="9525">
+            <a:solidFill>
+              <a:srgbClr val="C8CDD2"/>
+            </a:solidFill>
+          </a:ln>
+          <a:effectLst>
+            <a:outerShdw blurRad="38100" dist="19050" dir="5400000" rotWithShape="0">
+              <a:srgbClr val="000000">
+                <a:alpha val="24000"/>
+              </a:srgbClr>
+            </a:outerShdw>
+          </a:effectLst>
         </p:spPr>
       </p:pic>
     </p:spTree>
@@ -8508,7 +8530,7 @@
         <p:spPr>
           <a:xfrm>
             <a:off x="667512" y="2432304"/>
-            <a:ext cx="2304288" cy="2103120"/>
+            <a:ext cx="2304288" cy="1051560"/>
           </a:xfrm>
           <a:prstGeom prst="rect">
             <a:avLst/>
@@ -8720,7 +8742,7 @@
         <p:spPr>
           <a:xfrm>
             <a:off x="3502152" y="2432304"/>
-            <a:ext cx="2304288" cy="2103120"/>
+            <a:ext cx="2304288" cy="1051560"/>
           </a:xfrm>
           <a:prstGeom prst="rect">
             <a:avLst/>
@@ -8932,7 +8954,7 @@
         <p:spPr>
           <a:xfrm>
             <a:off x="6336792" y="2432304"/>
-            <a:ext cx="2304288" cy="2103120"/>
+            <a:ext cx="2304288" cy="1051560"/>
           </a:xfrm>
           <a:prstGeom prst="rect">
             <a:avLst/>
@@ -8998,12 +9020,24 @@
         </p:blipFill>
         <p:spPr>
           <a:xfrm>
-            <a:off x="91440" y="1748790"/>
-            <a:ext cx="2377440" cy="2897824"/>
-          </a:xfrm>
-          <a:prstGeom prst="rect">
-            <a:avLst/>
-          </a:prstGeom>
+            <a:off x="1344168" y="3520440"/>
+            <a:ext cx="950976" cy="1161288"/>
+          </a:xfrm>
+          <a:prstGeom prst="rect">
+            <a:avLst/>
+          </a:prstGeom>
+          <a:ln w="9525">
+            <a:solidFill>
+              <a:srgbClr val="C8CDD2"/>
+            </a:solidFill>
+          </a:ln>
+          <a:effectLst>
+            <a:outerShdw blurRad="38100" dist="19050" dir="5400000" rotWithShape="0">
+              <a:srgbClr val="000000">
+                <a:alpha val="24000"/>
+              </a:srgbClr>
+            </a:outerShdw>
+          </a:effectLst>
         </p:spPr>
       </p:pic>
       <p:pic>
@@ -9022,12 +9056,24 @@
         </p:blipFill>
         <p:spPr>
           <a:xfrm>
-            <a:off x="5029200" y="950000"/>
-            <a:ext cx="3800000" cy="2621000"/>
-          </a:xfrm>
-          <a:prstGeom prst="rect">
-            <a:avLst/>
-          </a:prstGeom>
+            <a:off x="3813048" y="3520440"/>
+            <a:ext cx="1682496" cy="1161288"/>
+          </a:xfrm>
+          <a:prstGeom prst="rect">
+            <a:avLst/>
+          </a:prstGeom>
+          <a:ln w="9525">
+            <a:solidFill>
+              <a:srgbClr val="C8CDD2"/>
+            </a:solidFill>
+          </a:ln>
+          <a:effectLst>
+            <a:outerShdw blurRad="38100" dist="19050" dir="5400000" rotWithShape="0">
+              <a:srgbClr val="000000">
+                <a:alpha val="24000"/>
+              </a:srgbClr>
+            </a:outerShdw>
+          </a:effectLst>
         </p:spPr>
       </p:pic>
       <p:pic>
@@ -9046,12 +9092,24 @@
         </p:blipFill>
         <p:spPr>
           <a:xfrm>
-            <a:off x="6583680" y="3188970"/>
-            <a:ext cx="2468880" cy="1213904"/>
-          </a:xfrm>
-          <a:prstGeom prst="rect">
-            <a:avLst/>
-          </a:prstGeom>
+            <a:off x="6391656" y="3561588"/>
+            <a:ext cx="2194560" cy="1079112"/>
+          </a:xfrm>
+          <a:prstGeom prst="rect">
+            <a:avLst/>
+          </a:prstGeom>
+          <a:ln w="9525">
+            <a:solidFill>
+              <a:srgbClr val="C8CDD2"/>
+            </a:solidFill>
+          </a:ln>
+          <a:effectLst>
+            <a:outerShdw blurRad="38100" dist="19050" dir="5400000" rotWithShape="0">
+              <a:srgbClr val="000000">
+                <a:alpha val="24000"/>
+              </a:srgbClr>
+            </a:outerShdw>
+          </a:effectLst>
         </p:spPr>
       </p:pic>
     </p:spTree>
@@ -10494,401 +10552,13 @@
       </p:sp>
       <p:sp>
         <p:nvSpPr>
-          <p:cNvPr id="8" name="Rounded Rectangle 7"/>
-          <p:cNvSpPr/>
-          <p:nvPr/>
-        </p:nvSpPr>
-        <p:spPr>
-          <a:xfrm>
-            <a:off x="4754880" y="1051560"/>
-            <a:ext cx="3931920" cy="2788920"/>
-          </a:xfrm>
-          <a:prstGeom prst="roundRect">
-            <a:avLst/>
-          </a:prstGeom>
-          <a:solidFill>
-            <a:srgbClr val="F1F8FE"/>
-          </a:solidFill>
-          <a:ln>
-            <a:noFill/>
-          </a:ln>
-        </p:spPr>
-        <p:style>
-          <a:lnRef idx="1">
-            <a:schemeClr val="accent1"/>
-          </a:lnRef>
-          <a:fillRef idx="3">
-            <a:schemeClr val="accent1"/>
-          </a:fillRef>
-          <a:effectRef idx="2">
-            <a:schemeClr val="accent1"/>
-          </a:effectRef>
-          <a:fontRef idx="minor">
-            <a:schemeClr val="lt1"/>
-          </a:fontRef>
-        </p:style>
-        <p:txBody>
-          <a:bodyPr rtlCol="0" anchor="ctr"/>
-          <a:lstStyle/>
-          <a:p>
-            <a:pPr algn="ctr"/>
-          </a:p>
-        </p:txBody>
-      </p:sp>
-      <p:sp>
-        <p:nvSpPr>
-          <p:cNvPr id="9" name="TextBox 8"/>
-          <p:cNvSpPr txBox="1"/>
-          <p:nvPr/>
-        </p:nvSpPr>
-        <p:spPr>
-          <a:xfrm>
-            <a:off x="4956048" y="1261872"/>
-            <a:ext cx="3566160" cy="320040"/>
-          </a:xfrm>
-          <a:prstGeom prst="rect">
-            <a:avLst/>
-          </a:prstGeom>
-          <a:noFill/>
-        </p:spPr>
-        <p:txBody>
-          <a:bodyPr wrap="square" lIns="0" rIns="0" tIns="18288" bIns="18288">
-            <a:spAutoFit/>
-          </a:bodyPr>
-          <a:lstStyle/>
-          <a:p>
-            <a:pPr algn="l"/>
-            <a:r>
-              <a:rPr sz="1250" b="1" i="0">
-                <a:solidFill>
-                  <a:srgbClr val="1A1A2E"/>
-                </a:solidFill>
-                <a:latin typeface="Calibri"/>
-              </a:rPr>
-              <a:t>Asset Number:</a:t>
-            </a:r>
-          </a:p>
-        </p:txBody>
-      </p:sp>
-      <p:sp>
-        <p:nvSpPr>
-          <p:cNvPr id="10" name="Rounded Rectangle 9"/>
-          <p:cNvSpPr/>
-          <p:nvPr/>
-        </p:nvSpPr>
-        <p:spPr>
-          <a:xfrm>
-            <a:off x="4956048" y="1618488"/>
-            <a:ext cx="3566160" cy="347472"/>
-          </a:xfrm>
-          <a:prstGeom prst="roundRect">
-            <a:avLst/>
-          </a:prstGeom>
-          <a:solidFill>
-            <a:srgbClr val="FFFFFF"/>
-          </a:solidFill>
-          <a:ln w="10160">
-            <a:solidFill>
-              <a:srgbClr val="CBD5E1"/>
-            </a:solidFill>
-          </a:ln>
-        </p:spPr>
-        <p:style>
-          <a:lnRef idx="1">
-            <a:schemeClr val="accent1"/>
-          </a:lnRef>
-          <a:fillRef idx="3">
-            <a:schemeClr val="accent1"/>
-          </a:fillRef>
-          <a:effectRef idx="2">
-            <a:schemeClr val="accent1"/>
-          </a:effectRef>
-          <a:fontRef idx="minor">
-            <a:schemeClr val="lt1"/>
-          </a:fontRef>
-        </p:style>
-        <p:txBody>
-          <a:bodyPr rtlCol="0" anchor="ctr"/>
-          <a:lstStyle/>
-          <a:p>
-            <a:pPr algn="ctr"/>
-          </a:p>
-        </p:txBody>
-      </p:sp>
-      <p:sp>
-        <p:nvSpPr>
-          <p:cNvPr id="11" name="TextBox 10"/>
-          <p:cNvSpPr txBox="1"/>
-          <p:nvPr/>
-        </p:nvSpPr>
-        <p:spPr>
-          <a:xfrm>
-            <a:off x="5065776" y="1618488"/>
-            <a:ext cx="3383280" cy="347472"/>
-          </a:xfrm>
-          <a:prstGeom prst="rect">
-            <a:avLst/>
-          </a:prstGeom>
-          <a:noFill/>
-        </p:spPr>
-        <p:txBody>
-          <a:bodyPr wrap="square" lIns="0" rIns="0" tIns="18288" bIns="18288">
-            <a:spAutoFit/>
-          </a:bodyPr>
-          <a:lstStyle/>
-          <a:p>
-            <a:pPr algn="l"/>
-            <a:r>
-              <a:rPr sz="1350" b="1" i="0">
-                <a:solidFill>
-                  <a:srgbClr val="1A1A2E"/>
-                </a:solidFill>
-                <a:latin typeface="Calibri"/>
-              </a:rPr>
-              <a:t>1042</a:t>
-            </a:r>
-          </a:p>
-        </p:txBody>
-      </p:sp>
-      <p:sp>
-        <p:nvSpPr>
-          <p:cNvPr id="12" name="TextBox 11"/>
-          <p:cNvSpPr txBox="1"/>
-          <p:nvPr/>
-        </p:nvSpPr>
-        <p:spPr>
-          <a:xfrm>
-            <a:off x="4956048" y="2029968"/>
-            <a:ext cx="3566160" cy="292608"/>
-          </a:xfrm>
-          <a:prstGeom prst="rect">
-            <a:avLst/>
-          </a:prstGeom>
-          <a:noFill/>
-        </p:spPr>
-        <p:txBody>
-          <a:bodyPr wrap="square" lIns="0" rIns="0" tIns="18288" bIns="18288">
-            <a:spAutoFit/>
-          </a:bodyPr>
-          <a:lstStyle/>
-          <a:p>
-            <a:pPr algn="l"/>
-            <a:r>
-              <a:rPr sz="1250" b="1" i="0">
-                <a:solidFill>
-                  <a:srgbClr val="1A1A2E"/>
-                </a:solidFill>
-                <a:latin typeface="Calibri"/>
-              </a:rPr>
-              <a:t>Type:</a:t>
-            </a:r>
-          </a:p>
-        </p:txBody>
-      </p:sp>
-      <p:sp>
-        <p:nvSpPr>
-          <p:cNvPr id="13" name="Rounded Rectangle 12"/>
-          <p:cNvSpPr/>
-          <p:nvPr/>
-        </p:nvSpPr>
-        <p:spPr>
-          <a:xfrm>
-            <a:off x="4956048" y="2359152"/>
-            <a:ext cx="3566160" cy="347472"/>
-          </a:xfrm>
-          <a:prstGeom prst="roundRect">
-            <a:avLst/>
-          </a:prstGeom>
-          <a:solidFill>
-            <a:srgbClr val="F0FDF4"/>
-          </a:solidFill>
-          <a:ln w="10160">
-            <a:solidFill>
-              <a:srgbClr val="86EFAC"/>
-            </a:solidFill>
-          </a:ln>
-        </p:spPr>
-        <p:style>
-          <a:lnRef idx="1">
-            <a:schemeClr val="accent1"/>
-          </a:lnRef>
-          <a:fillRef idx="3">
-            <a:schemeClr val="accent1"/>
-          </a:fillRef>
-          <a:effectRef idx="2">
-            <a:schemeClr val="accent1"/>
-          </a:effectRef>
-          <a:fontRef idx="minor">
-            <a:schemeClr val="lt1"/>
-          </a:fontRef>
-        </p:style>
-        <p:txBody>
-          <a:bodyPr rtlCol="0" anchor="ctr"/>
-          <a:lstStyle/>
-          <a:p>
-            <a:pPr algn="ctr"/>
-          </a:p>
-        </p:txBody>
-      </p:sp>
-      <p:sp>
-        <p:nvSpPr>
-          <p:cNvPr id="14" name="TextBox 13"/>
-          <p:cNvSpPr txBox="1"/>
-          <p:nvPr/>
-        </p:nvSpPr>
-        <p:spPr>
-          <a:xfrm>
-            <a:off x="5065776" y="2359152"/>
-            <a:ext cx="3383280" cy="347472"/>
-          </a:xfrm>
-          <a:prstGeom prst="rect">
-            <a:avLst/>
-          </a:prstGeom>
-          <a:noFill/>
-        </p:spPr>
-        <p:txBody>
-          <a:bodyPr wrap="square" lIns="0" rIns="0" tIns="18288" bIns="18288">
-            <a:spAutoFit/>
-          </a:bodyPr>
-          <a:lstStyle/>
-          <a:p>
-            <a:pPr algn="l"/>
-            <a:r>
-              <a:rPr sz="1250" b="0" i="0">
-                <a:solidFill>
-                  <a:srgbClr val="16A34A"/>
-                </a:solidFill>
-                <a:latin typeface="Segoe UI Emoji"/>
-              </a:rPr>
-              <a:t>✅  Laptop  (auto)</a:t>
-            </a:r>
-          </a:p>
-        </p:txBody>
-      </p:sp>
-      <p:sp>
-        <p:nvSpPr>
-          <p:cNvPr id="15" name="TextBox 14"/>
-          <p:cNvSpPr txBox="1"/>
-          <p:nvPr/>
-        </p:nvSpPr>
-        <p:spPr>
-          <a:xfrm>
-            <a:off x="4956048" y="2779776"/>
-            <a:ext cx="3566160" cy="292608"/>
-          </a:xfrm>
-          <a:prstGeom prst="rect">
-            <a:avLst/>
-          </a:prstGeom>
-          <a:noFill/>
-        </p:spPr>
-        <p:txBody>
-          <a:bodyPr wrap="square" lIns="0" rIns="0" tIns="18288" bIns="18288">
-            <a:spAutoFit/>
-          </a:bodyPr>
-          <a:lstStyle/>
-          <a:p>
-            <a:pPr algn="l"/>
-            <a:r>
-              <a:rPr sz="1250" b="1" i="0">
-                <a:solidFill>
-                  <a:srgbClr val="1A1A2E"/>
-                </a:solidFill>
-                <a:latin typeface="Calibri"/>
-              </a:rPr>
-              <a:t>Model:</a:t>
-            </a:r>
-          </a:p>
-        </p:txBody>
-      </p:sp>
-      <p:sp>
-        <p:nvSpPr>
-          <p:cNvPr id="16" name="Rounded Rectangle 15"/>
-          <p:cNvSpPr/>
-          <p:nvPr/>
-        </p:nvSpPr>
-        <p:spPr>
-          <a:xfrm>
-            <a:off x="4956048" y="3127248"/>
-            <a:ext cx="3566160" cy="347472"/>
-          </a:xfrm>
-          <a:prstGeom prst="roundRect">
-            <a:avLst/>
-          </a:prstGeom>
-          <a:solidFill>
-            <a:srgbClr val="F0FDF4"/>
-          </a:solidFill>
-          <a:ln w="10160">
-            <a:solidFill>
-              <a:srgbClr val="86EFAC"/>
-            </a:solidFill>
-          </a:ln>
-        </p:spPr>
-        <p:style>
-          <a:lnRef idx="1">
-            <a:schemeClr val="accent1"/>
-          </a:lnRef>
-          <a:fillRef idx="3">
-            <a:schemeClr val="accent1"/>
-          </a:fillRef>
-          <a:effectRef idx="2">
-            <a:schemeClr val="accent1"/>
-          </a:effectRef>
-          <a:fontRef idx="minor">
-            <a:schemeClr val="lt1"/>
-          </a:fontRef>
-        </p:style>
-        <p:txBody>
-          <a:bodyPr rtlCol="0" anchor="ctr"/>
-          <a:lstStyle/>
-          <a:p>
-            <a:pPr algn="ctr"/>
-          </a:p>
-        </p:txBody>
-      </p:sp>
-      <p:sp>
-        <p:nvSpPr>
-          <p:cNvPr id="17" name="TextBox 16"/>
-          <p:cNvSpPr txBox="1"/>
-          <p:nvPr/>
-        </p:nvSpPr>
-        <p:spPr>
-          <a:xfrm>
-            <a:off x="5065776" y="3127248"/>
-            <a:ext cx="3383280" cy="347472"/>
-          </a:xfrm>
-          <a:prstGeom prst="rect">
-            <a:avLst/>
-          </a:prstGeom>
-          <a:noFill/>
-        </p:spPr>
-        <p:txBody>
-          <a:bodyPr wrap="square" lIns="0" rIns="0" tIns="18288" bIns="18288">
-            <a:spAutoFit/>
-          </a:bodyPr>
-          <a:lstStyle/>
-          <a:p>
-            <a:pPr algn="l"/>
-            <a:r>
-              <a:rPr sz="1250" b="0" i="0">
-                <a:solidFill>
-                  <a:srgbClr val="16A34A"/>
-                </a:solidFill>
-                <a:latin typeface="Segoe UI Emoji"/>
-              </a:rPr>
-              <a:t>✅  Dell Latitude 5530  (auto)</a:t>
-            </a:r>
-          </a:p>
-        </p:txBody>
-      </p:sp>
-      <p:sp>
-        <p:nvSpPr>
           <p:cNvPr id="18" name="TextBox 17"/>
           <p:cNvSpPr txBox="1"/>
           <p:nvPr/>
         </p:nvSpPr>
         <p:spPr>
           <a:xfrm>
-            <a:off x="4754880" y="3977639"/>
+            <a:off x="4617720" y="4206240"/>
             <a:ext cx="3931920" cy="320040"/>
           </a:xfrm>
           <a:prstGeom prst="rect">
@@ -10931,12 +10601,24 @@
         </p:blipFill>
         <p:spPr>
           <a:xfrm>
-            <a:off x="5029200" y="950000"/>
-            <a:ext cx="3800000" cy="2621000"/>
-          </a:xfrm>
-          <a:prstGeom prst="rect">
-            <a:avLst/>
-          </a:prstGeom>
+            <a:off x="4617720" y="1188720"/>
+            <a:ext cx="4206240" cy="2898648"/>
+          </a:xfrm>
+          <a:prstGeom prst="rect">
+            <a:avLst/>
+          </a:prstGeom>
+          <a:ln w="9525">
+            <a:solidFill>
+              <a:srgbClr val="C8CDD2"/>
+            </a:solidFill>
+          </a:ln>
+          <a:effectLst>
+            <a:outerShdw blurRad="38100" dist="19050" dir="5400000" rotWithShape="0">
+              <a:srgbClr val="000000">
+                <a:alpha val="24000"/>
+              </a:srgbClr>
+            </a:outerShdw>
+          </a:effectLst>
         </p:spPr>
       </p:pic>
     </p:spTree>
@@ -11051,8 +10733,8 @@
         </p:nvSpPr>
         <p:spPr>
           <a:xfrm>
-            <a:off x="1645920" y="1051560"/>
-            <a:ext cx="5852160" cy="3383280"/>
+            <a:off x="502920" y="1051560"/>
+            <a:ext cx="3977640" cy="3383280"/>
           </a:xfrm>
           <a:prstGeom prst="roundRect">
             <a:avLst/>
@@ -11094,8 +10776,8 @@
         </p:nvSpPr>
         <p:spPr>
           <a:xfrm>
-            <a:off x="1828800" y="1207008"/>
-            <a:ext cx="5486400" cy="457200"/>
+            <a:off x="662940" y="1188720"/>
+            <a:ext cx="3657600" cy="457200"/>
           </a:xfrm>
           <a:prstGeom prst="rect">
             <a:avLst/>
@@ -11129,8 +10811,8 @@
         </p:nvSpPr>
         <p:spPr>
           <a:xfrm>
-            <a:off x="3474720" y="1755648"/>
-            <a:ext cx="2194560" cy="914400"/>
+            <a:off x="1394460" y="1645920"/>
+            <a:ext cx="2194560" cy="777240"/>
           </a:xfrm>
           <a:prstGeom prst="roundRect">
             <a:avLst/>
@@ -11172,8 +10854,8 @@
         </p:nvSpPr>
         <p:spPr>
           <a:xfrm>
-            <a:off x="3474720" y="1755648"/>
-            <a:ext cx="2194560" cy="914400"/>
+            <a:off x="1394460" y="1645920"/>
+            <a:ext cx="2194560" cy="777240"/>
           </a:xfrm>
           <a:prstGeom prst="rect">
             <a:avLst/>
@@ -11207,8 +10889,8 @@
         </p:nvSpPr>
         <p:spPr>
           <a:xfrm>
-            <a:off x="1828800" y="2816352"/>
-            <a:ext cx="5486400" cy="594360"/>
+            <a:off x="662940" y="2560320"/>
+            <a:ext cx="3657600" cy="594360"/>
           </a:xfrm>
           <a:prstGeom prst="rect">
             <a:avLst/>
@@ -11254,8 +10936,8 @@
         </p:nvSpPr>
         <p:spPr>
           <a:xfrm>
-            <a:off x="1920240" y="3520440"/>
-            <a:ext cx="2743200" cy="594360"/>
+            <a:off x="868680" y="3246120"/>
+            <a:ext cx="3108960" cy="457200"/>
           </a:xfrm>
           <a:prstGeom prst="roundRect">
             <a:avLst/>
@@ -11299,8 +10981,8 @@
         </p:nvSpPr>
         <p:spPr>
           <a:xfrm>
-            <a:off x="2011680" y="3520440"/>
-            <a:ext cx="2560320" cy="594360"/>
+            <a:off x="960120" y="3246120"/>
+            <a:ext cx="2926080" cy="457200"/>
           </a:xfrm>
           <a:prstGeom prst="rect">
             <a:avLst/>
@@ -11334,8 +11016,8 @@
         </p:nvSpPr>
         <p:spPr>
           <a:xfrm>
-            <a:off x="4846320" y="3520440"/>
-            <a:ext cx="2743200" cy="594360"/>
+            <a:off x="868680" y="3794760"/>
+            <a:ext cx="3108960" cy="457200"/>
           </a:xfrm>
           <a:prstGeom prst="roundRect">
             <a:avLst/>
@@ -11379,8 +11061,8 @@
         </p:nvSpPr>
         <p:spPr>
           <a:xfrm>
-            <a:off x="4937760" y="3520440"/>
-            <a:ext cx="2560320" cy="594360"/>
+            <a:off x="960120" y="3794760"/>
+            <a:ext cx="2926080" cy="457200"/>
           </a:xfrm>
           <a:prstGeom prst="rect">
             <a:avLst/>
@@ -11422,12 +11104,24 @@
         </p:blipFill>
         <p:spPr>
           <a:xfrm>
-            <a:off x="5029200" y="950000"/>
-            <a:ext cx="3800000" cy="2621000"/>
-          </a:xfrm>
-          <a:prstGeom prst="rect">
-            <a:avLst/>
-          </a:prstGeom>
+            <a:off x="4617720" y="1325880"/>
+            <a:ext cx="4206240" cy="2898648"/>
+          </a:xfrm>
+          <a:prstGeom prst="rect">
+            <a:avLst/>
+          </a:prstGeom>
+          <a:ln w="9525">
+            <a:solidFill>
+              <a:srgbClr val="C8CDD2"/>
+            </a:solidFill>
+          </a:ln>
+          <a:effectLst>
+            <a:outerShdw blurRad="38100" dist="19050" dir="5400000" rotWithShape="0">
+              <a:srgbClr val="000000">
+                <a:alpha val="24000"/>
+              </a:srgbClr>
+            </a:outerShdw>
+          </a:effectLst>
         </p:spPr>
       </p:pic>
     </p:spTree>
@@ -11934,267 +11628,6 @@
           </a:p>
         </p:txBody>
       </p:sp>
-      <p:sp>
-        <p:nvSpPr>
-          <p:cNvPr id="14" name="Rounded Rectangle 13"/>
-          <p:cNvSpPr/>
-          <p:nvPr/>
-        </p:nvSpPr>
-        <p:spPr>
-          <a:xfrm>
-            <a:off x="4828032" y="1024128"/>
-            <a:ext cx="3858768" cy="3730752"/>
-          </a:xfrm>
-          <a:prstGeom prst="roundRect">
-            <a:avLst/>
-          </a:prstGeom>
-          <a:solidFill>
-            <a:srgbClr val="E6F3FC"/>
-          </a:solidFill>
-          <a:ln>
-            <a:noFill/>
-          </a:ln>
-        </p:spPr>
-        <p:style>
-          <a:lnRef idx="1">
-            <a:schemeClr val="accent1"/>
-          </a:lnRef>
-          <a:fillRef idx="3">
-            <a:schemeClr val="accent1"/>
-          </a:fillRef>
-          <a:effectRef idx="2">
-            <a:schemeClr val="accent1"/>
-          </a:effectRef>
-          <a:fontRef idx="minor">
-            <a:schemeClr val="lt1"/>
-          </a:fontRef>
-        </p:style>
-        <p:txBody>
-          <a:bodyPr rtlCol="0" anchor="ctr"/>
-          <a:lstStyle/>
-          <a:p>
-            <a:pPr algn="ctr"/>
-          </a:p>
-        </p:txBody>
-      </p:sp>
-      <p:sp>
-        <p:nvSpPr>
-          <p:cNvPr id="15" name="TextBox 14"/>
-          <p:cNvSpPr txBox="1"/>
-          <p:nvPr/>
-        </p:nvSpPr>
-        <p:spPr>
-          <a:xfrm>
-            <a:off x="5029200" y="1207008"/>
-            <a:ext cx="3474720" cy="384048"/>
-          </a:xfrm>
-          <a:prstGeom prst="rect">
-            <a:avLst/>
-          </a:prstGeom>
-          <a:noFill/>
-        </p:spPr>
-        <p:txBody>
-          <a:bodyPr wrap="square" lIns="0" rIns="0" tIns="18288" bIns="18288">
-            <a:spAutoFit/>
-          </a:bodyPr>
-          <a:lstStyle/>
-          <a:p>
-            <a:pPr algn="l"/>
-            <a:r>
-              <a:rPr sz="1450" b="1" i="0">
-                <a:solidFill>
-                  <a:srgbClr val="1A1A2E"/>
-                </a:solidFill>
-                <a:latin typeface="Calibri"/>
-              </a:rPr>
-              <a:t>Charts included:</a:t>
-            </a:r>
-          </a:p>
-        </p:txBody>
-      </p:sp>
-      <p:sp>
-        <p:nvSpPr>
-          <p:cNvPr id="16" name="TextBox 15"/>
-          <p:cNvSpPr txBox="1"/>
-          <p:nvPr/>
-        </p:nvSpPr>
-        <p:spPr>
-          <a:xfrm>
-            <a:off x="5029200" y="1719072"/>
-            <a:ext cx="3474720" cy="384048"/>
-          </a:xfrm>
-          <a:prstGeom prst="rect">
-            <a:avLst/>
-          </a:prstGeom>
-          <a:noFill/>
-        </p:spPr>
-        <p:txBody>
-          <a:bodyPr wrap="square" lIns="0" rIns="0" tIns="18288" bIns="18288">
-            <a:spAutoFit/>
-          </a:bodyPr>
-          <a:lstStyle/>
-          <a:p>
-            <a:pPr algn="l"/>
-            <a:r>
-              <a:rPr sz="1350" b="0" i="0">
-                <a:solidFill>
-                  <a:srgbClr val="1A1A2E"/>
-                </a:solidFill>
-                <a:latin typeface="Calibri"/>
-              </a:rPr>
-              <a:t>•  Status bar chart</a:t>
-            </a:r>
-          </a:p>
-        </p:txBody>
-      </p:sp>
-      <p:sp>
-        <p:nvSpPr>
-          <p:cNvPr id="17" name="TextBox 16"/>
-          <p:cNvSpPr txBox="1"/>
-          <p:nvPr/>
-        </p:nvSpPr>
-        <p:spPr>
-          <a:xfrm>
-            <a:off x="5029200" y="2194560"/>
-            <a:ext cx="3474720" cy="384048"/>
-          </a:xfrm>
-          <a:prstGeom prst="rect">
-            <a:avLst/>
-          </a:prstGeom>
-          <a:noFill/>
-        </p:spPr>
-        <p:txBody>
-          <a:bodyPr wrap="square" lIns="0" rIns="0" tIns="18288" bIns="18288">
-            <a:spAutoFit/>
-          </a:bodyPr>
-          <a:lstStyle/>
-          <a:p>
-            <a:pPr algn="l"/>
-            <a:r>
-              <a:rPr sz="1350" b="0" i="0">
-                <a:solidFill>
-                  <a:srgbClr val="1A1A2E"/>
-                </a:solidFill>
-                <a:latin typeface="Calibri"/>
-              </a:rPr>
-              <a:t>•  Per-engineer bar chart</a:t>
-            </a:r>
-          </a:p>
-        </p:txBody>
-      </p:sp>
-      <p:sp>
-        <p:nvSpPr>
-          <p:cNvPr id="18" name="TextBox 17"/>
-          <p:cNvSpPr txBox="1"/>
-          <p:nvPr/>
-        </p:nvSpPr>
-        <p:spPr>
-          <a:xfrm>
-            <a:off x="5029200" y="2670048"/>
-            <a:ext cx="3474720" cy="384048"/>
-          </a:xfrm>
-          <a:prstGeom prst="rect">
-            <a:avLst/>
-          </a:prstGeom>
-          <a:noFill/>
-        </p:spPr>
-        <p:txBody>
-          <a:bodyPr wrap="square" lIns="0" rIns="0" tIns="18288" bIns="18288">
-            <a:spAutoFit/>
-          </a:bodyPr>
-          <a:lstStyle/>
-          <a:p>
-            <a:pPr algn="l"/>
-            <a:r>
-              <a:rPr sz="1350" b="0" i="0">
-                <a:solidFill>
-                  <a:srgbClr val="1A1A2E"/>
-                </a:solidFill>
-                <a:latin typeface="Calibri"/>
-              </a:rPr>
-              <a:t>•  In vs Out pie chart</a:t>
-            </a:r>
-          </a:p>
-        </p:txBody>
-      </p:sp>
-      <p:sp>
-        <p:nvSpPr>
-          <p:cNvPr id="19" name="Rectangle 18"/>
-          <p:cNvSpPr/>
-          <p:nvPr/>
-        </p:nvSpPr>
-        <p:spPr>
-          <a:xfrm>
-            <a:off x="5029200" y="3218688"/>
-            <a:ext cx="3474720" cy="27432"/>
-          </a:xfrm>
-          <a:prstGeom prst="rect">
-            <a:avLst/>
-          </a:prstGeom>
-          <a:solidFill>
-            <a:srgbClr val="CBD5E1"/>
-          </a:solidFill>
-          <a:ln>
-            <a:noFill/>
-          </a:ln>
-        </p:spPr>
-        <p:style>
-          <a:lnRef idx="1">
-            <a:schemeClr val="accent1"/>
-          </a:lnRef>
-          <a:fillRef idx="3">
-            <a:schemeClr val="accent1"/>
-          </a:fillRef>
-          <a:effectRef idx="2">
-            <a:schemeClr val="accent1"/>
-          </a:effectRef>
-          <a:fontRef idx="minor">
-            <a:schemeClr val="lt1"/>
-          </a:fontRef>
-        </p:style>
-        <p:txBody>
-          <a:bodyPr rtlCol="0" anchor="ctr"/>
-          <a:lstStyle/>
-          <a:p>
-            <a:pPr algn="ctr"/>
-          </a:p>
-        </p:txBody>
-      </p:sp>
-      <p:sp>
-        <p:nvSpPr>
-          <p:cNvPr id="20" name="TextBox 19"/>
-          <p:cNvSpPr txBox="1"/>
-          <p:nvPr/>
-        </p:nvSpPr>
-        <p:spPr>
-          <a:xfrm>
-            <a:off x="5029200" y="3337560"/>
-            <a:ext cx="3474720" cy="347472"/>
-          </a:xfrm>
-          <a:prstGeom prst="rect">
-            <a:avLst/>
-          </a:prstGeom>
-          <a:noFill/>
-        </p:spPr>
-        <p:txBody>
-          <a:bodyPr wrap="square" lIns="0" rIns="0" tIns="18288" bIns="18288">
-            <a:spAutoFit/>
-          </a:bodyPr>
-          <a:lstStyle/>
-          <a:p>
-            <a:pPr algn="l"/>
-            <a:r>
-              <a:rPr sz="1200" b="0" i="1">
-                <a:solidFill>
-                  <a:srgbClr val="64748B"/>
-                </a:solidFill>
-                <a:latin typeface="Calibri"/>
-              </a:rPr>
-              <a:t>Includes the new Model column</a:t>
-            </a:r>
-          </a:p>
-        </p:txBody>
-      </p:sp>
       <p:pic>
         <p:nvPicPr>
           <p:cNvPr id="21" name="Picture 20" descr="06_storekeeper_history.png"/>
@@ -12211,12 +11644,24 @@
         </p:blipFill>
         <p:spPr>
           <a:xfrm>
-            <a:off x="5029200" y="950000"/>
-            <a:ext cx="3800000" cy="2621000"/>
-          </a:xfrm>
-          <a:prstGeom prst="rect">
-            <a:avLst/>
-          </a:prstGeom>
+            <a:off x="4572000" y="1362456"/>
+            <a:ext cx="4297680" cy="2962656"/>
+          </a:xfrm>
+          <a:prstGeom prst="rect">
+            <a:avLst/>
+          </a:prstGeom>
+          <a:ln w="9525">
+            <a:solidFill>
+              <a:srgbClr val="C8CDD2"/>
+            </a:solidFill>
+          </a:ln>
+          <a:effectLst>
+            <a:outerShdw blurRad="38100" dist="19050" dir="5400000" rotWithShape="0">
+              <a:srgbClr val="000000">
+                <a:alpha val="24000"/>
+              </a:srgbClr>
+            </a:outerShdw>
+          </a:effectLst>
         </p:spPr>
       </p:pic>
     </p:spTree>

</xml_diff>

<commit_message>
PPTX: remove What's New slide, clarify slide 5, slim demo slides -- Removed What's New. Slide 5: 'Just 1 Field' + clearer subtext, dropped lookup caption. Demo slides cut to essentials (7 to 4, 5 to 3 steps). -- Co-Authored-By: Claude Opus 4.8 <noreply@anthropic.com>
</commit_message>
<xml_diff>
--- a/AssetManager_Presentation.pptx
+++ b/AssetManager_Presentation.pptx
@@ -13,7 +13,6 @@
     <p:sldId id="261" r:id="rId12"/>
     <p:sldId id="262" r:id="rId13"/>
     <p:sldId id="263" r:id="rId14"/>
-    <p:sldId id="264" r:id="rId15"/>
     <p:sldId id="265" r:id="rId16"/>
     <p:sldId id="266" r:id="rId17"/>
     <p:sldId id="267" r:id="rId18"/>
@@ -3491,7 +3490,7 @@
         </p:nvSpPr>
         <p:spPr>
           <a:xfrm>
-            <a:off x="630936" y="932688"/>
+            <a:off x="630936" y="1097280"/>
             <a:ext cx="512064" cy="512064"/>
           </a:xfrm>
           <a:prstGeom prst="ellipse">
@@ -3534,7 +3533,7 @@
         </p:nvSpPr>
         <p:spPr>
           <a:xfrm>
-            <a:off x="630936" y="932688"/>
+            <a:off x="630936" y="1097280"/>
             <a:ext cx="512064" cy="512064"/>
           </a:xfrm>
           <a:prstGeom prst="rect">
@@ -3569,7 +3568,7 @@
         </p:nvSpPr>
         <p:spPr>
           <a:xfrm>
-            <a:off x="1298448" y="1042416"/>
+            <a:off x="1298448" y="1207008"/>
             <a:ext cx="3566160" cy="384048"/>
           </a:xfrm>
           <a:prstGeom prst="rect">
@@ -3591,7 +3590,7 @@
                 </a:solidFill>
                 <a:latin typeface="Calibri"/>
               </a:rPr>
-              <a:t>Open Storekeeper App</a:t>
+              <a:t>Open app — set Out / In Store</a:t>
             </a:r>
           </a:p>
         </p:txBody>
@@ -3604,7 +3603,7 @@
         </p:nvSpPr>
         <p:spPr>
           <a:xfrm>
-            <a:off x="630936" y="1472184"/>
+            <a:off x="630936" y="1920240"/>
             <a:ext cx="512064" cy="512064"/>
           </a:xfrm>
           <a:prstGeom prst="ellipse">
@@ -3647,7 +3646,7 @@
         </p:nvSpPr>
         <p:spPr>
           <a:xfrm>
-            <a:off x="630936" y="1472184"/>
+            <a:off x="630936" y="1920240"/>
             <a:ext cx="512064" cy="512064"/>
           </a:xfrm>
           <a:prstGeom prst="rect">
@@ -3682,7 +3681,7 @@
         </p:nvSpPr>
         <p:spPr>
           <a:xfrm>
-            <a:off x="1298448" y="1581912"/>
+            <a:off x="1298448" y="2030328"/>
             <a:ext cx="3566160" cy="384048"/>
           </a:xfrm>
           <a:prstGeom prst="rect">
@@ -3704,7 +3703,7 @@
                 </a:solidFill>
                 <a:latin typeface="Calibri"/>
               </a:rPr>
-              <a:t>Select direction: Out Store</a:t>
+              <a:t>Enter Asset No. or Serial</a:t>
             </a:r>
           </a:p>
         </p:txBody>
@@ -3717,7 +3716,7 @@
         </p:nvSpPr>
         <p:spPr>
           <a:xfrm>
-            <a:off x="630936" y="2011680"/>
+            <a:off x="630936" y="2743200"/>
             <a:ext cx="512064" cy="512064"/>
           </a:xfrm>
           <a:prstGeom prst="ellipse">
@@ -3760,7 +3759,7 @@
         </p:nvSpPr>
         <p:spPr>
           <a:xfrm>
-            <a:off x="630936" y="2011680"/>
+            <a:off x="630936" y="2743200"/>
             <a:ext cx="512064" cy="512064"/>
           </a:xfrm>
           <a:prstGeom prst="rect">
@@ -3795,7 +3794,7 @@
         </p:nvSpPr>
         <p:spPr>
           <a:xfrm>
-            <a:off x="1298448" y="2121408"/>
+            <a:off x="1298448" y="2853408"/>
             <a:ext cx="3566160" cy="384048"/>
           </a:xfrm>
           <a:prstGeom prst="rect">
@@ -3817,7 +3816,7 @@
                 </a:solidFill>
                 <a:latin typeface="Calibri"/>
               </a:rPr>
-              <a:t>Enter Asset Number or Serial</a:t>
+              <a:t>Type &amp; Model auto-fill; pick engineer</a:t>
             </a:r>
           </a:p>
         </p:txBody>
@@ -3830,7 +3829,7 @@
         </p:nvSpPr>
         <p:spPr>
           <a:xfrm>
-            <a:off x="630936" y="2551176"/>
+            <a:off x="630936" y="3566160"/>
             <a:ext cx="512064" cy="512064"/>
           </a:xfrm>
           <a:prstGeom prst="ellipse">
@@ -3873,7 +3872,7 @@
         </p:nvSpPr>
         <p:spPr>
           <a:xfrm>
-            <a:off x="630936" y="2551176"/>
+            <a:off x="630936" y="3566160"/>
             <a:ext cx="512064" cy="512064"/>
           </a:xfrm>
           <a:prstGeom prst="rect">
@@ -3908,7 +3907,7 @@
         </p:nvSpPr>
         <p:spPr>
           <a:xfrm>
-            <a:off x="1298448" y="2660904"/>
+            <a:off x="1298448" y="3676248"/>
             <a:ext cx="3566160" cy="384048"/>
           </a:xfrm>
           <a:prstGeom prst="rect">
@@ -3930,346 +3929,7 @@
                 </a:solidFill>
                 <a:latin typeface="Calibri"/>
               </a:rPr>
-              <a:t>Type + Model auto-fill → locked</a:t>
-            </a:r>
-          </a:p>
-        </p:txBody>
-      </p:sp>
-      <p:sp>
-        <p:nvSpPr>
-          <p:cNvPr id="16" name="Oval 15"/>
-          <p:cNvSpPr/>
-          <p:nvPr/>
-        </p:nvSpPr>
-        <p:spPr>
-          <a:xfrm>
-            <a:off x="630936" y="3090672"/>
-            <a:ext cx="512064" cy="512064"/>
-          </a:xfrm>
-          <a:prstGeom prst="ellipse">
-            <a:avLst/>
-          </a:prstGeom>
-          <a:solidFill>
-            <a:srgbClr val="0078D4"/>
-          </a:solidFill>
-          <a:ln>
-            <a:noFill/>
-          </a:ln>
-        </p:spPr>
-        <p:style>
-          <a:lnRef idx="1">
-            <a:schemeClr val="accent1"/>
-          </a:lnRef>
-          <a:fillRef idx="3">
-            <a:schemeClr val="accent1"/>
-          </a:fillRef>
-          <a:effectRef idx="2">
-            <a:schemeClr val="accent1"/>
-          </a:effectRef>
-          <a:fontRef idx="minor">
-            <a:schemeClr val="lt1"/>
-          </a:fontRef>
-        </p:style>
-        <p:txBody>
-          <a:bodyPr rtlCol="0" anchor="ctr"/>
-          <a:lstStyle/>
-          <a:p>
-            <a:pPr algn="ctr"/>
-          </a:p>
-        </p:txBody>
-      </p:sp>
-      <p:sp>
-        <p:nvSpPr>
-          <p:cNvPr id="17" name="TextBox 16"/>
-          <p:cNvSpPr txBox="1"/>
-          <p:nvPr/>
-        </p:nvSpPr>
-        <p:spPr>
-          <a:xfrm>
-            <a:off x="630936" y="3090672"/>
-            <a:ext cx="512064" cy="512064"/>
-          </a:xfrm>
-          <a:prstGeom prst="rect">
-            <a:avLst/>
-          </a:prstGeom>
-          <a:noFill/>
-        </p:spPr>
-        <p:txBody>
-          <a:bodyPr wrap="square" lIns="0" rIns="0" tIns="18288" bIns="18288">
-            <a:spAutoFit/>
-          </a:bodyPr>
-          <a:lstStyle/>
-          <a:p>
-            <a:pPr algn="ctr"/>
-            <a:r>
-              <a:rPr sz="1400" b="1" i="0">
-                <a:solidFill>
-                  <a:srgbClr val="FFFFFF"/>
-                </a:solidFill>
-                <a:latin typeface="Calibri"/>
-              </a:rPr>
-              <a:t>5</a:t>
-            </a:r>
-          </a:p>
-        </p:txBody>
-      </p:sp>
-      <p:sp>
-        <p:nvSpPr>
-          <p:cNvPr id="18" name="TextBox 17"/>
-          <p:cNvSpPr txBox="1"/>
-          <p:nvPr/>
-        </p:nvSpPr>
-        <p:spPr>
-          <a:xfrm>
-            <a:off x="1298448" y="3200400"/>
-            <a:ext cx="3566160" cy="384048"/>
-          </a:xfrm>
-          <a:prstGeom prst="rect">
-            <a:avLst/>
-          </a:prstGeom>
-          <a:noFill/>
-        </p:spPr>
-        <p:txBody>
-          <a:bodyPr wrap="square" lIns="0" rIns="0" tIns="18288" bIns="18288">
-            <a:spAutoFit/>
-          </a:bodyPr>
-          <a:lstStyle/>
-          <a:p>
-            <a:pPr algn="l"/>
-            <a:r>
-              <a:rPr sz="1250" b="0" i="0">
-                <a:solidFill>
-                  <a:srgbClr val="1A1A2E"/>
-                </a:solidFill>
-                <a:latin typeface="Calibri"/>
-              </a:rPr>
-              <a:t>Select engineer from dropdown</a:t>
-            </a:r>
-          </a:p>
-        </p:txBody>
-      </p:sp>
-      <p:sp>
-        <p:nvSpPr>
-          <p:cNvPr id="19" name="Oval 18"/>
-          <p:cNvSpPr/>
-          <p:nvPr/>
-        </p:nvSpPr>
-        <p:spPr>
-          <a:xfrm>
-            <a:off x="630936" y="3630168"/>
-            <a:ext cx="512064" cy="512064"/>
-          </a:xfrm>
-          <a:prstGeom prst="ellipse">
-            <a:avLst/>
-          </a:prstGeom>
-          <a:solidFill>
-            <a:srgbClr val="0078D4"/>
-          </a:solidFill>
-          <a:ln>
-            <a:noFill/>
-          </a:ln>
-        </p:spPr>
-        <p:style>
-          <a:lnRef idx="1">
-            <a:schemeClr val="accent1"/>
-          </a:lnRef>
-          <a:fillRef idx="3">
-            <a:schemeClr val="accent1"/>
-          </a:fillRef>
-          <a:effectRef idx="2">
-            <a:schemeClr val="accent1"/>
-          </a:effectRef>
-          <a:fontRef idx="minor">
-            <a:schemeClr val="lt1"/>
-          </a:fontRef>
-        </p:style>
-        <p:txBody>
-          <a:bodyPr rtlCol="0" anchor="ctr"/>
-          <a:lstStyle/>
-          <a:p>
-            <a:pPr algn="ctr"/>
-          </a:p>
-        </p:txBody>
-      </p:sp>
-      <p:sp>
-        <p:nvSpPr>
-          <p:cNvPr id="20" name="TextBox 19"/>
-          <p:cNvSpPr txBox="1"/>
-          <p:nvPr/>
-        </p:nvSpPr>
-        <p:spPr>
-          <a:xfrm>
-            <a:off x="630936" y="3630168"/>
-            <a:ext cx="512064" cy="512064"/>
-          </a:xfrm>
-          <a:prstGeom prst="rect">
-            <a:avLst/>
-          </a:prstGeom>
-          <a:noFill/>
-        </p:spPr>
-        <p:txBody>
-          <a:bodyPr wrap="square" lIns="0" rIns="0" tIns="18288" bIns="18288">
-            <a:spAutoFit/>
-          </a:bodyPr>
-          <a:lstStyle/>
-          <a:p>
-            <a:pPr algn="ctr"/>
-            <a:r>
-              <a:rPr sz="1400" b="1" i="0">
-                <a:solidFill>
-                  <a:srgbClr val="FFFFFF"/>
-                </a:solidFill>
-                <a:latin typeface="Calibri"/>
-              </a:rPr>
-              <a:t>6</a:t>
-            </a:r>
-          </a:p>
-        </p:txBody>
-      </p:sp>
-      <p:sp>
-        <p:nvSpPr>
-          <p:cNvPr id="21" name="TextBox 20"/>
-          <p:cNvSpPr txBox="1"/>
-          <p:nvPr/>
-        </p:nvSpPr>
-        <p:spPr>
-          <a:xfrm>
-            <a:off x="1298448" y="3739896"/>
-            <a:ext cx="3566160" cy="384048"/>
-          </a:xfrm>
-          <a:prstGeom prst="rect">
-            <a:avLst/>
-          </a:prstGeom>
-          <a:noFill/>
-        </p:spPr>
-        <p:txBody>
-          <a:bodyPr wrap="square" lIns="0" rIns="0" tIns="18288" bIns="18288">
-            <a:spAutoFit/>
-          </a:bodyPr>
-          <a:lstStyle/>
-          <a:p>
-            <a:pPr algn="l"/>
-            <a:r>
-              <a:rPr sz="1250" b="0" i="0">
-                <a:solidFill>
-                  <a:srgbClr val="1A1A2E"/>
-                </a:solidFill>
-                <a:latin typeface="Calibri"/>
-              </a:rPr>
-              <a:t>Click Submit</a:t>
-            </a:r>
-          </a:p>
-        </p:txBody>
-      </p:sp>
-      <p:sp>
-        <p:nvSpPr>
-          <p:cNvPr id="22" name="Oval 21"/>
-          <p:cNvSpPr/>
-          <p:nvPr/>
-        </p:nvSpPr>
-        <p:spPr>
-          <a:xfrm>
-            <a:off x="630936" y="4169663"/>
-            <a:ext cx="512064" cy="512064"/>
-          </a:xfrm>
-          <a:prstGeom prst="ellipse">
-            <a:avLst/>
-          </a:prstGeom>
-          <a:solidFill>
-            <a:srgbClr val="0078D4"/>
-          </a:solidFill>
-          <a:ln>
-            <a:noFill/>
-          </a:ln>
-        </p:spPr>
-        <p:style>
-          <a:lnRef idx="1">
-            <a:schemeClr val="accent1"/>
-          </a:lnRef>
-          <a:fillRef idx="3">
-            <a:schemeClr val="accent1"/>
-          </a:fillRef>
-          <a:effectRef idx="2">
-            <a:schemeClr val="accent1"/>
-          </a:effectRef>
-          <a:fontRef idx="minor">
-            <a:schemeClr val="lt1"/>
-          </a:fontRef>
-        </p:style>
-        <p:txBody>
-          <a:bodyPr rtlCol="0" anchor="ctr"/>
-          <a:lstStyle/>
-          <a:p>
-            <a:pPr algn="ctr"/>
-          </a:p>
-        </p:txBody>
-      </p:sp>
-      <p:sp>
-        <p:nvSpPr>
-          <p:cNvPr id="23" name="TextBox 22"/>
-          <p:cNvSpPr txBox="1"/>
-          <p:nvPr/>
-        </p:nvSpPr>
-        <p:spPr>
-          <a:xfrm>
-            <a:off x="630936" y="4169663"/>
-            <a:ext cx="512064" cy="512064"/>
-          </a:xfrm>
-          <a:prstGeom prst="rect">
-            <a:avLst/>
-          </a:prstGeom>
-          <a:noFill/>
-        </p:spPr>
-        <p:txBody>
-          <a:bodyPr wrap="square" lIns="0" rIns="0" tIns="18288" bIns="18288">
-            <a:spAutoFit/>
-          </a:bodyPr>
-          <a:lstStyle/>
-          <a:p>
-            <a:pPr algn="ctr"/>
-            <a:r>
-              <a:rPr sz="1400" b="1" i="0">
-                <a:solidFill>
-                  <a:srgbClr val="FFFFFF"/>
-                </a:solidFill>
-                <a:latin typeface="Calibri"/>
-              </a:rPr>
-              <a:t>7</a:t>
-            </a:r>
-          </a:p>
-        </p:txBody>
-      </p:sp>
-      <p:sp>
-        <p:nvSpPr>
-          <p:cNvPr id="24" name="TextBox 23"/>
-          <p:cNvSpPr txBox="1"/>
-          <p:nvPr/>
-        </p:nvSpPr>
-        <p:spPr>
-          <a:xfrm>
-            <a:off x="1298448" y="4279392"/>
-            <a:ext cx="3566160" cy="384048"/>
-          </a:xfrm>
-          <a:prstGeom prst="rect">
-            <a:avLst/>
-          </a:prstGeom>
-          <a:noFill/>
-        </p:spPr>
-        <p:txBody>
-          <a:bodyPr wrap="square" lIns="0" rIns="0" tIns="18288" bIns="18288">
-            <a:spAutoFit/>
-          </a:bodyPr>
-          <a:lstStyle/>
-          <a:p>
-            <a:pPr algn="l"/>
-            <a:r>
-              <a:rPr sz="1250" b="0" i="0">
-                <a:solidFill>
-                  <a:srgbClr val="1A1A2E"/>
-                </a:solidFill>
-                <a:latin typeface="Calibri"/>
-              </a:rPr>
-              <a:t>Engineer receives notification instantly</a:t>
+              <a:t>Submit — engineer notified instantly</a:t>
             </a:r>
           </a:p>
         </p:txBody>
@@ -4500,7 +4160,7 @@
         </p:nvSpPr>
         <p:spPr>
           <a:xfrm>
-            <a:off x="630936" y="987551"/>
+            <a:off x="630936" y="1371600"/>
             <a:ext cx="512064" cy="512064"/>
           </a:xfrm>
           <a:prstGeom prst="ellipse">
@@ -4543,7 +4203,7 @@
         </p:nvSpPr>
         <p:spPr>
           <a:xfrm>
-            <a:off x="630936" y="987551"/>
+            <a:off x="630936" y="1371600"/>
             <a:ext cx="512064" cy="512064"/>
           </a:xfrm>
           <a:prstGeom prst="rect">
@@ -4578,7 +4238,7 @@
         </p:nvSpPr>
         <p:spPr>
           <a:xfrm>
-            <a:off x="1298448" y="1097280"/>
+            <a:off x="1298448" y="1481328"/>
             <a:ext cx="3566160" cy="384048"/>
           </a:xfrm>
           <a:prstGeom prst="rect">
@@ -4600,7 +4260,7 @@
                 </a:solidFill>
                 <a:latin typeface="Calibri"/>
               </a:rPr>
-              <a:t>Launch NotifierApp.exe -- runs in system tray</a:t>
+              <a:t>Runs quietly in the system tray</a:t>
             </a:r>
           </a:p>
         </p:txBody>
@@ -4613,7 +4273,7 @@
         </p:nvSpPr>
         <p:spPr>
           <a:xfrm>
-            <a:off x="630936" y="1645920"/>
+            <a:off x="630936" y="2331720"/>
             <a:ext cx="512064" cy="512064"/>
           </a:xfrm>
           <a:prstGeom prst="ellipse">
@@ -4656,7 +4316,7 @@
         </p:nvSpPr>
         <p:spPr>
           <a:xfrm>
-            <a:off x="630936" y="1645920"/>
+            <a:off x="630936" y="2331720"/>
             <a:ext cx="512064" cy="512064"/>
           </a:xfrm>
           <a:prstGeom prst="rect">
@@ -4691,7 +4351,7 @@
         </p:nvSpPr>
         <p:spPr>
           <a:xfrm>
-            <a:off x="1298448" y="1755648"/>
+            <a:off x="1298448" y="2441448"/>
             <a:ext cx="3566160" cy="384048"/>
           </a:xfrm>
           <a:prstGeom prst="rect">
@@ -4726,7 +4386,7 @@
         </p:nvSpPr>
         <p:spPr>
           <a:xfrm>
-            <a:off x="630936" y="2304288"/>
+            <a:off x="630936" y="3291840"/>
             <a:ext cx="512064" cy="512064"/>
           </a:xfrm>
           <a:prstGeom prst="ellipse">
@@ -4769,7 +4429,7 @@
         </p:nvSpPr>
         <p:spPr>
           <a:xfrm>
-            <a:off x="630936" y="2304288"/>
+            <a:off x="630936" y="3291840"/>
             <a:ext cx="512064" cy="512064"/>
           </a:xfrm>
           <a:prstGeom prst="rect">
@@ -4804,7 +4464,7 @@
         </p:nvSpPr>
         <p:spPr>
           <a:xfrm>
-            <a:off x="1298448" y="2414016"/>
+            <a:off x="1298448" y="3401568"/>
             <a:ext cx="3566160" cy="384048"/>
           </a:xfrm>
           <a:prstGeom prst="rect">
@@ -4826,233 +4486,7 @@
                 </a:solidFill>
                 <a:latin typeface="Calibri"/>
               </a:rPr>
-              <a:t>Shows: Type, Model, Asset No., Direction</a:t>
-            </a:r>
-          </a:p>
-        </p:txBody>
-      </p:sp>
-      <p:sp>
-        <p:nvSpPr>
-          <p:cNvPr id="13" name="Oval 12"/>
-          <p:cNvSpPr/>
-          <p:nvPr/>
-        </p:nvSpPr>
-        <p:spPr>
-          <a:xfrm>
-            <a:off x="630936" y="2962656"/>
-            <a:ext cx="512064" cy="512064"/>
-          </a:xfrm>
-          <a:prstGeom prst="ellipse">
-            <a:avLst/>
-          </a:prstGeom>
-          <a:solidFill>
-            <a:srgbClr val="0078D4"/>
-          </a:solidFill>
-          <a:ln>
-            <a:noFill/>
-          </a:ln>
-        </p:spPr>
-        <p:style>
-          <a:lnRef idx="1">
-            <a:schemeClr val="accent1"/>
-          </a:lnRef>
-          <a:fillRef idx="3">
-            <a:schemeClr val="accent1"/>
-          </a:fillRef>
-          <a:effectRef idx="2">
-            <a:schemeClr val="accent1"/>
-          </a:effectRef>
-          <a:fontRef idx="minor">
-            <a:schemeClr val="lt1"/>
-          </a:fontRef>
-        </p:style>
-        <p:txBody>
-          <a:bodyPr rtlCol="0" anchor="ctr"/>
-          <a:lstStyle/>
-          <a:p>
-            <a:pPr algn="ctr"/>
-          </a:p>
-        </p:txBody>
-      </p:sp>
-      <p:sp>
-        <p:nvSpPr>
-          <p:cNvPr id="14" name="TextBox 13"/>
-          <p:cNvSpPr txBox="1"/>
-          <p:nvPr/>
-        </p:nvSpPr>
-        <p:spPr>
-          <a:xfrm>
-            <a:off x="630936" y="2962656"/>
-            <a:ext cx="512064" cy="512064"/>
-          </a:xfrm>
-          <a:prstGeom prst="rect">
-            <a:avLst/>
-          </a:prstGeom>
-          <a:noFill/>
-        </p:spPr>
-        <p:txBody>
-          <a:bodyPr wrap="square" lIns="0" rIns="0" tIns="18288" bIns="18288">
-            <a:spAutoFit/>
-          </a:bodyPr>
-          <a:lstStyle/>
-          <a:p>
-            <a:pPr algn="ctr"/>
-            <a:r>
-              <a:rPr sz="1400" b="1" i="0">
-                <a:solidFill>
-                  <a:srgbClr val="FFFFFF"/>
-                </a:solidFill>
-                <a:latin typeface="Calibri"/>
-              </a:rPr>
-              <a:t>4</a:t>
-            </a:r>
-          </a:p>
-        </p:txBody>
-      </p:sp>
-      <p:sp>
-        <p:nvSpPr>
-          <p:cNvPr id="15" name="TextBox 14"/>
-          <p:cNvSpPr txBox="1"/>
-          <p:nvPr/>
-        </p:nvSpPr>
-        <p:spPr>
-          <a:xfrm>
-            <a:off x="1298448" y="3072384"/>
-            <a:ext cx="3566160" cy="384048"/>
-          </a:xfrm>
-          <a:prstGeom prst="rect">
-            <a:avLst/>
-          </a:prstGeom>
-          <a:noFill/>
-        </p:spPr>
-        <p:txBody>
-          <a:bodyPr wrap="square" lIns="0" rIns="0" tIns="18288" bIns="18288">
-            <a:spAutoFit/>
-          </a:bodyPr>
-          <a:lstStyle/>
-          <a:p>
-            <a:pPr algn="l"/>
-            <a:r>
-              <a:rPr sz="1250" b="0" i="0">
-                <a:solidFill>
-                  <a:srgbClr val="1A1A2E"/>
-                </a:solidFill>
-                <a:latin typeface="Calibri"/>
-              </a:rPr>
-              <a:t>Click Confirm or Reject</a:t>
-            </a:r>
-          </a:p>
-        </p:txBody>
-      </p:sp>
-      <p:sp>
-        <p:nvSpPr>
-          <p:cNvPr id="16" name="Oval 15"/>
-          <p:cNvSpPr/>
-          <p:nvPr/>
-        </p:nvSpPr>
-        <p:spPr>
-          <a:xfrm>
-            <a:off x="630936" y="3621023"/>
-            <a:ext cx="512064" cy="512064"/>
-          </a:xfrm>
-          <a:prstGeom prst="ellipse">
-            <a:avLst/>
-          </a:prstGeom>
-          <a:solidFill>
-            <a:srgbClr val="0078D4"/>
-          </a:solidFill>
-          <a:ln>
-            <a:noFill/>
-          </a:ln>
-        </p:spPr>
-        <p:style>
-          <a:lnRef idx="1">
-            <a:schemeClr val="accent1"/>
-          </a:lnRef>
-          <a:fillRef idx="3">
-            <a:schemeClr val="accent1"/>
-          </a:fillRef>
-          <a:effectRef idx="2">
-            <a:schemeClr val="accent1"/>
-          </a:effectRef>
-          <a:fontRef idx="minor">
-            <a:schemeClr val="lt1"/>
-          </a:fontRef>
-        </p:style>
-        <p:txBody>
-          <a:bodyPr rtlCol="0" anchor="ctr"/>
-          <a:lstStyle/>
-          <a:p>
-            <a:pPr algn="ctr"/>
-          </a:p>
-        </p:txBody>
-      </p:sp>
-      <p:sp>
-        <p:nvSpPr>
-          <p:cNvPr id="17" name="TextBox 16"/>
-          <p:cNvSpPr txBox="1"/>
-          <p:nvPr/>
-        </p:nvSpPr>
-        <p:spPr>
-          <a:xfrm>
-            <a:off x="630936" y="3621023"/>
-            <a:ext cx="512064" cy="512064"/>
-          </a:xfrm>
-          <a:prstGeom prst="rect">
-            <a:avLst/>
-          </a:prstGeom>
-          <a:noFill/>
-        </p:spPr>
-        <p:txBody>
-          <a:bodyPr wrap="square" lIns="0" rIns="0" tIns="18288" bIns="18288">
-            <a:spAutoFit/>
-          </a:bodyPr>
-          <a:lstStyle/>
-          <a:p>
-            <a:pPr algn="ctr"/>
-            <a:r>
-              <a:rPr sz="1400" b="1" i="0">
-                <a:solidFill>
-                  <a:srgbClr val="FFFFFF"/>
-                </a:solidFill>
-                <a:latin typeface="Calibri"/>
-              </a:rPr>
-              <a:t>5</a:t>
-            </a:r>
-          </a:p>
-        </p:txBody>
-      </p:sp>
-      <p:sp>
-        <p:nvSpPr>
-          <p:cNvPr id="18" name="TextBox 17"/>
-          <p:cNvSpPr txBox="1"/>
-          <p:nvPr/>
-        </p:nvSpPr>
-        <p:spPr>
-          <a:xfrm>
-            <a:off x="1298448" y="3730751"/>
-            <a:ext cx="3566160" cy="384048"/>
-          </a:xfrm>
-          <a:prstGeom prst="rect">
-            <a:avLst/>
-          </a:prstGeom>
-          <a:noFill/>
-        </p:spPr>
-        <p:txBody>
-          <a:bodyPr wrap="square" lIns="0" rIns="0" tIns="18288" bIns="18288">
-            <a:spAutoFit/>
-          </a:bodyPr>
-          <a:lstStyle/>
-          <a:p>
-            <a:pPr algn="l"/>
-            <a:r>
-              <a:rPr sz="1250" b="0" i="0">
-                <a:solidFill>
-                  <a:srgbClr val="1A1A2E"/>
-                </a:solidFill>
-                <a:latin typeface="Calibri"/>
-              </a:rPr>
-              <a:t>Status updates in real time for storekeeper</a:t>
+              <a:t>Confirm or Reject — updates live</a:t>
             </a:r>
           </a:p>
         </p:txBody>
@@ -10475,7 +9909,7 @@
                 </a:solidFill>
                 <a:latin typeface="Calibri"/>
               </a:rPr>
-              <a:t>1 field</a:t>
+              <a:t>Just 1 Field</a:t>
             </a:r>
           </a:p>
         </p:txBody>
@@ -10510,7 +9944,7 @@
                 </a:solidFill>
                 <a:latin typeface="Calibri"/>
               </a:rPr>
-              <a:t>Enter asset number or serial —</a:t>
+              <a:t>Enter the Asset No. or Serial No.</a:t>
             </a:r>
           </a:p>
         </p:txBody>
@@ -10545,42 +9979,7 @@
                 </a:solidFill>
                 <a:latin typeface="Calibri"/>
               </a:rPr>
-              <a:t>Type AND Model fill in automatically and lock.</a:t>
-            </a:r>
-          </a:p>
-        </p:txBody>
-      </p:sp>
-      <p:sp>
-        <p:nvSpPr>
-          <p:cNvPr id="18" name="TextBox 17"/>
-          <p:cNvSpPr txBox="1"/>
-          <p:nvPr/>
-        </p:nvSpPr>
-        <p:spPr>
-          <a:xfrm>
-            <a:off x="4617720" y="4206240"/>
-            <a:ext cx="3931920" cy="320040"/>
-          </a:xfrm>
-          <a:prstGeom prst="rect">
-            <a:avLst/>
-          </a:prstGeom>
-          <a:noFill/>
-        </p:spPr>
-        <p:txBody>
-          <a:bodyPr wrap="square" lIns="0" rIns="0" tIns="18288" bIns="18288">
-            <a:spAutoFit/>
-          </a:bodyPr>
-          <a:lstStyle/>
-          <a:p>
-            <a:pPr algn="ctr"/>
-            <a:r>
-              <a:rPr sz="1100" b="0" i="1">
-                <a:solidFill>
-                  <a:srgbClr val="64748B"/>
-                </a:solidFill>
-                <a:latin typeface="Calibri"/>
-              </a:rPr>
-              <a:t>Powered by asset_lookup.xlsx — editable anytime</a:t>
+              <a:t>Type &amp; Model auto-fill — then lock.</a:t>
             </a:r>
           </a:p>
         </p:txBody>
@@ -12612,1802 +12011,6 @@
                 <a:latin typeface="Calibri"/>
               </a:rPr>
               <a:t/>
-            </a:r>
-          </a:p>
-        </p:txBody>
-      </p:sp>
-    </p:spTree>
-  </p:cSld>
-  <p:clrMapOvr>
-    <a:masterClrMapping/>
-  </p:clrMapOvr>
-</p:sld>
-</file>
-
-<file path=ppt/slides/slide9.xml><?xml version="1.0" encoding="utf-8"?>
-<p:sld xmlns:a="http://schemas.openxmlformats.org/drawingml/2006/main" xmlns:p="http://schemas.openxmlformats.org/presentationml/2006/main" xmlns:r="http://schemas.openxmlformats.org/officeDocument/2006/relationships">
-  <p:cSld>
-    <p:bg>
-      <p:bgPr>
-        <a:solidFill>
-          <a:srgbClr val="0F2137"/>
-        </a:solidFill>
-        <a:effectLst/>
-      </p:bgPr>
-    </p:bg>
-    <p:spTree>
-      <p:nvGrpSpPr>
-        <p:cNvPr id="1" name=""/>
-        <p:cNvGrpSpPr/>
-        <p:nvPr/>
-      </p:nvGrpSpPr>
-      <p:grpSpPr/>
-      <p:sp>
-        <p:nvSpPr>
-          <p:cNvPr id="2" name="TextBox 1"/>
-          <p:cNvSpPr txBox="1"/>
-          <p:nvPr/>
-        </p:nvSpPr>
-        <p:spPr>
-          <a:xfrm>
-            <a:off x="502920" y="228600"/>
-            <a:ext cx="8229600" cy="594360"/>
-          </a:xfrm>
-          <a:prstGeom prst="rect">
-            <a:avLst/>
-          </a:prstGeom>
-          <a:noFill/>
-        </p:spPr>
-        <p:txBody>
-          <a:bodyPr wrap="square" lIns="0" rIns="0" tIns="18288" bIns="18288">
-            <a:spAutoFit/>
-          </a:bodyPr>
-          <a:lstStyle/>
-          <a:p>
-            <a:pPr algn="l"/>
-            <a:r>
-              <a:rPr sz="3000" b="1" i="0">
-                <a:solidFill>
-                  <a:srgbClr val="FFFFFF"/>
-                </a:solidFill>
-                <a:latin typeface="Calibri"/>
-              </a:rPr>
-              <a:t>What's New</a:t>
-            </a:r>
-          </a:p>
-        </p:txBody>
-      </p:sp>
-      <p:sp>
-        <p:nvSpPr>
-          <p:cNvPr id="3" name="Rectangle 2"/>
-          <p:cNvSpPr/>
-          <p:nvPr/>
-        </p:nvSpPr>
-        <p:spPr>
-          <a:xfrm>
-            <a:off x="502920" y="868680"/>
-            <a:ext cx="8138160" cy="27432"/>
-          </a:xfrm>
-          <a:prstGeom prst="rect">
-            <a:avLst/>
-          </a:prstGeom>
-          <a:solidFill>
-            <a:srgbClr val="1E4A7A"/>
-          </a:solidFill>
-          <a:ln>
-            <a:noFill/>
-          </a:ln>
-        </p:spPr>
-        <p:style>
-          <a:lnRef idx="1">
-            <a:schemeClr val="accent1"/>
-          </a:lnRef>
-          <a:fillRef idx="3">
-            <a:schemeClr val="accent1"/>
-          </a:fillRef>
-          <a:effectRef idx="2">
-            <a:schemeClr val="accent1"/>
-          </a:effectRef>
-          <a:fontRef idx="minor">
-            <a:schemeClr val="lt1"/>
-          </a:fontRef>
-        </p:style>
-        <p:txBody>
-          <a:bodyPr rtlCol="0" anchor="ctr"/>
-          <a:lstStyle/>
-          <a:p>
-            <a:pPr algn="ctr"/>
-          </a:p>
-        </p:txBody>
-      </p:sp>
-      <p:sp>
-        <p:nvSpPr>
-          <p:cNvPr id="4" name="Rounded Rectangle 3"/>
-          <p:cNvSpPr/>
-          <p:nvPr/>
-        </p:nvSpPr>
-        <p:spPr>
-          <a:xfrm>
-            <a:off x="502920" y="1005840"/>
-            <a:ext cx="4023360" cy="1143000"/>
-          </a:xfrm>
-          <a:prstGeom prst="roundRect">
-            <a:avLst/>
-          </a:prstGeom>
-          <a:solidFill>
-            <a:srgbClr val="173455"/>
-          </a:solidFill>
-          <a:ln>
-            <a:noFill/>
-          </a:ln>
-        </p:spPr>
-        <p:style>
-          <a:lnRef idx="1">
-            <a:schemeClr val="accent1"/>
-          </a:lnRef>
-          <a:fillRef idx="3">
-            <a:schemeClr val="accent1"/>
-          </a:fillRef>
-          <a:effectRef idx="2">
-            <a:schemeClr val="accent1"/>
-          </a:effectRef>
-          <a:fontRef idx="minor">
-            <a:schemeClr val="lt1"/>
-          </a:fontRef>
-        </p:style>
-        <p:txBody>
-          <a:bodyPr rtlCol="0" anchor="ctr"/>
-          <a:lstStyle/>
-          <a:p>
-            <a:pPr algn="ctr"/>
-          </a:p>
-        </p:txBody>
-      </p:sp>
-      <p:sp>
-        <p:nvSpPr>
-          <p:cNvPr id="5" name="Oval 4"/>
-          <p:cNvSpPr/>
-          <p:nvPr/>
-        </p:nvSpPr>
-        <p:spPr>
-          <a:xfrm>
-            <a:off x="667512" y="1353312"/>
-            <a:ext cx="438912" cy="438912"/>
-          </a:xfrm>
-          <a:prstGeom prst="ellipse">
-            <a:avLst/>
-          </a:prstGeom>
-          <a:solidFill>
-            <a:srgbClr val="0078D4"/>
-          </a:solidFill>
-          <a:ln>
-            <a:noFill/>
-          </a:ln>
-        </p:spPr>
-        <p:style>
-          <a:lnRef idx="1">
-            <a:schemeClr val="accent1"/>
-          </a:lnRef>
-          <a:fillRef idx="3">
-            <a:schemeClr val="accent1"/>
-          </a:fillRef>
-          <a:effectRef idx="2">
-            <a:schemeClr val="accent1"/>
-          </a:effectRef>
-          <a:fontRef idx="minor">
-            <a:schemeClr val="lt1"/>
-          </a:fontRef>
-        </p:style>
-        <p:txBody>
-          <a:bodyPr rtlCol="0" anchor="ctr"/>
-          <a:lstStyle/>
-          <a:p>
-            <a:pPr algn="ctr"/>
-          </a:p>
-        </p:txBody>
-      </p:sp>
-      <p:sp>
-        <p:nvSpPr>
-          <p:cNvPr id="6" name="TextBox 5"/>
-          <p:cNvSpPr txBox="1"/>
-          <p:nvPr/>
-        </p:nvSpPr>
-        <p:spPr>
-          <a:xfrm>
-            <a:off x="667512" y="1344168"/>
-            <a:ext cx="438912" cy="438912"/>
-          </a:xfrm>
-          <a:prstGeom prst="rect">
-            <a:avLst/>
-          </a:prstGeom>
-          <a:noFill/>
-        </p:spPr>
-        <p:txBody>
-          <a:bodyPr wrap="square" lIns="0" rIns="0" tIns="18288" bIns="18288">
-            <a:spAutoFit/>
-          </a:bodyPr>
-          <a:lstStyle/>
-          <a:p>
-            <a:pPr algn="ctr"/>
-            <a:r>
-              <a:rPr sz="1400" b="0" i="0">
-                <a:latin typeface="Segoe UI Emoji"/>
-              </a:rPr>
-              <a:t>🆕</a:t>
-            </a:r>
-          </a:p>
-        </p:txBody>
-      </p:sp>
-      <p:sp>
-        <p:nvSpPr>
-          <p:cNvPr id="7" name="TextBox 6"/>
-          <p:cNvSpPr txBox="1"/>
-          <p:nvPr/>
-        </p:nvSpPr>
-        <p:spPr>
-          <a:xfrm>
-            <a:off x="1234440" y="1097280"/>
-            <a:ext cx="3154680" cy="384048"/>
-          </a:xfrm>
-          <a:prstGeom prst="rect">
-            <a:avLst/>
-          </a:prstGeom>
-          <a:noFill/>
-        </p:spPr>
-        <p:txBody>
-          <a:bodyPr wrap="square" lIns="0" rIns="0" tIns="18288" bIns="18288">
-            <a:spAutoFit/>
-          </a:bodyPr>
-          <a:lstStyle/>
-          <a:p>
-            <a:pPr algn="l"/>
-            <a:r>
-              <a:rPr sz="1350" b="1" i="0">
-                <a:solidFill>
-                  <a:srgbClr val="FFFFFF"/>
-                </a:solidFill>
-                <a:latin typeface="Calibri"/>
-              </a:rPr>
-              <a:t>Asset Model Field</a:t>
-            </a:r>
-          </a:p>
-        </p:txBody>
-      </p:sp>
-      <p:sp>
-        <p:nvSpPr>
-          <p:cNvPr id="8" name="TextBox 7"/>
-          <p:cNvSpPr txBox="1"/>
-          <p:nvPr/>
-        </p:nvSpPr>
-        <p:spPr>
-          <a:xfrm>
-            <a:off x="1234440" y="1508760"/>
-            <a:ext cx="3154680" cy="530352"/>
-          </a:xfrm>
-          <a:prstGeom prst="rect">
-            <a:avLst/>
-          </a:prstGeom>
-          <a:noFill/>
-        </p:spPr>
-        <p:txBody>
-          <a:bodyPr wrap="square" lIns="0" rIns="0" tIns="18288" bIns="18288">
-            <a:spAutoFit/>
-          </a:bodyPr>
-          <a:lstStyle/>
-          <a:p>
-            <a:pPr algn="l"/>
-            <a:r>
-              <a:rPr sz="1200" b="0" i="0">
-                <a:solidFill>
-                  <a:srgbClr val="A8C8E8"/>
-                </a:solidFill>
-                <a:latin typeface="Calibri"/>
-              </a:rPr>
-              <a:t>Stored, displayed, exported</a:t>
-            </a:r>
-          </a:p>
-        </p:txBody>
-      </p:sp>
-      <p:sp>
-        <p:nvSpPr>
-          <p:cNvPr id="9" name="Rounded Rectangle 8"/>
-          <p:cNvSpPr/>
-          <p:nvPr/>
-        </p:nvSpPr>
-        <p:spPr>
-          <a:xfrm>
-            <a:off x="4846320" y="1005840"/>
-            <a:ext cx="4023360" cy="1143000"/>
-          </a:xfrm>
-          <a:prstGeom prst="roundRect">
-            <a:avLst/>
-          </a:prstGeom>
-          <a:solidFill>
-            <a:srgbClr val="173455"/>
-          </a:solidFill>
-          <a:ln>
-            <a:noFill/>
-          </a:ln>
-        </p:spPr>
-        <p:style>
-          <a:lnRef idx="1">
-            <a:schemeClr val="accent1"/>
-          </a:lnRef>
-          <a:fillRef idx="3">
-            <a:schemeClr val="accent1"/>
-          </a:fillRef>
-          <a:effectRef idx="2">
-            <a:schemeClr val="accent1"/>
-          </a:effectRef>
-          <a:fontRef idx="minor">
-            <a:schemeClr val="lt1"/>
-          </a:fontRef>
-        </p:style>
-        <p:txBody>
-          <a:bodyPr rtlCol="0" anchor="ctr"/>
-          <a:lstStyle/>
-          <a:p>
-            <a:pPr algn="ctr"/>
-          </a:p>
-        </p:txBody>
-      </p:sp>
-      <p:sp>
-        <p:nvSpPr>
-          <p:cNvPr id="10" name="Oval 9"/>
-          <p:cNvSpPr/>
-          <p:nvPr/>
-        </p:nvSpPr>
-        <p:spPr>
-          <a:xfrm>
-            <a:off x="5010912" y="1353312"/>
-            <a:ext cx="438912" cy="438912"/>
-          </a:xfrm>
-          <a:prstGeom prst="ellipse">
-            <a:avLst/>
-          </a:prstGeom>
-          <a:solidFill>
-            <a:srgbClr val="0078D4"/>
-          </a:solidFill>
-          <a:ln>
-            <a:noFill/>
-          </a:ln>
-        </p:spPr>
-        <p:style>
-          <a:lnRef idx="1">
-            <a:schemeClr val="accent1"/>
-          </a:lnRef>
-          <a:fillRef idx="3">
-            <a:schemeClr val="accent1"/>
-          </a:fillRef>
-          <a:effectRef idx="2">
-            <a:schemeClr val="accent1"/>
-          </a:effectRef>
-          <a:fontRef idx="minor">
-            <a:schemeClr val="lt1"/>
-          </a:fontRef>
-        </p:style>
-        <p:txBody>
-          <a:bodyPr rtlCol="0" anchor="ctr"/>
-          <a:lstStyle/>
-          <a:p>
-            <a:pPr algn="ctr"/>
-          </a:p>
-        </p:txBody>
-      </p:sp>
-      <p:sp>
-        <p:nvSpPr>
-          <p:cNvPr id="11" name="TextBox 10"/>
-          <p:cNvSpPr txBox="1"/>
-          <p:nvPr/>
-        </p:nvSpPr>
-        <p:spPr>
-          <a:xfrm>
-            <a:off x="5010912" y="1344168"/>
-            <a:ext cx="438912" cy="438912"/>
-          </a:xfrm>
-          <a:prstGeom prst="rect">
-            <a:avLst/>
-          </a:prstGeom>
-          <a:noFill/>
-        </p:spPr>
-        <p:txBody>
-          <a:bodyPr wrap="square" lIns="0" rIns="0" tIns="18288" bIns="18288">
-            <a:spAutoFit/>
-          </a:bodyPr>
-          <a:lstStyle/>
-          <a:p>
-            <a:pPr algn="ctr"/>
-            <a:r>
-              <a:rPr sz="1400" b="0" i="0">
-                <a:latin typeface="Segoe UI Emoji"/>
-              </a:rPr>
-              <a:t>🛡️</a:t>
-            </a:r>
-          </a:p>
-        </p:txBody>
-      </p:sp>
-      <p:sp>
-        <p:nvSpPr>
-          <p:cNvPr id="12" name="TextBox 11"/>
-          <p:cNvSpPr txBox="1"/>
-          <p:nvPr/>
-        </p:nvSpPr>
-        <p:spPr>
-          <a:xfrm>
-            <a:off x="5577840" y="1097280"/>
-            <a:ext cx="3154680" cy="384048"/>
-          </a:xfrm>
-          <a:prstGeom prst="rect">
-            <a:avLst/>
-          </a:prstGeom>
-          <a:noFill/>
-        </p:spPr>
-        <p:txBody>
-          <a:bodyPr wrap="square" lIns="0" rIns="0" tIns="18288" bIns="18288">
-            <a:spAutoFit/>
-          </a:bodyPr>
-          <a:lstStyle/>
-          <a:p>
-            <a:pPr algn="l"/>
-            <a:r>
-              <a:rPr sz="1350" b="1" i="0">
-                <a:solidFill>
-                  <a:srgbClr val="FFFFFF"/>
-                </a:solidFill>
-                <a:latin typeface="Calibri"/>
-              </a:rPr>
-              <a:t>Duplicate Guard</a:t>
-            </a:r>
-          </a:p>
-        </p:txBody>
-      </p:sp>
-      <p:sp>
-        <p:nvSpPr>
-          <p:cNvPr id="13" name="TextBox 12"/>
-          <p:cNvSpPr txBox="1"/>
-          <p:nvPr/>
-        </p:nvSpPr>
-        <p:spPr>
-          <a:xfrm>
-            <a:off x="5577840" y="1508760"/>
-            <a:ext cx="3154680" cy="530352"/>
-          </a:xfrm>
-          <a:prstGeom prst="rect">
-            <a:avLst/>
-          </a:prstGeom>
-          <a:noFill/>
-        </p:spPr>
-        <p:txBody>
-          <a:bodyPr wrap="square" lIns="0" rIns="0" tIns="18288" bIns="18288">
-            <a:spAutoFit/>
-          </a:bodyPr>
-          <a:lstStyle/>
-          <a:p>
-            <a:pPr algn="l"/>
-            <a:r>
-              <a:rPr sz="1200" b="0" i="0">
-                <a:solidFill>
-                  <a:srgbClr val="A8C8E8"/>
-                </a:solidFill>
-                <a:latin typeface="Calibri"/>
-              </a:rPr>
-              <a:t>409 blocks re-submission</a:t>
-            </a:r>
-          </a:p>
-        </p:txBody>
-      </p:sp>
-      <p:sp>
-        <p:nvSpPr>
-          <p:cNvPr id="14" name="Rounded Rectangle 13"/>
-          <p:cNvSpPr/>
-          <p:nvPr/>
-        </p:nvSpPr>
-        <p:spPr>
-          <a:xfrm>
-            <a:off x="502920" y="2304288"/>
-            <a:ext cx="4023360" cy="1143000"/>
-          </a:xfrm>
-          <a:prstGeom prst="roundRect">
-            <a:avLst/>
-          </a:prstGeom>
-          <a:solidFill>
-            <a:srgbClr val="173455"/>
-          </a:solidFill>
-          <a:ln>
-            <a:noFill/>
-          </a:ln>
-        </p:spPr>
-        <p:style>
-          <a:lnRef idx="1">
-            <a:schemeClr val="accent1"/>
-          </a:lnRef>
-          <a:fillRef idx="3">
-            <a:schemeClr val="accent1"/>
-          </a:fillRef>
-          <a:effectRef idx="2">
-            <a:schemeClr val="accent1"/>
-          </a:effectRef>
-          <a:fontRef idx="minor">
-            <a:schemeClr val="lt1"/>
-          </a:fontRef>
-        </p:style>
-        <p:txBody>
-          <a:bodyPr rtlCol="0" anchor="ctr"/>
-          <a:lstStyle/>
-          <a:p>
-            <a:pPr algn="ctr"/>
-          </a:p>
-        </p:txBody>
-      </p:sp>
-      <p:sp>
-        <p:nvSpPr>
-          <p:cNvPr id="15" name="Oval 14"/>
-          <p:cNvSpPr/>
-          <p:nvPr/>
-        </p:nvSpPr>
-        <p:spPr>
-          <a:xfrm>
-            <a:off x="667512" y="2651760"/>
-            <a:ext cx="438912" cy="438912"/>
-          </a:xfrm>
-          <a:prstGeom prst="ellipse">
-            <a:avLst/>
-          </a:prstGeom>
-          <a:solidFill>
-            <a:srgbClr val="0078D4"/>
-          </a:solidFill>
-          <a:ln>
-            <a:noFill/>
-          </a:ln>
-        </p:spPr>
-        <p:style>
-          <a:lnRef idx="1">
-            <a:schemeClr val="accent1"/>
-          </a:lnRef>
-          <a:fillRef idx="3">
-            <a:schemeClr val="accent1"/>
-          </a:fillRef>
-          <a:effectRef idx="2">
-            <a:schemeClr val="accent1"/>
-          </a:effectRef>
-          <a:fontRef idx="minor">
-            <a:schemeClr val="lt1"/>
-          </a:fontRef>
-        </p:style>
-        <p:txBody>
-          <a:bodyPr rtlCol="0" anchor="ctr"/>
-          <a:lstStyle/>
-          <a:p>
-            <a:pPr algn="ctr"/>
-          </a:p>
-        </p:txBody>
-      </p:sp>
-      <p:sp>
-        <p:nvSpPr>
-          <p:cNvPr id="16" name="TextBox 15"/>
-          <p:cNvSpPr txBox="1"/>
-          <p:nvPr/>
-        </p:nvSpPr>
-        <p:spPr>
-          <a:xfrm>
-            <a:off x="667512" y="2642616"/>
-            <a:ext cx="438912" cy="438912"/>
-          </a:xfrm>
-          <a:prstGeom prst="rect">
-            <a:avLst/>
-          </a:prstGeom>
-          <a:noFill/>
-        </p:spPr>
-        <p:txBody>
-          <a:bodyPr wrap="square" lIns="0" rIns="0" tIns="18288" bIns="18288">
-            <a:spAutoFit/>
-          </a:bodyPr>
-          <a:lstStyle/>
-          <a:p>
-            <a:pPr algn="ctr"/>
-            <a:r>
-              <a:rPr sz="1400" b="0" i="0">
-                <a:latin typeface="Segoe UI Emoji"/>
-              </a:rPr>
-              <a:t>📊</a:t>
-            </a:r>
-          </a:p>
-        </p:txBody>
-      </p:sp>
-      <p:sp>
-        <p:nvSpPr>
-          <p:cNvPr id="17" name="TextBox 16"/>
-          <p:cNvSpPr txBox="1"/>
-          <p:nvPr/>
-        </p:nvSpPr>
-        <p:spPr>
-          <a:xfrm>
-            <a:off x="1234440" y="2395728"/>
-            <a:ext cx="3154680" cy="384048"/>
-          </a:xfrm>
-          <a:prstGeom prst="rect">
-            <a:avLst/>
-          </a:prstGeom>
-          <a:noFill/>
-        </p:spPr>
-        <p:txBody>
-          <a:bodyPr wrap="square" lIns="0" rIns="0" tIns="18288" bIns="18288">
-            <a:spAutoFit/>
-          </a:bodyPr>
-          <a:lstStyle/>
-          <a:p>
-            <a:pPr algn="l"/>
-            <a:r>
-              <a:rPr sz="1350" b="1" i="0">
-                <a:solidFill>
-                  <a:srgbClr val="FFFFFF"/>
-                </a:solidFill>
-                <a:latin typeface="Calibri"/>
-              </a:rPr>
-              <a:t>Better Export</a:t>
-            </a:r>
-          </a:p>
-        </p:txBody>
-      </p:sp>
-      <p:sp>
-        <p:nvSpPr>
-          <p:cNvPr id="18" name="TextBox 17"/>
-          <p:cNvSpPr txBox="1"/>
-          <p:nvPr/>
-        </p:nvSpPr>
-        <p:spPr>
-          <a:xfrm>
-            <a:off x="1234440" y="2807208"/>
-            <a:ext cx="3154680" cy="530352"/>
-          </a:xfrm>
-          <a:prstGeom prst="rect">
-            <a:avLst/>
-          </a:prstGeom>
-          <a:noFill/>
-        </p:spPr>
-        <p:txBody>
-          <a:bodyPr wrap="square" lIns="0" rIns="0" tIns="18288" bIns="18288">
-            <a:spAutoFit/>
-          </a:bodyPr>
-          <a:lstStyle/>
-          <a:p>
-            <a:pPr algn="l"/>
-            <a:r>
-              <a:rPr sz="1200" b="0" i="0">
-                <a:solidFill>
-                  <a:srgbClr val="A8C8E8"/>
-                </a:solidFill>
-                <a:latin typeface="Calibri"/>
-              </a:rPr>
-              <a:t>3 charts in Summary sheet</a:t>
-            </a:r>
-          </a:p>
-        </p:txBody>
-      </p:sp>
-      <p:sp>
-        <p:nvSpPr>
-          <p:cNvPr id="19" name="Rounded Rectangle 18"/>
-          <p:cNvSpPr/>
-          <p:nvPr/>
-        </p:nvSpPr>
-        <p:spPr>
-          <a:xfrm>
-            <a:off x="4846320" y="2304288"/>
-            <a:ext cx="4023360" cy="1143000"/>
-          </a:xfrm>
-          <a:prstGeom prst="roundRect">
-            <a:avLst/>
-          </a:prstGeom>
-          <a:solidFill>
-            <a:srgbClr val="173455"/>
-          </a:solidFill>
-          <a:ln>
-            <a:noFill/>
-          </a:ln>
-        </p:spPr>
-        <p:style>
-          <a:lnRef idx="1">
-            <a:schemeClr val="accent1"/>
-          </a:lnRef>
-          <a:fillRef idx="3">
-            <a:schemeClr val="accent1"/>
-          </a:fillRef>
-          <a:effectRef idx="2">
-            <a:schemeClr val="accent1"/>
-          </a:effectRef>
-          <a:fontRef idx="minor">
-            <a:schemeClr val="lt1"/>
-          </a:fontRef>
-        </p:style>
-        <p:txBody>
-          <a:bodyPr rtlCol="0" anchor="ctr"/>
-          <a:lstStyle/>
-          <a:p>
-            <a:pPr algn="ctr"/>
-          </a:p>
-        </p:txBody>
-      </p:sp>
-      <p:sp>
-        <p:nvSpPr>
-          <p:cNvPr id="20" name="Oval 19"/>
-          <p:cNvSpPr/>
-          <p:nvPr/>
-        </p:nvSpPr>
-        <p:spPr>
-          <a:xfrm>
-            <a:off x="5010912" y="2651760"/>
-            <a:ext cx="438912" cy="438912"/>
-          </a:xfrm>
-          <a:prstGeom prst="ellipse">
-            <a:avLst/>
-          </a:prstGeom>
-          <a:solidFill>
-            <a:srgbClr val="0078D4"/>
-          </a:solidFill>
-          <a:ln>
-            <a:noFill/>
-          </a:ln>
-        </p:spPr>
-        <p:style>
-          <a:lnRef idx="1">
-            <a:schemeClr val="accent1"/>
-          </a:lnRef>
-          <a:fillRef idx="3">
-            <a:schemeClr val="accent1"/>
-          </a:fillRef>
-          <a:effectRef idx="2">
-            <a:schemeClr val="accent1"/>
-          </a:effectRef>
-          <a:fontRef idx="minor">
-            <a:schemeClr val="lt1"/>
-          </a:fontRef>
-        </p:style>
-        <p:txBody>
-          <a:bodyPr rtlCol="0" anchor="ctr"/>
-          <a:lstStyle/>
-          <a:p>
-            <a:pPr algn="ctr"/>
-          </a:p>
-        </p:txBody>
-      </p:sp>
-      <p:sp>
-        <p:nvSpPr>
-          <p:cNvPr id="21" name="TextBox 20"/>
-          <p:cNvSpPr txBox="1"/>
-          <p:nvPr/>
-        </p:nvSpPr>
-        <p:spPr>
-          <a:xfrm>
-            <a:off x="5010912" y="2642616"/>
-            <a:ext cx="438912" cy="438912"/>
-          </a:xfrm>
-          <a:prstGeom prst="rect">
-            <a:avLst/>
-          </a:prstGeom>
-          <a:noFill/>
-        </p:spPr>
-        <p:txBody>
-          <a:bodyPr wrap="square" lIns="0" rIns="0" tIns="18288" bIns="18288">
-            <a:spAutoFit/>
-          </a:bodyPr>
-          <a:lstStyle/>
-          <a:p>
-            <a:pPr algn="ctr"/>
-            <a:r>
-              <a:rPr sz="1400" b="0" i="0">
-                <a:latin typeface="Segoe UI Emoji"/>
-              </a:rPr>
-              <a:t>⚙️</a:t>
-            </a:r>
-          </a:p>
-        </p:txBody>
-      </p:sp>
-      <p:sp>
-        <p:nvSpPr>
-          <p:cNvPr id="22" name="TextBox 21"/>
-          <p:cNvSpPr txBox="1"/>
-          <p:nvPr/>
-        </p:nvSpPr>
-        <p:spPr>
-          <a:xfrm>
-            <a:off x="5577840" y="2395728"/>
-            <a:ext cx="3154680" cy="384048"/>
-          </a:xfrm>
-          <a:prstGeom prst="rect">
-            <a:avLst/>
-          </a:prstGeom>
-          <a:noFill/>
-        </p:spPr>
-        <p:txBody>
-          <a:bodyPr wrap="square" lIns="0" rIns="0" tIns="18288" bIns="18288">
-            <a:spAutoFit/>
-          </a:bodyPr>
-          <a:lstStyle/>
-          <a:p>
-            <a:pPr algn="l"/>
-            <a:r>
-              <a:rPr sz="1350" b="1" i="0">
-                <a:solidFill>
-                  <a:srgbClr val="FFFFFF"/>
-                </a:solidFill>
-                <a:latin typeface="Calibri"/>
-              </a:rPr>
-              <a:t>Port Config</a:t>
-            </a:r>
-          </a:p>
-        </p:txBody>
-      </p:sp>
-      <p:sp>
-        <p:nvSpPr>
-          <p:cNvPr id="23" name="TextBox 22"/>
-          <p:cNvSpPr txBox="1"/>
-          <p:nvPr/>
-        </p:nvSpPr>
-        <p:spPr>
-          <a:xfrm>
-            <a:off x="5577840" y="2807208"/>
-            <a:ext cx="3154680" cy="530352"/>
-          </a:xfrm>
-          <a:prstGeom prst="rect">
-            <a:avLst/>
-          </a:prstGeom>
-          <a:noFill/>
-        </p:spPr>
-        <p:txBody>
-          <a:bodyPr wrap="square" lIns="0" rIns="0" tIns="18288" bIns="18288">
-            <a:spAutoFit/>
-          </a:bodyPr>
-          <a:lstStyle/>
-          <a:p>
-            <a:pPr algn="l"/>
-            <a:r>
-              <a:rPr sz="1200" b="0" i="0">
-                <a:solidFill>
-                  <a:srgbClr val="A8C8E8"/>
-                </a:solidFill>
-                <a:latin typeface="Calibri"/>
-              </a:rPr>
-              <a:t>Change host/port via GUI</a:t>
-            </a:r>
-          </a:p>
-        </p:txBody>
-      </p:sp>
-      <p:sp>
-        <p:nvSpPr>
-          <p:cNvPr id="24" name="Rounded Rectangle 23"/>
-          <p:cNvSpPr/>
-          <p:nvPr/>
-        </p:nvSpPr>
-        <p:spPr>
-          <a:xfrm>
-            <a:off x="502920" y="3602736"/>
-            <a:ext cx="4023360" cy="1143000"/>
-          </a:xfrm>
-          <a:prstGeom prst="roundRect">
-            <a:avLst/>
-          </a:prstGeom>
-          <a:solidFill>
-            <a:srgbClr val="173455"/>
-          </a:solidFill>
-          <a:ln>
-            <a:noFill/>
-          </a:ln>
-        </p:spPr>
-        <p:style>
-          <a:lnRef idx="1">
-            <a:schemeClr val="accent1"/>
-          </a:lnRef>
-          <a:fillRef idx="3">
-            <a:schemeClr val="accent1"/>
-          </a:fillRef>
-          <a:effectRef idx="2">
-            <a:schemeClr val="accent1"/>
-          </a:effectRef>
-          <a:fontRef idx="minor">
-            <a:schemeClr val="lt1"/>
-          </a:fontRef>
-        </p:style>
-        <p:txBody>
-          <a:bodyPr rtlCol="0" anchor="ctr"/>
-          <a:lstStyle/>
-          <a:p>
-            <a:pPr algn="ctr"/>
-          </a:p>
-        </p:txBody>
-      </p:sp>
-      <p:sp>
-        <p:nvSpPr>
-          <p:cNvPr id="25" name="Oval 24"/>
-          <p:cNvSpPr/>
-          <p:nvPr/>
-        </p:nvSpPr>
-        <p:spPr>
-          <a:xfrm>
-            <a:off x="667512" y="3950207"/>
-            <a:ext cx="438912" cy="438912"/>
-          </a:xfrm>
-          <a:prstGeom prst="ellipse">
-            <a:avLst/>
-          </a:prstGeom>
-          <a:solidFill>
-            <a:srgbClr val="0078D4"/>
-          </a:solidFill>
-          <a:ln>
-            <a:noFill/>
-          </a:ln>
-        </p:spPr>
-        <p:style>
-          <a:lnRef idx="1">
-            <a:schemeClr val="accent1"/>
-          </a:lnRef>
-          <a:fillRef idx="3">
-            <a:schemeClr val="accent1"/>
-          </a:fillRef>
-          <a:effectRef idx="2">
-            <a:schemeClr val="accent1"/>
-          </a:effectRef>
-          <a:fontRef idx="minor">
-            <a:schemeClr val="lt1"/>
-          </a:fontRef>
-        </p:style>
-        <p:txBody>
-          <a:bodyPr rtlCol="0" anchor="ctr"/>
-          <a:lstStyle/>
-          <a:p>
-            <a:pPr algn="ctr"/>
-          </a:p>
-        </p:txBody>
-      </p:sp>
-      <p:sp>
-        <p:nvSpPr>
-          <p:cNvPr id="26" name="TextBox 25"/>
-          <p:cNvSpPr txBox="1"/>
-          <p:nvPr/>
-        </p:nvSpPr>
-        <p:spPr>
-          <a:xfrm>
-            <a:off x="667512" y="3941063"/>
-            <a:ext cx="438912" cy="438912"/>
-          </a:xfrm>
-          <a:prstGeom prst="rect">
-            <a:avLst/>
-          </a:prstGeom>
-          <a:noFill/>
-        </p:spPr>
-        <p:txBody>
-          <a:bodyPr wrap="square" lIns="0" rIns="0" tIns="18288" bIns="18288">
-            <a:spAutoFit/>
-          </a:bodyPr>
-          <a:lstStyle/>
-          <a:p>
-            <a:pPr algn="ctr"/>
-            <a:r>
-              <a:rPr sz="1400" b="0" i="0">
-                <a:latin typeface="Segoe UI Emoji"/>
-              </a:rPr>
-              <a:t>📱</a:t>
-            </a:r>
-          </a:p>
-        </p:txBody>
-      </p:sp>
-      <p:sp>
-        <p:nvSpPr>
-          <p:cNvPr id="27" name="TextBox 26"/>
-          <p:cNvSpPr txBox="1"/>
-          <p:nvPr/>
-        </p:nvSpPr>
-        <p:spPr>
-          <a:xfrm>
-            <a:off x="1234440" y="3694176"/>
-            <a:ext cx="3154680" cy="384048"/>
-          </a:xfrm>
-          <a:prstGeom prst="rect">
-            <a:avLst/>
-          </a:prstGeom>
-          <a:noFill/>
-        </p:spPr>
-        <p:txBody>
-          <a:bodyPr wrap="square" lIns="0" rIns="0" tIns="18288" bIns="18288">
-            <a:spAutoFit/>
-          </a:bodyPr>
-          <a:lstStyle/>
-          <a:p>
-            <a:pPr algn="l"/>
-            <a:r>
-              <a:rPr sz="1350" b="1" i="0">
-                <a:solidFill>
-                  <a:srgbClr val="FFFFFF"/>
-                </a:solidFill>
-                <a:latin typeface="Calibri"/>
-              </a:rPr>
-              <a:t>4 New Types</a:t>
-            </a:r>
-          </a:p>
-        </p:txBody>
-      </p:sp>
-      <p:sp>
-        <p:nvSpPr>
-          <p:cNvPr id="28" name="TextBox 27"/>
-          <p:cNvSpPr txBox="1"/>
-          <p:nvPr/>
-        </p:nvSpPr>
-        <p:spPr>
-          <a:xfrm>
-            <a:off x="1234440" y="4105656"/>
-            <a:ext cx="3154680" cy="530352"/>
-          </a:xfrm>
-          <a:prstGeom prst="rect">
-            <a:avLst/>
-          </a:prstGeom>
-          <a:noFill/>
-        </p:spPr>
-        <p:txBody>
-          <a:bodyPr wrap="square" lIns="0" rIns="0" tIns="18288" bIns="18288">
-            <a:spAutoFit/>
-          </a:bodyPr>
-          <a:lstStyle/>
-          <a:p>
-            <a:pPr algn="l"/>
-            <a:r>
-              <a:rPr sz="1200" b="0" i="0">
-                <a:solidFill>
-                  <a:srgbClr val="A8C8E8"/>
-                </a:solidFill>
-                <a:latin typeface="Calibri"/>
-              </a:rPr>
-              <a:t>Cisco Phone, Printer, Scanner, Switch</a:t>
-            </a:r>
-          </a:p>
-        </p:txBody>
-      </p:sp>
-      <p:sp>
-        <p:nvSpPr>
-          <p:cNvPr id="29" name="Rounded Rectangle 28"/>
-          <p:cNvSpPr/>
-          <p:nvPr/>
-        </p:nvSpPr>
-        <p:spPr>
-          <a:xfrm>
-            <a:off x="4846320" y="3602736"/>
-            <a:ext cx="4023360" cy="1143000"/>
-          </a:xfrm>
-          <a:prstGeom prst="roundRect">
-            <a:avLst/>
-          </a:prstGeom>
-          <a:solidFill>
-            <a:srgbClr val="173455"/>
-          </a:solidFill>
-          <a:ln>
-            <a:noFill/>
-          </a:ln>
-        </p:spPr>
-        <p:style>
-          <a:lnRef idx="1">
-            <a:schemeClr val="accent1"/>
-          </a:lnRef>
-          <a:fillRef idx="3">
-            <a:schemeClr val="accent1"/>
-          </a:fillRef>
-          <a:effectRef idx="2">
-            <a:schemeClr val="accent1"/>
-          </a:effectRef>
-          <a:fontRef idx="minor">
-            <a:schemeClr val="lt1"/>
-          </a:fontRef>
-        </p:style>
-        <p:txBody>
-          <a:bodyPr rtlCol="0" anchor="ctr"/>
-          <a:lstStyle/>
-          <a:p>
-            <a:pPr algn="ctr"/>
-          </a:p>
-        </p:txBody>
-      </p:sp>
-      <p:sp>
-        <p:nvSpPr>
-          <p:cNvPr id="30" name="Oval 29"/>
-          <p:cNvSpPr/>
-          <p:nvPr/>
-        </p:nvSpPr>
-        <p:spPr>
-          <a:xfrm>
-            <a:off x="5010912" y="3950207"/>
-            <a:ext cx="438912" cy="438912"/>
-          </a:xfrm>
-          <a:prstGeom prst="ellipse">
-            <a:avLst/>
-          </a:prstGeom>
-          <a:solidFill>
-            <a:srgbClr val="0078D4"/>
-          </a:solidFill>
-          <a:ln>
-            <a:noFill/>
-          </a:ln>
-        </p:spPr>
-        <p:style>
-          <a:lnRef idx="1">
-            <a:schemeClr val="accent1"/>
-          </a:lnRef>
-          <a:fillRef idx="3">
-            <a:schemeClr val="accent1"/>
-          </a:fillRef>
-          <a:effectRef idx="2">
-            <a:schemeClr val="accent1"/>
-          </a:effectRef>
-          <a:fontRef idx="minor">
-            <a:schemeClr val="lt1"/>
-          </a:fontRef>
-        </p:style>
-        <p:txBody>
-          <a:bodyPr rtlCol="0" anchor="ctr"/>
-          <a:lstStyle/>
-          <a:p>
-            <a:pPr algn="ctr"/>
-          </a:p>
-        </p:txBody>
-      </p:sp>
-      <p:sp>
-        <p:nvSpPr>
-          <p:cNvPr id="31" name="TextBox 30"/>
-          <p:cNvSpPr txBox="1"/>
-          <p:nvPr/>
-        </p:nvSpPr>
-        <p:spPr>
-          <a:xfrm>
-            <a:off x="5010912" y="3941063"/>
-            <a:ext cx="438912" cy="438912"/>
-          </a:xfrm>
-          <a:prstGeom prst="rect">
-            <a:avLst/>
-          </a:prstGeom>
-          <a:noFill/>
-        </p:spPr>
-        <p:txBody>
-          <a:bodyPr wrap="square" lIns="0" rIns="0" tIns="18288" bIns="18288">
-            <a:spAutoFit/>
-          </a:bodyPr>
-          <a:lstStyle/>
-          <a:p>
-            <a:pPr algn="ctr"/>
-            <a:r>
-              <a:rPr sz="1400" b="0" i="0">
-                <a:latin typeface="Segoe UI Emoji"/>
-              </a:rPr>
-              <a:t>⚡</a:t>
-            </a:r>
-          </a:p>
-        </p:txBody>
-      </p:sp>
-      <p:sp>
-        <p:nvSpPr>
-          <p:cNvPr id="32" name="TextBox 31"/>
-          <p:cNvSpPr txBox="1"/>
-          <p:nvPr/>
-        </p:nvSpPr>
-        <p:spPr>
-          <a:xfrm>
-            <a:off x="5577840" y="3694176"/>
-            <a:ext cx="3154680" cy="384048"/>
-          </a:xfrm>
-          <a:prstGeom prst="rect">
-            <a:avLst/>
-          </a:prstGeom>
-          <a:noFill/>
-        </p:spPr>
-        <p:txBody>
-          <a:bodyPr wrap="square" lIns="0" rIns="0" tIns="18288" bIns="18288">
-            <a:spAutoFit/>
-          </a:bodyPr>
-          <a:lstStyle/>
-          <a:p>
-            <a:pPr algn="l"/>
-            <a:r>
-              <a:rPr sz="1350" b="1" i="0">
-                <a:solidFill>
-                  <a:srgbClr val="FFFFFF"/>
-                </a:solidFill>
-                <a:latin typeface="Calibri"/>
-              </a:rPr>
-              <a:t>Windows Service</a:t>
-            </a:r>
-          </a:p>
-        </p:txBody>
-      </p:sp>
-      <p:sp>
-        <p:nvSpPr>
-          <p:cNvPr id="33" name="TextBox 32"/>
-          <p:cNvSpPr txBox="1"/>
-          <p:nvPr/>
-        </p:nvSpPr>
-        <p:spPr>
-          <a:xfrm>
-            <a:off x="5577840" y="4105656"/>
-            <a:ext cx="3154680" cy="530352"/>
-          </a:xfrm>
-          <a:prstGeom prst="rect">
-            <a:avLst/>
-          </a:prstGeom>
-          <a:noFill/>
-        </p:spPr>
-        <p:txBody>
-          <a:bodyPr wrap="square" lIns="0" rIns="0" tIns="18288" bIns="18288">
-            <a:spAutoFit/>
-          </a:bodyPr>
-          <a:lstStyle/>
-          <a:p>
-            <a:pPr algn="l"/>
-            <a:r>
-              <a:rPr sz="1200" b="0" i="0">
-                <a:solidFill>
-                  <a:srgbClr val="A8C8E8"/>
-                </a:solidFill>
-                <a:latin typeface="Calibri"/>
-              </a:rPr>
-              <a:t>Starts at boot. No login needed.</a:t>
-            </a:r>
-          </a:p>
-        </p:txBody>
-      </p:sp>
-      <p:sp>
-        <p:nvSpPr>
-          <p:cNvPr id="24" name="Rounded Rectangle 23"/>
-          <p:cNvSpPr/>
-          <p:nvPr/>
-        </p:nvSpPr>
-        <p:spPr>
-          <a:xfrm>
-            <a:off x="502920" y="4901184"/>
-            <a:ext cx="4023360" cy="1143000"/>
-          </a:xfrm>
-          <a:prstGeom prst="roundRect">
-            <a:avLst/>
-          </a:prstGeom>
-          <a:solidFill>
-            <a:srgbClr val="173455"/>
-          </a:solidFill>
-          <a:ln>
-            <a:noFill/>
-          </a:ln>
-        </p:spPr>
-        <p:style>
-          <a:lnRef idx="1">
-            <a:schemeClr val="accent1"/>
-          </a:lnRef>
-          <a:fillRef idx="3">
-            <a:schemeClr val="accent1"/>
-          </a:fillRef>
-          <a:effectRef idx="2">
-            <a:schemeClr val="accent1"/>
-          </a:effectRef>
-          <a:fontRef idx="minor">
-            <a:schemeClr val="lt1"/>
-          </a:fontRef>
-        </p:style>
-        <p:txBody>
-          <a:bodyPr rtlCol="0" anchor="ctr"/>
-          <a:lstStyle/>
-          <a:p>
-            <a:pPr algn="ctr"/>
-          </a:p>
-        </p:txBody>
-      </p:sp>
-      <p:sp>
-        <p:nvSpPr>
-          <p:cNvPr id="25" name="Oval 24"/>
-          <p:cNvSpPr/>
-          <p:nvPr/>
-        </p:nvSpPr>
-        <p:spPr>
-          <a:xfrm>
-            <a:off x="667512" y="5248655"/>
-            <a:ext cx="438912" cy="438912"/>
-          </a:xfrm>
-          <a:prstGeom prst="ellipse">
-            <a:avLst/>
-          </a:prstGeom>
-          <a:solidFill>
-            <a:srgbClr val="0078D4"/>
-          </a:solidFill>
-          <a:ln>
-            <a:noFill/>
-          </a:ln>
-        </p:spPr>
-        <p:style>
-          <a:lnRef idx="1">
-            <a:schemeClr val="accent1"/>
-          </a:lnRef>
-          <a:fillRef idx="3">
-            <a:schemeClr val="accent1"/>
-          </a:fillRef>
-          <a:effectRef idx="2">
-            <a:schemeClr val="accent1"/>
-          </a:effectRef>
-          <a:fontRef idx="minor">
-            <a:schemeClr val="lt1"/>
-          </a:fontRef>
-        </p:style>
-        <p:txBody>
-          <a:bodyPr rtlCol="0" anchor="ctr"/>
-          <a:lstStyle/>
-          <a:p>
-            <a:pPr algn="ctr"/>
-          </a:p>
-        </p:txBody>
-      </p:sp>
-      <p:sp>
-        <p:nvSpPr>
-          <p:cNvPr id="26" name="TextBox 25"/>
-          <p:cNvSpPr txBox="1"/>
-          <p:nvPr/>
-        </p:nvSpPr>
-        <p:spPr>
-          <a:xfrm>
-            <a:off x="667512" y="5239511"/>
-            <a:ext cx="438912" cy="438912"/>
-          </a:xfrm>
-          <a:prstGeom prst="rect">
-            <a:avLst/>
-          </a:prstGeom>
-          <a:noFill/>
-        </p:spPr>
-        <p:txBody>
-          <a:bodyPr wrap="square" lIns="0" rIns="0" tIns="18288" bIns="18288">
-            <a:spAutoFit/>
-          </a:bodyPr>
-          <a:lstStyle/>
-          <a:p>
-            <a:pPr algn="ctr"/>
-            <a:r>
-              <a:rPr sz="1400" b="0" i="0">
-                <a:latin typeface="Segoe UI Emoji"/>
-              </a:rPr>
-              <a:t>🔒</a:t>
-            </a:r>
-          </a:p>
-        </p:txBody>
-      </p:sp>
-      <p:sp>
-        <p:nvSpPr>
-          <p:cNvPr id="27" name="TextBox 26"/>
-          <p:cNvSpPr txBox="1"/>
-          <p:nvPr/>
-        </p:nvSpPr>
-        <p:spPr>
-          <a:xfrm>
-            <a:off x="1234440" y="4992624"/>
-            <a:ext cx="3154680" cy="384048"/>
-          </a:xfrm>
-          <a:prstGeom prst="rect">
-            <a:avLst/>
-          </a:prstGeom>
-          <a:noFill/>
-        </p:spPr>
-        <p:txBody>
-          <a:bodyPr wrap="square" lIns="0" rIns="0" tIns="18288" bIns="18288">
-            <a:spAutoFit/>
-          </a:bodyPr>
-          <a:lstStyle/>
-          <a:p>
-            <a:pPr algn="l"/>
-            <a:r>
-              <a:rPr sz="1350" b="1" i="0">
-                <a:solidFill>
-                  <a:srgbClr val="FFFFFF"/>
-                </a:solidFill>
-                <a:latin typeface="Calibri"/>
-              </a:rPr>
-              <a:t>SSL Certificate</a:t>
-            </a:r>
-          </a:p>
-        </p:txBody>
-      </p:sp>
-      <p:sp>
-        <p:nvSpPr>
-          <p:cNvPr id="28" name="TextBox 27"/>
-          <p:cNvSpPr txBox="1"/>
-          <p:nvPr/>
-        </p:nvSpPr>
-        <p:spPr>
-          <a:xfrm>
-            <a:off x="1234440" y="5404104"/>
-            <a:ext cx="3154680" cy="530352"/>
-          </a:xfrm>
-          <a:prstGeom prst="rect">
-            <a:avLst/>
-          </a:prstGeom>
-          <a:noFill/>
-        </p:spPr>
-        <p:txBody>
-          <a:bodyPr wrap="square" lIns="0" rIns="0" tIns="18288" bIns="18288">
-            <a:spAutoFit/>
-          </a:bodyPr>
-          <a:lstStyle/>
-          <a:p>
-            <a:pPr algn="l"/>
-            <a:r>
-              <a:rPr sz="1200" b="0" i="0">
-                <a:solidFill>
-                  <a:srgbClr val="A8C8E8"/>
-                </a:solidFill>
-                <a:latin typeface="Calibri"/>
-              </a:rPr>
-              <a:t>HTTPS encryption on port 8081</a:t>
-            </a:r>
-          </a:p>
-        </p:txBody>
-      </p:sp>
-      <p:sp>
-        <p:nvSpPr>
-          <p:cNvPr id="29" name="Rounded Rectangle 28"/>
-          <p:cNvSpPr/>
-          <p:nvPr/>
-        </p:nvSpPr>
-        <p:spPr>
-          <a:xfrm>
-            <a:off x="4846320" y="4901184"/>
-            <a:ext cx="4023360" cy="1143000"/>
-          </a:xfrm>
-          <a:prstGeom prst="roundRect">
-            <a:avLst/>
-          </a:prstGeom>
-          <a:solidFill>
-            <a:srgbClr val="173455"/>
-          </a:solidFill>
-          <a:ln>
-            <a:noFill/>
-          </a:ln>
-        </p:spPr>
-        <p:style>
-          <a:lnRef idx="1">
-            <a:schemeClr val="accent1"/>
-          </a:lnRef>
-          <a:fillRef idx="3">
-            <a:schemeClr val="accent1"/>
-          </a:fillRef>
-          <a:effectRef idx="2">
-            <a:schemeClr val="accent1"/>
-          </a:effectRef>
-          <a:fontRef idx="minor">
-            <a:schemeClr val="lt1"/>
-          </a:fontRef>
-        </p:style>
-        <p:txBody>
-          <a:bodyPr rtlCol="0" anchor="ctr"/>
-          <a:lstStyle/>
-          <a:p>
-            <a:pPr algn="ctr"/>
-          </a:p>
-        </p:txBody>
-      </p:sp>
-      <p:sp>
-        <p:nvSpPr>
-          <p:cNvPr id="30" name="Oval 29"/>
-          <p:cNvSpPr/>
-          <p:nvPr/>
-        </p:nvSpPr>
-        <p:spPr>
-          <a:xfrm>
-            <a:off x="5010912" y="5248655"/>
-            <a:ext cx="438912" cy="438912"/>
-          </a:xfrm>
-          <a:prstGeom prst="ellipse">
-            <a:avLst/>
-          </a:prstGeom>
-          <a:solidFill>
-            <a:srgbClr val="0078D4"/>
-          </a:solidFill>
-          <a:ln>
-            <a:noFill/>
-          </a:ln>
-        </p:spPr>
-        <p:style>
-          <a:lnRef idx="1">
-            <a:schemeClr val="accent1"/>
-          </a:lnRef>
-          <a:fillRef idx="3">
-            <a:schemeClr val="accent1"/>
-          </a:fillRef>
-          <a:effectRef idx="2">
-            <a:schemeClr val="accent1"/>
-          </a:effectRef>
-          <a:fontRef idx="minor">
-            <a:schemeClr val="lt1"/>
-          </a:fontRef>
-        </p:style>
-        <p:txBody>
-          <a:bodyPr rtlCol="0" anchor="ctr"/>
-          <a:lstStyle/>
-          <a:p>
-            <a:pPr algn="ctr"/>
-          </a:p>
-        </p:txBody>
-      </p:sp>
-      <p:sp>
-        <p:nvSpPr>
-          <p:cNvPr id="31" name="TextBox 30"/>
-          <p:cNvSpPr txBox="1"/>
-          <p:nvPr/>
-        </p:nvSpPr>
-        <p:spPr>
-          <a:xfrm>
-            <a:off x="5010912" y="5239511"/>
-            <a:ext cx="438912" cy="438912"/>
-          </a:xfrm>
-          <a:prstGeom prst="rect">
-            <a:avLst/>
-          </a:prstGeom>
-          <a:noFill/>
-        </p:spPr>
-        <p:txBody>
-          <a:bodyPr wrap="square" lIns="0" rIns="0" tIns="18288" bIns="18288">
-            <a:spAutoFit/>
-          </a:bodyPr>
-          <a:lstStyle/>
-          <a:p>
-            <a:pPr algn="ctr"/>
-            <a:r>
-              <a:rPr sz="1400" b="0" i="0">
-                <a:latin typeface="Segoe UI Emoji"/>
-              </a:rPr>
-              <a:t>🗑</a:t>
-            </a:r>
-          </a:p>
-        </p:txBody>
-      </p:sp>
-      <p:sp>
-        <p:nvSpPr>
-          <p:cNvPr id="32" name="TextBox 31"/>
-          <p:cNvSpPr txBox="1"/>
-          <p:nvPr/>
-        </p:nvSpPr>
-        <p:spPr>
-          <a:xfrm>
-            <a:off x="5577840" y="4992624"/>
-            <a:ext cx="3154680" cy="384048"/>
-          </a:xfrm>
-          <a:prstGeom prst="rect">
-            <a:avLst/>
-          </a:prstGeom>
-          <a:noFill/>
-        </p:spPr>
-        <p:txBody>
-          <a:bodyPr wrap="square" lIns="0" rIns="0" tIns="18288" bIns="18288">
-            <a:spAutoFit/>
-          </a:bodyPr>
-          <a:lstStyle/>
-          <a:p>
-            <a:pPr algn="l"/>
-            <a:r>
-              <a:rPr sz="1350" b="1" i="0">
-                <a:solidFill>
-                  <a:srgbClr val="FFFFFF"/>
-                </a:solidFill>
-                <a:latin typeface="Calibri"/>
-              </a:rPr>
-              <a:t>Clear All Records</a:t>
-            </a:r>
-          </a:p>
-        </p:txBody>
-      </p:sp>
-      <p:sp>
-        <p:nvSpPr>
-          <p:cNvPr id="33" name="TextBox 32"/>
-          <p:cNvSpPr txBox="1"/>
-          <p:nvPr/>
-        </p:nvSpPr>
-        <p:spPr>
-          <a:xfrm>
-            <a:off x="5577840" y="5404104"/>
-            <a:ext cx="3154680" cy="530352"/>
-          </a:xfrm>
-          <a:prstGeom prst="rect">
-            <a:avLst/>
-          </a:prstGeom>
-          <a:noFill/>
-        </p:spPr>
-        <p:txBody>
-          <a:bodyPr wrap="square" lIns="0" rIns="0" tIns="18288" bIns="18288">
-            <a:spAutoFit/>
-          </a:bodyPr>
-          <a:lstStyle/>
-          <a:p>
-            <a:pPr algn="l"/>
-            <a:r>
-              <a:rPr sz="1200" b="0" i="0">
-                <a:solidFill>
-                  <a:srgbClr val="A8C8E8"/>
-                </a:solidFill>
-                <a:latin typeface="Calibri"/>
-              </a:rPr>
-              <a:t>Admin-protected database wipe</a:t>
-            </a:r>
-          </a:p>
-        </p:txBody>
-      </p:sp>
-      <p:sp>
-        <p:nvSpPr>
-          <p:cNvPr id="50" name="Rounded Rectangle 49"/>
-          <p:cNvSpPr/>
-          <p:nvPr/>
-        </p:nvSpPr>
-        <p:spPr>
-          <a:xfrm>
-            <a:off x="502920" y="6130000"/>
-            <a:ext cx="8138160" cy="500000"/>
-          </a:xfrm>
-          <a:prstGeom prst="roundRect">
-            <a:avLst/>
-          </a:prstGeom>
-          <a:solidFill>
-            <a:srgbClr val="173455"/>
-          </a:solidFill>
-          <a:ln>
-            <a:noFill/>
-          </a:ln>
-        </p:spPr>
-        <p:style>
-          <a:lnRef idx="1">
-            <a:schemeClr val="accent1"/>
-          </a:lnRef>
-          <a:fillRef idx="3">
-            <a:schemeClr val="accent1"/>
-          </a:fillRef>
-          <a:effectRef idx="2">
-            <a:schemeClr val="accent1"/>
-          </a:effectRef>
-          <a:fontRef idx="minor">
-            <a:schemeClr val="lt1"/>
-          </a:fontRef>
-        </p:style>
-        <p:txBody>
-          <a:bodyPr rtlCol="0" anchor="ctr"/>
-          <a:lstStyle/>
-          <a:p>
-            <a:pPr algn="ctr"/>
-          </a:p>
-        </p:txBody>
-      </p:sp>
-      <p:sp>
-        <p:nvSpPr>
-          <p:cNvPr id="51" name="Oval 50"/>
-          <p:cNvSpPr/>
-          <p:nvPr/>
-        </p:nvSpPr>
-        <p:spPr>
-          <a:xfrm>
-            <a:off x="667512" y="6312656"/>
-            <a:ext cx="438912" cy="438912"/>
-          </a:xfrm>
-          <a:prstGeom prst="ellipse">
-            <a:avLst/>
-          </a:prstGeom>
-          <a:solidFill>
-            <a:srgbClr val="0078D4"/>
-          </a:solidFill>
-          <a:ln>
-            <a:noFill/>
-          </a:ln>
-        </p:spPr>
-        <p:style>
-          <a:lnRef idx="1">
-            <a:schemeClr val="accent1"/>
-          </a:lnRef>
-          <a:fillRef idx="3">
-            <a:schemeClr val="accent1"/>
-          </a:fillRef>
-          <a:effectRef idx="2">
-            <a:schemeClr val="accent1"/>
-          </a:effectRef>
-          <a:fontRef idx="minor">
-            <a:schemeClr val="lt1"/>
-          </a:fontRef>
-        </p:style>
-        <p:txBody>
-          <a:bodyPr rtlCol="0" anchor="ctr"/>
-          <a:lstStyle/>
-          <a:p>
-            <a:pPr algn="ctr"/>
-          </a:p>
-        </p:txBody>
-      </p:sp>
-      <p:sp>
-        <p:nvSpPr>
-          <p:cNvPr id="52" name="TextBox 51"/>
-          <p:cNvSpPr txBox="1"/>
-          <p:nvPr/>
-        </p:nvSpPr>
-        <p:spPr>
-          <a:xfrm>
-            <a:off x="667512" y="6303512"/>
-            <a:ext cx="438912" cy="438912"/>
-          </a:xfrm>
-          <a:prstGeom prst="rect">
-            <a:avLst/>
-          </a:prstGeom>
-          <a:noFill/>
-        </p:spPr>
-        <p:txBody>
-          <a:bodyPr wrap="square" lIns="0" rIns="0" tIns="18288" bIns="18288">
-            <a:spAutoFit/>
-          </a:bodyPr>
-          <a:lstStyle/>
-          <a:p>
-            <a:pPr algn="ctr"/>
-            <a:r>
-              <a:rPr sz="1400" b="0" i="0">
-                <a:latin typeface="Segoe UI Emoji"/>
-              </a:rPr>
-              <a:t>🖥️</a:t>
-            </a:r>
-          </a:p>
-        </p:txBody>
-      </p:sp>
-      <p:sp>
-        <p:nvSpPr>
-          <p:cNvPr id="53" name="TextBox 52"/>
-          <p:cNvSpPr txBox="1"/>
-          <p:nvPr/>
-        </p:nvSpPr>
-        <p:spPr>
-          <a:xfrm>
-            <a:off x="1234440" y="6155440"/>
-            <a:ext cx="7148760" cy="384048"/>
-          </a:xfrm>
-          <a:prstGeom prst="rect">
-            <a:avLst/>
-          </a:prstGeom>
-          <a:noFill/>
-        </p:spPr>
-        <p:txBody>
-          <a:bodyPr wrap="square" lIns="0" rIns="0" tIns="18288" bIns="18288">
-            <a:spAutoFit/>
-          </a:bodyPr>
-          <a:lstStyle/>
-          <a:p>
-            <a:pPr algn="l"/>
-            <a:r>
-              <a:rPr sz="1350" b="1" i="0">
-                <a:solidFill>
-                  <a:srgbClr val="FFFFFF"/>
-                </a:solidFill>
-                <a:latin typeface="Calibri"/>
-              </a:rPr>
-              <a:t>System Tray</a:t>
-            </a:r>
-          </a:p>
-        </p:txBody>
-      </p:sp>
-      <p:sp>
-        <p:nvSpPr>
-          <p:cNvPr id="54" name="TextBox 53"/>
-          <p:cNvSpPr txBox="1"/>
-          <p:nvPr/>
-        </p:nvSpPr>
-        <p:spPr>
-          <a:xfrm>
-            <a:off x="1234440" y="6400000"/>
-            <a:ext cx="7148760" cy="230352"/>
-          </a:xfrm>
-          <a:prstGeom prst="rect">
-            <a:avLst/>
-          </a:prstGeom>
-          <a:noFill/>
-        </p:spPr>
-        <p:txBody>
-          <a:bodyPr wrap="square" lIns="0" rIns="0" tIns="18288" bIns="18288">
-            <a:spAutoFit/>
-          </a:bodyPr>
-          <a:lstStyle/>
-          <a:p>
-            <a:pPr algn="l"/>
-            <a:r>
-              <a:rPr sz="1200" b="0" i="0">
-                <a:solidFill>
-                  <a:srgbClr val="A8C8E8"/>
-                </a:solidFill>
-                <a:latin typeface="Calibri"/>
-              </a:rPr>
-              <a:t>Server minimises to tray — click X to hide, right-click to show or exit</a:t>
             </a:r>
           </a:p>
         </p:txBody>

</xml_diff>

<commit_message>
PPTX: lean rebuild — 12 to 8 slides, main points only. Consolidated feature slides into one 'Key Features' slide; trimmed Three Apps with larger screenshots; cut feature deep-dives (kept hidden in-file). Built for live demo. -- Co-Authored-By: Claude Opus 4.8 <noreply@anthropic.com>
</commit_message>
<xml_diff>
--- a/AssetManager_Presentation.pptx
+++ b/AssetManager_Presentation.pptx
@@ -9,13 +9,9 @@
     <p:sldId id="257" r:id="rId8"/>
     <p:sldId id="258" r:id="rId9"/>
     <p:sldId id="259" r:id="rId10"/>
-    <p:sldId id="260" r:id="rId11"/>
-    <p:sldId id="261" r:id="rId12"/>
-    <p:sldId id="262" r:id="rId13"/>
     <p:sldId id="263" r:id="rId14"/>
     <p:sldId id="265" r:id="rId16"/>
     <p:sldId id="266" r:id="rId17"/>
-    <p:sldId id="267" r:id="rId18"/>
     <p:sldId id="268" r:id="rId19"/>
   </p:sldIdLst>
   <p:sldSz cx="9144000" cy="5143500" type="screen4x3"/>
@@ -7985,7 +7981,7 @@
                 </a:solidFill>
                 <a:latin typeface="Calibri"/>
               </a:rPr>
-              <a:t>Flask API + SQLite DB.</a:t>
+              <a:t>Flask + SQLite, Windows Service</a:t>
             </a:r>
           </a:p>
           <a:p>
@@ -7997,7 +7993,7 @@
                 </a:solidFill>
                 <a:latin typeface="Calibri"/>
               </a:rPr>
-              <a:t>Runs as Windows Service on the server computer.</a:t>
+              <a:t/>
             </a:r>
           </a:p>
           <a:p>
@@ -8009,7 +8005,7 @@
                 </a:solidFill>
                 <a:latin typeface="Calibri"/>
               </a:rPr>
-              <a:t>Admin GUI included.</a:t>
+              <a:t/>
             </a:r>
           </a:p>
         </p:txBody>
@@ -8197,7 +8193,7 @@
                 </a:solidFill>
                 <a:latin typeface="Calibri"/>
               </a:rPr>
-              <a:t>Used by Storekeeper User.</a:t>
+              <a:t>Log assets in &amp; out</a:t>
             </a:r>
           </a:p>
           <a:p>
@@ -8209,7 +8205,7 @@
                 </a:solidFill>
                 <a:latin typeface="Calibri"/>
               </a:rPr>
-              <a:t>Log assets in and out.</a:t>
+              <a:t/>
             </a:r>
           </a:p>
           <a:p>
@@ -8221,7 +8217,7 @@
                 </a:solidFill>
                 <a:latin typeface="Calibri"/>
               </a:rPr>
-              <a:t>Lookup, history, bulk scan, export.</a:t>
+              <a:t/>
             </a:r>
           </a:p>
         </p:txBody>
@@ -8409,7 +8405,7 @@
                 </a:solidFill>
                 <a:latin typeface="Calibri"/>
               </a:rPr>
-              <a:t>Used by engineers.</a:t>
+              <a:t>Confirm / reject via popup</a:t>
             </a:r>
           </a:p>
           <a:p>
@@ -8421,7 +8417,7 @@
                 </a:solidFill>
                 <a:latin typeface="Calibri"/>
               </a:rPr>
-              <a:t>Receives transaction alerts.</a:t>
+              <a:t/>
             </a:r>
           </a:p>
           <a:p>
@@ -8433,7 +8429,7 @@
                 </a:solidFill>
                 <a:latin typeface="Calibri"/>
               </a:rPr>
-              <a:t>Confirm or reject in one click.</a:t>
+              <a:t/>
             </a:r>
           </a:p>
         </p:txBody>
@@ -8454,8 +8450,8 @@
         </p:blipFill>
         <p:spPr>
           <a:xfrm>
-            <a:off x="1344168" y="3520440"/>
-            <a:ext cx="950976" cy="1161288"/>
+            <a:off x="1088136" y="2857500"/>
+            <a:ext cx="1463040" cy="1783080"/>
           </a:xfrm>
           <a:prstGeom prst="rect">
             <a:avLst/>
@@ -8490,8 +8486,8 @@
         </p:blipFill>
         <p:spPr>
           <a:xfrm>
-            <a:off x="3813048" y="3520440"/>
-            <a:ext cx="1682496" cy="1161288"/>
+            <a:off x="3488436" y="2944368"/>
+            <a:ext cx="2331720" cy="1609344"/>
           </a:xfrm>
           <a:prstGeom prst="rect">
             <a:avLst/>
@@ -8526,8 +8522,8 @@
         </p:blipFill>
         <p:spPr>
           <a:xfrm>
-            <a:off x="6391656" y="3561588"/>
-            <a:ext cx="2194560" cy="1079112"/>
+            <a:off x="6323076" y="3172968"/>
+            <a:ext cx="2331720" cy="1152144"/>
           </a:xfrm>
           <a:prstGeom prst="rect">
             <a:avLst/>
@@ -11119,7 +11115,7 @@
                 </a:solidFill>
                 <a:latin typeface="Calibri"/>
               </a:rPr>
-              <a:t>Admin Has Full Control</a:t>
+              <a:t>Key Features</a:t>
             </a:r>
           </a:p>
         </p:txBody>
@@ -11280,7 +11276,7 @@
               <a:rPr sz="1600" b="0" i="0">
                 <a:latin typeface="Segoe UI Emoji"/>
               </a:rPr>
-              <a:t>🔐</a:t>
+              <a:t>📝</a:t>
             </a:r>
           </a:p>
         </p:txBody>
@@ -11315,7 +11311,7 @@
                 </a:solidFill>
                 <a:latin typeface="Calibri"/>
               </a:rPr>
-              <a:t>Change Password</a:t>
+              <a:t>Auto-Fill</a:t>
             </a:r>
           </a:p>
         </p:txBody>
@@ -11350,7 +11346,7 @@
                 </a:solidFill>
                 <a:latin typeface="Calibri"/>
               </a:rPr>
-              <a:t>SHA-256 protected.</a:t>
+              <a:t>Type asset or serial,</a:t>
             </a:r>
           </a:p>
           <a:p>
@@ -11362,7 +11358,7 @@
                 </a:solidFill>
                 <a:latin typeface="Calibri"/>
               </a:rPr>
-              <a:t>Update anytime from</a:t>
+              <a:t>type &amp; model fill in.</a:t>
             </a:r>
           </a:p>
           <a:p>
@@ -11374,7 +11370,7 @@
                 </a:solidFill>
                 <a:latin typeface="Calibri"/>
               </a:rPr>
-              <a:t>the server GUI.</a:t>
+              <a:t/>
             </a:r>
           </a:p>
         </p:txBody>
@@ -11492,7 +11488,7 @@
               <a:rPr sz="1600" b="0" i="0">
                 <a:latin typeface="Segoe UI Emoji"/>
               </a:rPr>
-              <a:t>🌐</a:t>
+              <a:t>🛡</a:t>
             </a:r>
           </a:p>
         </p:txBody>
@@ -11527,7 +11523,7 @@
                 </a:solidFill>
                 <a:latin typeface="Calibri"/>
               </a:rPr>
-              <a:t>Change Host / Port</a:t>
+              <a:t>Duplicate Guard</a:t>
             </a:r>
           </a:p>
         </p:txBody>
@@ -11562,7 +11558,7 @@
                 </a:solidFill>
                 <a:latin typeface="Calibri"/>
               </a:rPr>
-              <a:t>Move to any port.</a:t>
+              <a:t>Server blocks</a:t>
             </a:r>
           </a:p>
           <a:p>
@@ -11574,7 +11570,7 @@
                 </a:solidFill>
                 <a:latin typeface="Calibri"/>
               </a:rPr>
-              <a:t>Default is 8081. Saved to</a:t>
+              <a:t>re-submission (409).</a:t>
             </a:r>
           </a:p>
           <a:p>
@@ -11586,7 +11582,7 @@
                 </a:solidFill>
                 <a:latin typeface="Calibri"/>
               </a:rPr>
-              <a:t>config, applied on restart.</a:t>
+              <a:t/>
             </a:r>
           </a:p>
         </p:txBody>
@@ -11704,7 +11700,7 @@
               <a:rPr sz="1600" b="0" i="0">
                 <a:latin typeface="Segoe UI Emoji"/>
               </a:rPr>
-              <a:t>📋</a:t>
+              <a:t>📊</a:t>
             </a:r>
           </a:p>
         </p:txBody>
@@ -11739,7 +11735,7 @@
                 </a:solidFill>
                 <a:latin typeface="Calibri"/>
               </a:rPr>
-              <a:t>Update Lookup File</a:t>
+              <a:t>Excel Export</a:t>
             </a:r>
           </a:p>
         </p:txBody>
@@ -11774,7 +11770,7 @@
                 </a:solidFill>
                 <a:latin typeface="Calibri"/>
               </a:rPr>
-              <a:t>Edit asset_lookup.xlsx directly.</a:t>
+              <a:t>Color-coded history,</a:t>
             </a:r>
           </a:p>
           <a:p>
@@ -11786,7 +11782,7 @@
                 </a:solidFill>
                 <a:latin typeface="Calibri"/>
               </a:rPr>
-              <a:t>Changes apply immediately,</a:t>
+              <a:t>summary + charts.</a:t>
             </a:r>
           </a:p>
           <a:p>
@@ -11798,7 +11794,7 @@
                 </a:solidFill>
                 <a:latin typeface="Calibri"/>
               </a:rPr>
-              <a:t>no restart needed.</a:t>
+              <a:t/>
             </a:r>
           </a:p>
         </p:txBody>
@@ -11916,7 +11912,7 @@
               <a:rPr sz="1600" b="0" i="0">
                 <a:latin typeface="Segoe UI Emoji"/>
               </a:rPr>
-              <a:t>🗑</a:t>
+              <a:t>🔐</a:t>
             </a:r>
           </a:p>
         </p:txBody>
@@ -11951,7 +11947,7 @@
                 </a:solidFill>
                 <a:latin typeface="Calibri"/>
               </a:rPr>
-              <a:t>Clear All Records</a:t>
+              <a:t>Admin &amp; Security</a:t>
             </a:r>
           </a:p>
         </p:txBody>
@@ -11986,7 +11982,7 @@
                 </a:solidFill>
                 <a:latin typeface="Calibri"/>
               </a:rPr>
-              <a:t>Delete all records from the database.</a:t>
+              <a:t>Password, port, SSL,</a:t>
             </a:r>
           </a:p>
           <a:p>
@@ -11998,7 +11994,7 @@
                 </a:solidFill>
                 <a:latin typeface="Calibri"/>
               </a:rPr>
-              <a:t>Admin password + confirmation required.</a:t>
+              <a:t>clear records.</a:t>
             </a:r>
           </a:p>
           <a:p>

</xml_diff>

<commit_message>
Roll back to pre-feature state (v1.3.0): revert this session's 8 features, autostart, presentation redesign and doc changes. Restores working v1.3.0 code and assets.
</commit_message>
<xml_diff>
--- a/AssetManager_Presentation.pptx
+++ b/AssetManager_Presentation.pptx
@@ -9,9 +9,14 @@
     <p:sldId id="257" r:id="rId8"/>
     <p:sldId id="258" r:id="rId9"/>
     <p:sldId id="259" r:id="rId10"/>
+    <p:sldId id="260" r:id="rId11"/>
+    <p:sldId id="261" r:id="rId12"/>
+    <p:sldId id="262" r:id="rId13"/>
     <p:sldId id="263" r:id="rId14"/>
+    <p:sldId id="264" r:id="rId15"/>
     <p:sldId id="265" r:id="rId16"/>
     <p:sldId id="266" r:id="rId17"/>
+    <p:sldId id="267" r:id="rId18"/>
     <p:sldId id="268" r:id="rId19"/>
   </p:sldIdLst>
   <p:sldSz cx="9144000" cy="5143500" type="screen4x3"/>
@@ -3486,7 +3491,7 @@
         </p:nvSpPr>
         <p:spPr>
           <a:xfrm>
-            <a:off x="630936" y="1097280"/>
+            <a:off x="630936" y="932688"/>
             <a:ext cx="512064" cy="512064"/>
           </a:xfrm>
           <a:prstGeom prst="ellipse">
@@ -3529,7 +3534,7 @@
         </p:nvSpPr>
         <p:spPr>
           <a:xfrm>
-            <a:off x="630936" y="1097280"/>
+            <a:off x="630936" y="932688"/>
             <a:ext cx="512064" cy="512064"/>
           </a:xfrm>
           <a:prstGeom prst="rect">
@@ -3564,7 +3569,7 @@
         </p:nvSpPr>
         <p:spPr>
           <a:xfrm>
-            <a:off x="1298448" y="1207008"/>
+            <a:off x="1298448" y="1042416"/>
             <a:ext cx="3566160" cy="384048"/>
           </a:xfrm>
           <a:prstGeom prst="rect">
@@ -3586,7 +3591,7 @@
                 </a:solidFill>
                 <a:latin typeface="Calibri"/>
               </a:rPr>
-              <a:t>Open app — set Out / In Store</a:t>
+              <a:t>Open Storekeeper App</a:t>
             </a:r>
           </a:p>
         </p:txBody>
@@ -3599,7 +3604,7 @@
         </p:nvSpPr>
         <p:spPr>
           <a:xfrm>
-            <a:off x="630936" y="1920240"/>
+            <a:off x="630936" y="1472184"/>
             <a:ext cx="512064" cy="512064"/>
           </a:xfrm>
           <a:prstGeom prst="ellipse">
@@ -3642,7 +3647,7 @@
         </p:nvSpPr>
         <p:spPr>
           <a:xfrm>
-            <a:off x="630936" y="1920240"/>
+            <a:off x="630936" y="1472184"/>
             <a:ext cx="512064" cy="512064"/>
           </a:xfrm>
           <a:prstGeom prst="rect">
@@ -3677,7 +3682,7 @@
         </p:nvSpPr>
         <p:spPr>
           <a:xfrm>
-            <a:off x="1298448" y="2030328"/>
+            <a:off x="1298448" y="1581912"/>
             <a:ext cx="3566160" cy="384048"/>
           </a:xfrm>
           <a:prstGeom prst="rect">
@@ -3699,7 +3704,7 @@
                 </a:solidFill>
                 <a:latin typeface="Calibri"/>
               </a:rPr>
-              <a:t>Enter Asset No. or Serial</a:t>
+              <a:t>Select direction: Out Store</a:t>
             </a:r>
           </a:p>
         </p:txBody>
@@ -3712,7 +3717,7 @@
         </p:nvSpPr>
         <p:spPr>
           <a:xfrm>
-            <a:off x="630936" y="2743200"/>
+            <a:off x="630936" y="2011680"/>
             <a:ext cx="512064" cy="512064"/>
           </a:xfrm>
           <a:prstGeom prst="ellipse">
@@ -3755,7 +3760,7 @@
         </p:nvSpPr>
         <p:spPr>
           <a:xfrm>
-            <a:off x="630936" y="2743200"/>
+            <a:off x="630936" y="2011680"/>
             <a:ext cx="512064" cy="512064"/>
           </a:xfrm>
           <a:prstGeom prst="rect">
@@ -3790,7 +3795,7 @@
         </p:nvSpPr>
         <p:spPr>
           <a:xfrm>
-            <a:off x="1298448" y="2853408"/>
+            <a:off x="1298448" y="2121408"/>
             <a:ext cx="3566160" cy="384048"/>
           </a:xfrm>
           <a:prstGeom prst="rect">
@@ -3812,7 +3817,7 @@
                 </a:solidFill>
                 <a:latin typeface="Calibri"/>
               </a:rPr>
-              <a:t>Type &amp; Model auto-fill; pick engineer</a:t>
+              <a:t>Enter Asset Number or Serial</a:t>
             </a:r>
           </a:p>
         </p:txBody>
@@ -3825,7 +3830,7 @@
         </p:nvSpPr>
         <p:spPr>
           <a:xfrm>
-            <a:off x="630936" y="3566160"/>
+            <a:off x="630936" y="2551176"/>
             <a:ext cx="512064" cy="512064"/>
           </a:xfrm>
           <a:prstGeom prst="ellipse">
@@ -3868,7 +3873,7 @@
         </p:nvSpPr>
         <p:spPr>
           <a:xfrm>
-            <a:off x="630936" y="3566160"/>
+            <a:off x="630936" y="2551176"/>
             <a:ext cx="512064" cy="512064"/>
           </a:xfrm>
           <a:prstGeom prst="rect">
@@ -3903,7 +3908,7 @@
         </p:nvSpPr>
         <p:spPr>
           <a:xfrm>
-            <a:off x="1298448" y="3676248"/>
+            <a:off x="1298448" y="2660904"/>
             <a:ext cx="3566160" cy="384048"/>
           </a:xfrm>
           <a:prstGeom prst="rect">
@@ -3925,7 +3930,346 @@
                 </a:solidFill>
                 <a:latin typeface="Calibri"/>
               </a:rPr>
-              <a:t>Submit — engineer notified instantly</a:t>
+              <a:t>Type + Model auto-fill → locked</a:t>
+            </a:r>
+          </a:p>
+        </p:txBody>
+      </p:sp>
+      <p:sp>
+        <p:nvSpPr>
+          <p:cNvPr id="16" name="Oval 15"/>
+          <p:cNvSpPr/>
+          <p:nvPr/>
+        </p:nvSpPr>
+        <p:spPr>
+          <a:xfrm>
+            <a:off x="630936" y="3090672"/>
+            <a:ext cx="512064" cy="512064"/>
+          </a:xfrm>
+          <a:prstGeom prst="ellipse">
+            <a:avLst/>
+          </a:prstGeom>
+          <a:solidFill>
+            <a:srgbClr val="0078D4"/>
+          </a:solidFill>
+          <a:ln>
+            <a:noFill/>
+          </a:ln>
+        </p:spPr>
+        <p:style>
+          <a:lnRef idx="1">
+            <a:schemeClr val="accent1"/>
+          </a:lnRef>
+          <a:fillRef idx="3">
+            <a:schemeClr val="accent1"/>
+          </a:fillRef>
+          <a:effectRef idx="2">
+            <a:schemeClr val="accent1"/>
+          </a:effectRef>
+          <a:fontRef idx="minor">
+            <a:schemeClr val="lt1"/>
+          </a:fontRef>
+        </p:style>
+        <p:txBody>
+          <a:bodyPr rtlCol="0" anchor="ctr"/>
+          <a:lstStyle/>
+          <a:p>
+            <a:pPr algn="ctr"/>
+          </a:p>
+        </p:txBody>
+      </p:sp>
+      <p:sp>
+        <p:nvSpPr>
+          <p:cNvPr id="17" name="TextBox 16"/>
+          <p:cNvSpPr txBox="1"/>
+          <p:nvPr/>
+        </p:nvSpPr>
+        <p:spPr>
+          <a:xfrm>
+            <a:off x="630936" y="3090672"/>
+            <a:ext cx="512064" cy="512064"/>
+          </a:xfrm>
+          <a:prstGeom prst="rect">
+            <a:avLst/>
+          </a:prstGeom>
+          <a:noFill/>
+        </p:spPr>
+        <p:txBody>
+          <a:bodyPr wrap="square" lIns="0" rIns="0" tIns="18288" bIns="18288">
+            <a:spAutoFit/>
+          </a:bodyPr>
+          <a:lstStyle/>
+          <a:p>
+            <a:pPr algn="ctr"/>
+            <a:r>
+              <a:rPr sz="1400" b="1" i="0">
+                <a:solidFill>
+                  <a:srgbClr val="FFFFFF"/>
+                </a:solidFill>
+                <a:latin typeface="Calibri"/>
+              </a:rPr>
+              <a:t>5</a:t>
+            </a:r>
+          </a:p>
+        </p:txBody>
+      </p:sp>
+      <p:sp>
+        <p:nvSpPr>
+          <p:cNvPr id="18" name="TextBox 17"/>
+          <p:cNvSpPr txBox="1"/>
+          <p:nvPr/>
+        </p:nvSpPr>
+        <p:spPr>
+          <a:xfrm>
+            <a:off x="1298448" y="3200400"/>
+            <a:ext cx="3566160" cy="384048"/>
+          </a:xfrm>
+          <a:prstGeom prst="rect">
+            <a:avLst/>
+          </a:prstGeom>
+          <a:noFill/>
+        </p:spPr>
+        <p:txBody>
+          <a:bodyPr wrap="square" lIns="0" rIns="0" tIns="18288" bIns="18288">
+            <a:spAutoFit/>
+          </a:bodyPr>
+          <a:lstStyle/>
+          <a:p>
+            <a:pPr algn="l"/>
+            <a:r>
+              <a:rPr sz="1250" b="0" i="0">
+                <a:solidFill>
+                  <a:srgbClr val="1A1A2E"/>
+                </a:solidFill>
+                <a:latin typeface="Calibri"/>
+              </a:rPr>
+              <a:t>Select engineer from dropdown</a:t>
+            </a:r>
+          </a:p>
+        </p:txBody>
+      </p:sp>
+      <p:sp>
+        <p:nvSpPr>
+          <p:cNvPr id="19" name="Oval 18"/>
+          <p:cNvSpPr/>
+          <p:nvPr/>
+        </p:nvSpPr>
+        <p:spPr>
+          <a:xfrm>
+            <a:off x="630936" y="3630168"/>
+            <a:ext cx="512064" cy="512064"/>
+          </a:xfrm>
+          <a:prstGeom prst="ellipse">
+            <a:avLst/>
+          </a:prstGeom>
+          <a:solidFill>
+            <a:srgbClr val="0078D4"/>
+          </a:solidFill>
+          <a:ln>
+            <a:noFill/>
+          </a:ln>
+        </p:spPr>
+        <p:style>
+          <a:lnRef idx="1">
+            <a:schemeClr val="accent1"/>
+          </a:lnRef>
+          <a:fillRef idx="3">
+            <a:schemeClr val="accent1"/>
+          </a:fillRef>
+          <a:effectRef idx="2">
+            <a:schemeClr val="accent1"/>
+          </a:effectRef>
+          <a:fontRef idx="minor">
+            <a:schemeClr val="lt1"/>
+          </a:fontRef>
+        </p:style>
+        <p:txBody>
+          <a:bodyPr rtlCol="0" anchor="ctr"/>
+          <a:lstStyle/>
+          <a:p>
+            <a:pPr algn="ctr"/>
+          </a:p>
+        </p:txBody>
+      </p:sp>
+      <p:sp>
+        <p:nvSpPr>
+          <p:cNvPr id="20" name="TextBox 19"/>
+          <p:cNvSpPr txBox="1"/>
+          <p:nvPr/>
+        </p:nvSpPr>
+        <p:spPr>
+          <a:xfrm>
+            <a:off x="630936" y="3630168"/>
+            <a:ext cx="512064" cy="512064"/>
+          </a:xfrm>
+          <a:prstGeom prst="rect">
+            <a:avLst/>
+          </a:prstGeom>
+          <a:noFill/>
+        </p:spPr>
+        <p:txBody>
+          <a:bodyPr wrap="square" lIns="0" rIns="0" tIns="18288" bIns="18288">
+            <a:spAutoFit/>
+          </a:bodyPr>
+          <a:lstStyle/>
+          <a:p>
+            <a:pPr algn="ctr"/>
+            <a:r>
+              <a:rPr sz="1400" b="1" i="0">
+                <a:solidFill>
+                  <a:srgbClr val="FFFFFF"/>
+                </a:solidFill>
+                <a:latin typeface="Calibri"/>
+              </a:rPr>
+              <a:t>6</a:t>
+            </a:r>
+          </a:p>
+        </p:txBody>
+      </p:sp>
+      <p:sp>
+        <p:nvSpPr>
+          <p:cNvPr id="21" name="TextBox 20"/>
+          <p:cNvSpPr txBox="1"/>
+          <p:nvPr/>
+        </p:nvSpPr>
+        <p:spPr>
+          <a:xfrm>
+            <a:off x="1298448" y="3739896"/>
+            <a:ext cx="3566160" cy="384048"/>
+          </a:xfrm>
+          <a:prstGeom prst="rect">
+            <a:avLst/>
+          </a:prstGeom>
+          <a:noFill/>
+        </p:spPr>
+        <p:txBody>
+          <a:bodyPr wrap="square" lIns="0" rIns="0" tIns="18288" bIns="18288">
+            <a:spAutoFit/>
+          </a:bodyPr>
+          <a:lstStyle/>
+          <a:p>
+            <a:pPr algn="l"/>
+            <a:r>
+              <a:rPr sz="1250" b="0" i="0">
+                <a:solidFill>
+                  <a:srgbClr val="1A1A2E"/>
+                </a:solidFill>
+                <a:latin typeface="Calibri"/>
+              </a:rPr>
+              <a:t>Click Submit</a:t>
+            </a:r>
+          </a:p>
+        </p:txBody>
+      </p:sp>
+      <p:sp>
+        <p:nvSpPr>
+          <p:cNvPr id="22" name="Oval 21"/>
+          <p:cNvSpPr/>
+          <p:nvPr/>
+        </p:nvSpPr>
+        <p:spPr>
+          <a:xfrm>
+            <a:off x="630936" y="4169663"/>
+            <a:ext cx="512064" cy="512064"/>
+          </a:xfrm>
+          <a:prstGeom prst="ellipse">
+            <a:avLst/>
+          </a:prstGeom>
+          <a:solidFill>
+            <a:srgbClr val="0078D4"/>
+          </a:solidFill>
+          <a:ln>
+            <a:noFill/>
+          </a:ln>
+        </p:spPr>
+        <p:style>
+          <a:lnRef idx="1">
+            <a:schemeClr val="accent1"/>
+          </a:lnRef>
+          <a:fillRef idx="3">
+            <a:schemeClr val="accent1"/>
+          </a:fillRef>
+          <a:effectRef idx="2">
+            <a:schemeClr val="accent1"/>
+          </a:effectRef>
+          <a:fontRef idx="minor">
+            <a:schemeClr val="lt1"/>
+          </a:fontRef>
+        </p:style>
+        <p:txBody>
+          <a:bodyPr rtlCol="0" anchor="ctr"/>
+          <a:lstStyle/>
+          <a:p>
+            <a:pPr algn="ctr"/>
+          </a:p>
+        </p:txBody>
+      </p:sp>
+      <p:sp>
+        <p:nvSpPr>
+          <p:cNvPr id="23" name="TextBox 22"/>
+          <p:cNvSpPr txBox="1"/>
+          <p:nvPr/>
+        </p:nvSpPr>
+        <p:spPr>
+          <a:xfrm>
+            <a:off x="630936" y="4169663"/>
+            <a:ext cx="512064" cy="512064"/>
+          </a:xfrm>
+          <a:prstGeom prst="rect">
+            <a:avLst/>
+          </a:prstGeom>
+          <a:noFill/>
+        </p:spPr>
+        <p:txBody>
+          <a:bodyPr wrap="square" lIns="0" rIns="0" tIns="18288" bIns="18288">
+            <a:spAutoFit/>
+          </a:bodyPr>
+          <a:lstStyle/>
+          <a:p>
+            <a:pPr algn="ctr"/>
+            <a:r>
+              <a:rPr sz="1400" b="1" i="0">
+                <a:solidFill>
+                  <a:srgbClr val="FFFFFF"/>
+                </a:solidFill>
+                <a:latin typeface="Calibri"/>
+              </a:rPr>
+              <a:t>7</a:t>
+            </a:r>
+          </a:p>
+        </p:txBody>
+      </p:sp>
+      <p:sp>
+        <p:nvSpPr>
+          <p:cNvPr id="24" name="TextBox 23"/>
+          <p:cNvSpPr txBox="1"/>
+          <p:nvPr/>
+        </p:nvSpPr>
+        <p:spPr>
+          <a:xfrm>
+            <a:off x="1298448" y="4279392"/>
+            <a:ext cx="3566160" cy="384048"/>
+          </a:xfrm>
+          <a:prstGeom prst="rect">
+            <a:avLst/>
+          </a:prstGeom>
+          <a:noFill/>
+        </p:spPr>
+        <p:txBody>
+          <a:bodyPr wrap="square" lIns="0" rIns="0" tIns="18288" bIns="18288">
+            <a:spAutoFit/>
+          </a:bodyPr>
+          <a:lstStyle/>
+          <a:p>
+            <a:pPr algn="l"/>
+            <a:r>
+              <a:rPr sz="1250" b="0" i="0">
+                <a:solidFill>
+                  <a:srgbClr val="1A1A2E"/>
+                </a:solidFill>
+                <a:latin typeface="Calibri"/>
+              </a:rPr>
+              <a:t>Engineer receives notification instantly</a:t>
             </a:r>
           </a:p>
         </p:txBody>
@@ -3938,8 +4282,8 @@
         </p:nvSpPr>
         <p:spPr>
           <a:xfrm>
-            <a:off x="4873752" y="1517904"/>
-            <a:ext cx="4151376" cy="2935224"/>
+            <a:off x="5074920" y="1024128"/>
+            <a:ext cx="3566160" cy="3767328"/>
           </a:xfrm>
           <a:prstGeom prst="roundRect">
             <a:avLst/>
@@ -4003,7 +4347,7 @@
                 </a:solidFill>
                 <a:latin typeface="Calibri"/>
               </a:rPr>
-              <a:t/>
+              <a:t>[ Demo / Screenshot here ]</a:t>
             </a:r>
           </a:p>
         </p:txBody>
@@ -4024,24 +4368,12 @@
         </p:blipFill>
         <p:spPr>
           <a:xfrm>
-            <a:off x="4983480" y="1627632"/>
-            <a:ext cx="3931920" cy="2715948"/>
-          </a:xfrm>
-          <a:prstGeom prst="rect">
-            <a:avLst/>
-          </a:prstGeom>
-          <a:ln w="9525">
-            <a:solidFill>
-              <a:srgbClr val="C8CDD2"/>
-            </a:solidFill>
-          </a:ln>
-          <a:effectLst>
-            <a:outerShdw blurRad="38100" dist="19050" dir="5400000" rotWithShape="0">
-              <a:srgbClr val="000000">
-                <a:alpha val="24000"/>
-              </a:srgbClr>
-            </a:outerShdw>
-          </a:effectLst>
+            <a:off x="457200" y="1131570"/>
+            <a:ext cx="8229600" cy="5673610"/>
+          </a:xfrm>
+          <a:prstGeom prst="rect">
+            <a:avLst/>
+          </a:prstGeom>
         </p:spPr>
       </p:pic>
     </p:spTree>
@@ -4156,7 +4488,7 @@
         </p:nvSpPr>
         <p:spPr>
           <a:xfrm>
-            <a:off x="630936" y="1371600"/>
+            <a:off x="630936" y="987551"/>
             <a:ext cx="512064" cy="512064"/>
           </a:xfrm>
           <a:prstGeom prst="ellipse">
@@ -4199,7 +4531,7 @@
         </p:nvSpPr>
         <p:spPr>
           <a:xfrm>
-            <a:off x="630936" y="1371600"/>
+            <a:off x="630936" y="987551"/>
             <a:ext cx="512064" cy="512064"/>
           </a:xfrm>
           <a:prstGeom prst="rect">
@@ -4234,7 +4566,7 @@
         </p:nvSpPr>
         <p:spPr>
           <a:xfrm>
-            <a:off x="1298448" y="1481328"/>
+            <a:off x="1298448" y="1097280"/>
             <a:ext cx="3566160" cy="384048"/>
           </a:xfrm>
           <a:prstGeom prst="rect">
@@ -4256,7 +4588,7 @@
                 </a:solidFill>
                 <a:latin typeface="Calibri"/>
               </a:rPr>
-              <a:t>Runs quietly in the system tray</a:t>
+              <a:t>Launch NotifierApp.exe -- runs in system tray</a:t>
             </a:r>
           </a:p>
         </p:txBody>
@@ -4269,7 +4601,7 @@
         </p:nvSpPr>
         <p:spPr>
           <a:xfrm>
-            <a:off x="630936" y="2331720"/>
+            <a:off x="630936" y="1645920"/>
             <a:ext cx="512064" cy="512064"/>
           </a:xfrm>
           <a:prstGeom prst="ellipse">
@@ -4312,7 +4644,7 @@
         </p:nvSpPr>
         <p:spPr>
           <a:xfrm>
-            <a:off x="630936" y="2331720"/>
+            <a:off x="630936" y="1645920"/>
             <a:ext cx="512064" cy="512064"/>
           </a:xfrm>
           <a:prstGeom prst="rect">
@@ -4347,7 +4679,7 @@
         </p:nvSpPr>
         <p:spPr>
           <a:xfrm>
-            <a:off x="1298448" y="2441448"/>
+            <a:off x="1298448" y="1755648"/>
             <a:ext cx="3566160" cy="384048"/>
           </a:xfrm>
           <a:prstGeom prst="rect">
@@ -4382,7 +4714,7 @@
         </p:nvSpPr>
         <p:spPr>
           <a:xfrm>
-            <a:off x="630936" y="3291840"/>
+            <a:off x="630936" y="2304288"/>
             <a:ext cx="512064" cy="512064"/>
           </a:xfrm>
           <a:prstGeom prst="ellipse">
@@ -4425,7 +4757,7 @@
         </p:nvSpPr>
         <p:spPr>
           <a:xfrm>
-            <a:off x="630936" y="3291840"/>
+            <a:off x="630936" y="2304288"/>
             <a:ext cx="512064" cy="512064"/>
           </a:xfrm>
           <a:prstGeom prst="rect">
@@ -4460,7 +4792,7 @@
         </p:nvSpPr>
         <p:spPr>
           <a:xfrm>
-            <a:off x="1298448" y="3401568"/>
+            <a:off x="1298448" y="2414016"/>
             <a:ext cx="3566160" cy="384048"/>
           </a:xfrm>
           <a:prstGeom prst="rect">
@@ -4482,26 +4814,28 @@
                 </a:solidFill>
                 <a:latin typeface="Calibri"/>
               </a:rPr>
-              <a:t>Confirm or Reject — updates live</a:t>
-            </a:r>
-          </a:p>
-        </p:txBody>
-      </p:sp>
-      <p:sp>
-        <p:nvSpPr>
-          <p:cNvPr id="19" name="Rounded Rectangle 18"/>
+              <a:t>Shows: Type, Model, Asset No., Direction</a:t>
+            </a:r>
+          </a:p>
+        </p:txBody>
+      </p:sp>
+      <p:sp>
+        <p:nvSpPr>
+          <p:cNvPr id="13" name="Oval 12"/>
           <p:cNvSpPr/>
           <p:nvPr/>
         </p:nvSpPr>
         <p:spPr>
           <a:xfrm>
-            <a:off x="5074920" y="1024128"/>
-            <a:ext cx="3566160" cy="3767328"/>
-          </a:xfrm>
-          <a:prstGeom prst="roundRect">
-            <a:avLst/>
-          </a:prstGeom>
-          <a:noFill/>
+            <a:off x="630936" y="2962656"/>
+            <a:ext cx="512064" cy="512064"/>
+          </a:xfrm>
+          <a:prstGeom prst="ellipse">
+            <a:avLst/>
+          </a:prstGeom>
+          <a:solidFill>
+            <a:srgbClr val="0078D4"/>
+          </a:solidFill>
           <a:ln>
             <a:noFill/>
           </a:ln>
@@ -4530,8 +4864,191 @@
       </p:sp>
       <p:sp>
         <p:nvSpPr>
-          <p:cNvPr id="20" name="TextBox 19"/>
-          <p:cNvSpPr txBox="1"/>
+          <p:cNvPr id="14" name="TextBox 13"/>
+          <p:cNvSpPr txBox="1"/>
+          <p:nvPr/>
+        </p:nvSpPr>
+        <p:spPr>
+          <a:xfrm>
+            <a:off x="630936" y="2962656"/>
+            <a:ext cx="512064" cy="512064"/>
+          </a:xfrm>
+          <a:prstGeom prst="rect">
+            <a:avLst/>
+          </a:prstGeom>
+          <a:noFill/>
+        </p:spPr>
+        <p:txBody>
+          <a:bodyPr wrap="square" lIns="0" rIns="0" tIns="18288" bIns="18288">
+            <a:spAutoFit/>
+          </a:bodyPr>
+          <a:lstStyle/>
+          <a:p>
+            <a:pPr algn="ctr"/>
+            <a:r>
+              <a:rPr sz="1400" b="1" i="0">
+                <a:solidFill>
+                  <a:srgbClr val="FFFFFF"/>
+                </a:solidFill>
+                <a:latin typeface="Calibri"/>
+              </a:rPr>
+              <a:t>4</a:t>
+            </a:r>
+          </a:p>
+        </p:txBody>
+      </p:sp>
+      <p:sp>
+        <p:nvSpPr>
+          <p:cNvPr id="15" name="TextBox 14"/>
+          <p:cNvSpPr txBox="1"/>
+          <p:nvPr/>
+        </p:nvSpPr>
+        <p:spPr>
+          <a:xfrm>
+            <a:off x="1298448" y="3072384"/>
+            <a:ext cx="3566160" cy="384048"/>
+          </a:xfrm>
+          <a:prstGeom prst="rect">
+            <a:avLst/>
+          </a:prstGeom>
+          <a:noFill/>
+        </p:spPr>
+        <p:txBody>
+          <a:bodyPr wrap="square" lIns="0" rIns="0" tIns="18288" bIns="18288">
+            <a:spAutoFit/>
+          </a:bodyPr>
+          <a:lstStyle/>
+          <a:p>
+            <a:pPr algn="l"/>
+            <a:r>
+              <a:rPr sz="1250" b="0" i="0">
+                <a:solidFill>
+                  <a:srgbClr val="1A1A2E"/>
+                </a:solidFill>
+                <a:latin typeface="Calibri"/>
+              </a:rPr>
+              <a:t>Click Confirm or Reject</a:t>
+            </a:r>
+          </a:p>
+        </p:txBody>
+      </p:sp>
+      <p:sp>
+        <p:nvSpPr>
+          <p:cNvPr id="16" name="Oval 15"/>
+          <p:cNvSpPr/>
+          <p:nvPr/>
+        </p:nvSpPr>
+        <p:spPr>
+          <a:xfrm>
+            <a:off x="630936" y="3621023"/>
+            <a:ext cx="512064" cy="512064"/>
+          </a:xfrm>
+          <a:prstGeom prst="ellipse">
+            <a:avLst/>
+          </a:prstGeom>
+          <a:solidFill>
+            <a:srgbClr val="0078D4"/>
+          </a:solidFill>
+          <a:ln>
+            <a:noFill/>
+          </a:ln>
+        </p:spPr>
+        <p:style>
+          <a:lnRef idx="1">
+            <a:schemeClr val="accent1"/>
+          </a:lnRef>
+          <a:fillRef idx="3">
+            <a:schemeClr val="accent1"/>
+          </a:fillRef>
+          <a:effectRef idx="2">
+            <a:schemeClr val="accent1"/>
+          </a:effectRef>
+          <a:fontRef idx="minor">
+            <a:schemeClr val="lt1"/>
+          </a:fontRef>
+        </p:style>
+        <p:txBody>
+          <a:bodyPr rtlCol="0" anchor="ctr"/>
+          <a:lstStyle/>
+          <a:p>
+            <a:pPr algn="ctr"/>
+          </a:p>
+        </p:txBody>
+      </p:sp>
+      <p:sp>
+        <p:nvSpPr>
+          <p:cNvPr id="17" name="TextBox 16"/>
+          <p:cNvSpPr txBox="1"/>
+          <p:nvPr/>
+        </p:nvSpPr>
+        <p:spPr>
+          <a:xfrm>
+            <a:off x="630936" y="3621023"/>
+            <a:ext cx="512064" cy="512064"/>
+          </a:xfrm>
+          <a:prstGeom prst="rect">
+            <a:avLst/>
+          </a:prstGeom>
+          <a:noFill/>
+        </p:spPr>
+        <p:txBody>
+          <a:bodyPr wrap="square" lIns="0" rIns="0" tIns="18288" bIns="18288">
+            <a:spAutoFit/>
+          </a:bodyPr>
+          <a:lstStyle/>
+          <a:p>
+            <a:pPr algn="ctr"/>
+            <a:r>
+              <a:rPr sz="1400" b="1" i="0">
+                <a:solidFill>
+                  <a:srgbClr val="FFFFFF"/>
+                </a:solidFill>
+                <a:latin typeface="Calibri"/>
+              </a:rPr>
+              <a:t>5</a:t>
+            </a:r>
+          </a:p>
+        </p:txBody>
+      </p:sp>
+      <p:sp>
+        <p:nvSpPr>
+          <p:cNvPr id="18" name="TextBox 17"/>
+          <p:cNvSpPr txBox="1"/>
+          <p:nvPr/>
+        </p:nvSpPr>
+        <p:spPr>
+          <a:xfrm>
+            <a:off x="1298448" y="3730751"/>
+            <a:ext cx="3566160" cy="384048"/>
+          </a:xfrm>
+          <a:prstGeom prst="rect">
+            <a:avLst/>
+          </a:prstGeom>
+          <a:noFill/>
+        </p:spPr>
+        <p:txBody>
+          <a:bodyPr wrap="square" lIns="0" rIns="0" tIns="18288" bIns="18288">
+            <a:spAutoFit/>
+          </a:bodyPr>
+          <a:lstStyle/>
+          <a:p>
+            <a:pPr algn="l"/>
+            <a:r>
+              <a:rPr sz="1250" b="0" i="0">
+                <a:solidFill>
+                  <a:srgbClr val="1A1A2E"/>
+                </a:solidFill>
+                <a:latin typeface="Calibri"/>
+              </a:rPr>
+              <a:t>Status updates in real time for storekeeper</a:t>
+            </a:r>
+          </a:p>
+        </p:txBody>
+      </p:sp>
+      <p:sp>
+        <p:nvSpPr>
+          <p:cNvPr id="19" name="Rounded Rectangle 18"/>
+          <p:cNvSpPr/>
           <p:nvPr/>
         </p:nvSpPr>
         <p:spPr>
@@ -4539,6 +5056,49 @@
             <a:off x="5074920" y="1024128"/>
             <a:ext cx="3566160" cy="3767328"/>
           </a:xfrm>
+          <a:prstGeom prst="roundRect">
+            <a:avLst/>
+          </a:prstGeom>
+          <a:solidFill>
+            <a:srgbClr val="E8E8E8"/>
+          </a:solidFill>
+          <a:ln>
+            <a:noFill/>
+          </a:ln>
+        </p:spPr>
+        <p:style>
+          <a:lnRef idx="1">
+            <a:schemeClr val="accent1"/>
+          </a:lnRef>
+          <a:fillRef idx="3">
+            <a:schemeClr val="accent1"/>
+          </a:fillRef>
+          <a:effectRef idx="2">
+            <a:schemeClr val="accent1"/>
+          </a:effectRef>
+          <a:fontRef idx="minor">
+            <a:schemeClr val="lt1"/>
+          </a:fontRef>
+        </p:style>
+        <p:txBody>
+          <a:bodyPr rtlCol="0" anchor="ctr"/>
+          <a:lstStyle/>
+          <a:p>
+            <a:pPr algn="ctr"/>
+          </a:p>
+        </p:txBody>
+      </p:sp>
+      <p:sp>
+        <p:nvSpPr>
+          <p:cNvPr id="20" name="TextBox 19"/>
+          <p:cNvSpPr txBox="1"/>
+          <p:nvPr/>
+        </p:nvSpPr>
+        <p:spPr>
+          <a:xfrm>
+            <a:off x="5074920" y="1024128"/>
+            <a:ext cx="3566160" cy="3767328"/>
+          </a:xfrm>
           <a:prstGeom prst="rect">
             <a:avLst/>
           </a:prstGeom>
@@ -4558,7 +5118,7 @@
                 </a:solidFill>
                 <a:latin typeface="Calibri"/>
               </a:rPr>
-              <a:t/>
+              <a:t>[ Demo / Screenshot here ]</a:t>
             </a:r>
           </a:p>
         </p:txBody>
@@ -4579,24 +5139,12 @@
         </p:blipFill>
         <p:spPr>
           <a:xfrm>
-            <a:off x="4983480" y="2002536"/>
-            <a:ext cx="3931920" cy="1938528"/>
-          </a:xfrm>
-          <a:prstGeom prst="rect">
-            <a:avLst/>
-          </a:prstGeom>
-          <a:ln w="9525">
-            <a:solidFill>
-              <a:srgbClr val="C8CDD2"/>
-            </a:solidFill>
-          </a:ln>
-          <a:effectLst>
-            <a:outerShdw blurRad="38100" dist="19050" dir="5400000" rotWithShape="0">
-              <a:srgbClr val="000000">
-                <a:alpha val="24000"/>
-              </a:srgbClr>
-            </a:outerShdw>
-          </a:effectLst>
+            <a:off x="2560320" y="1388745"/>
+            <a:ext cx="4023360" cy="1978214"/>
+          </a:xfrm>
+          <a:prstGeom prst="rect">
+            <a:avLst/>
+          </a:prstGeom>
         </p:spPr>
       </p:pic>
     </p:spTree>
@@ -7960,7 +8508,7 @@
         <p:spPr>
           <a:xfrm>
             <a:off x="667512" y="2432304"/>
-            <a:ext cx="2304288" cy="1051560"/>
+            <a:ext cx="2304288" cy="2103120"/>
           </a:xfrm>
           <a:prstGeom prst="rect">
             <a:avLst/>
@@ -7981,7 +8529,7 @@
                 </a:solidFill>
                 <a:latin typeface="Calibri"/>
               </a:rPr>
-              <a:t>Flask + SQLite, Windows Service</a:t>
+              <a:t>Flask API + SQLite DB.</a:t>
             </a:r>
           </a:p>
           <a:p>
@@ -7993,7 +8541,7 @@
                 </a:solidFill>
                 <a:latin typeface="Calibri"/>
               </a:rPr>
-              <a:t/>
+              <a:t>Runs as Windows Service on the server computer.</a:t>
             </a:r>
           </a:p>
           <a:p>
@@ -8005,7 +8553,7 @@
                 </a:solidFill>
                 <a:latin typeface="Calibri"/>
               </a:rPr>
-              <a:t/>
+              <a:t>Admin GUI included.</a:t>
             </a:r>
           </a:p>
         </p:txBody>
@@ -8172,7 +8720,7 @@
         <p:spPr>
           <a:xfrm>
             <a:off x="3502152" y="2432304"/>
-            <a:ext cx="2304288" cy="1051560"/>
+            <a:ext cx="2304288" cy="2103120"/>
           </a:xfrm>
           <a:prstGeom prst="rect">
             <a:avLst/>
@@ -8193,7 +8741,7 @@
                 </a:solidFill>
                 <a:latin typeface="Calibri"/>
               </a:rPr>
-              <a:t>Log assets in &amp; out</a:t>
+              <a:t>Used by Storekeeper User.</a:t>
             </a:r>
           </a:p>
           <a:p>
@@ -8205,7 +8753,7 @@
                 </a:solidFill>
                 <a:latin typeface="Calibri"/>
               </a:rPr>
-              <a:t/>
+              <a:t>Log assets in and out.</a:t>
             </a:r>
           </a:p>
           <a:p>
@@ -8217,7 +8765,7 @@
                 </a:solidFill>
                 <a:latin typeface="Calibri"/>
               </a:rPr>
-              <a:t/>
+              <a:t>Lookup, history, bulk scan, export.</a:t>
             </a:r>
           </a:p>
         </p:txBody>
@@ -8384,7 +8932,7 @@
         <p:spPr>
           <a:xfrm>
             <a:off x="6336792" y="2432304"/>
-            <a:ext cx="2304288" cy="1051560"/>
+            <a:ext cx="2304288" cy="2103120"/>
           </a:xfrm>
           <a:prstGeom prst="rect">
             <a:avLst/>
@@ -8405,7 +8953,7 @@
                 </a:solidFill>
                 <a:latin typeface="Calibri"/>
               </a:rPr>
-              <a:t>Confirm / reject via popup</a:t>
+              <a:t>Used by engineers.</a:t>
             </a:r>
           </a:p>
           <a:p>
@@ -8417,7 +8965,7 @@
                 </a:solidFill>
                 <a:latin typeface="Calibri"/>
               </a:rPr>
-              <a:t/>
+              <a:t>Receives transaction alerts.</a:t>
             </a:r>
           </a:p>
           <a:p>
@@ -8429,7 +8977,7 @@
                 </a:solidFill>
                 <a:latin typeface="Calibri"/>
               </a:rPr>
-              <a:t/>
+              <a:t>Confirm or reject in one click.</a:t>
             </a:r>
           </a:p>
         </p:txBody>
@@ -8450,24 +8998,12 @@
         </p:blipFill>
         <p:spPr>
           <a:xfrm>
-            <a:off x="1088136" y="2857500"/>
-            <a:ext cx="1463040" cy="1783080"/>
-          </a:xfrm>
-          <a:prstGeom prst="rect">
-            <a:avLst/>
-          </a:prstGeom>
-          <a:ln w="9525">
-            <a:solidFill>
-              <a:srgbClr val="C8CDD2"/>
-            </a:solidFill>
-          </a:ln>
-          <a:effectLst>
-            <a:outerShdw blurRad="38100" dist="19050" dir="5400000" rotWithShape="0">
-              <a:srgbClr val="000000">
-                <a:alpha val="24000"/>
-              </a:srgbClr>
-            </a:outerShdw>
-          </a:effectLst>
+            <a:off x="91440" y="1748790"/>
+            <a:ext cx="2377440" cy="2897824"/>
+          </a:xfrm>
+          <a:prstGeom prst="rect">
+            <a:avLst/>
+          </a:prstGeom>
         </p:spPr>
       </p:pic>
       <p:pic>
@@ -8486,24 +9022,12 @@
         </p:blipFill>
         <p:spPr>
           <a:xfrm>
-            <a:off x="3488436" y="2944368"/>
-            <a:ext cx="2331720" cy="1609344"/>
-          </a:xfrm>
-          <a:prstGeom prst="rect">
-            <a:avLst/>
-          </a:prstGeom>
-          <a:ln w="9525">
-            <a:solidFill>
-              <a:srgbClr val="C8CDD2"/>
-            </a:solidFill>
-          </a:ln>
-          <a:effectLst>
-            <a:outerShdw blurRad="38100" dist="19050" dir="5400000" rotWithShape="0">
-              <a:srgbClr val="000000">
-                <a:alpha val="24000"/>
-              </a:srgbClr>
-            </a:outerShdw>
-          </a:effectLst>
+            <a:off x="2651760" y="1543050"/>
+            <a:ext cx="6400800" cy="4412808"/>
+          </a:xfrm>
+          <a:prstGeom prst="rect">
+            <a:avLst/>
+          </a:prstGeom>
         </p:spPr>
       </p:pic>
       <p:pic>
@@ -8522,24 +9046,12 @@
         </p:blipFill>
         <p:spPr>
           <a:xfrm>
-            <a:off x="6323076" y="3172968"/>
-            <a:ext cx="2331720" cy="1152144"/>
-          </a:xfrm>
-          <a:prstGeom prst="rect">
-            <a:avLst/>
-          </a:prstGeom>
-          <a:ln w="9525">
-            <a:solidFill>
-              <a:srgbClr val="C8CDD2"/>
-            </a:solidFill>
-          </a:ln>
-          <a:effectLst>
-            <a:outerShdw blurRad="38100" dist="19050" dir="5400000" rotWithShape="0">
-              <a:srgbClr val="000000">
-                <a:alpha val="24000"/>
-              </a:srgbClr>
-            </a:outerShdw>
-          </a:effectLst>
+            <a:off x="6583680" y="3188970"/>
+            <a:ext cx="2468880" cy="1213904"/>
+          </a:xfrm>
+          <a:prstGeom prst="rect">
+            <a:avLst/>
+          </a:prstGeom>
         </p:spPr>
       </p:pic>
     </p:spTree>
@@ -9905,7 +10417,7 @@
                 </a:solidFill>
                 <a:latin typeface="Calibri"/>
               </a:rPr>
-              <a:t>Just 1 Field</a:t>
+              <a:t>1 field</a:t>
             </a:r>
           </a:p>
         </p:txBody>
@@ -9940,7 +10452,7 @@
                 </a:solidFill>
                 <a:latin typeface="Calibri"/>
               </a:rPr>
-              <a:t>Enter the Asset No. or Serial No.</a:t>
+              <a:t>Enter asset number or serial —</a:t>
             </a:r>
           </a:p>
         </p:txBody>
@@ -9975,7 +10487,430 @@
                 </a:solidFill>
                 <a:latin typeface="Calibri"/>
               </a:rPr>
-              <a:t>Type &amp; Model auto-fill — then lock.</a:t>
+              <a:t>Type AND Model fill in automatically and lock.</a:t>
+            </a:r>
+          </a:p>
+        </p:txBody>
+      </p:sp>
+      <p:sp>
+        <p:nvSpPr>
+          <p:cNvPr id="8" name="Rounded Rectangle 7"/>
+          <p:cNvSpPr/>
+          <p:nvPr/>
+        </p:nvSpPr>
+        <p:spPr>
+          <a:xfrm>
+            <a:off x="4754880" y="1051560"/>
+            <a:ext cx="3931920" cy="2788920"/>
+          </a:xfrm>
+          <a:prstGeom prst="roundRect">
+            <a:avLst/>
+          </a:prstGeom>
+          <a:solidFill>
+            <a:srgbClr val="F1F8FE"/>
+          </a:solidFill>
+          <a:ln>
+            <a:noFill/>
+          </a:ln>
+        </p:spPr>
+        <p:style>
+          <a:lnRef idx="1">
+            <a:schemeClr val="accent1"/>
+          </a:lnRef>
+          <a:fillRef idx="3">
+            <a:schemeClr val="accent1"/>
+          </a:fillRef>
+          <a:effectRef idx="2">
+            <a:schemeClr val="accent1"/>
+          </a:effectRef>
+          <a:fontRef idx="minor">
+            <a:schemeClr val="lt1"/>
+          </a:fontRef>
+        </p:style>
+        <p:txBody>
+          <a:bodyPr rtlCol="0" anchor="ctr"/>
+          <a:lstStyle/>
+          <a:p>
+            <a:pPr algn="ctr"/>
+          </a:p>
+        </p:txBody>
+      </p:sp>
+      <p:sp>
+        <p:nvSpPr>
+          <p:cNvPr id="9" name="TextBox 8"/>
+          <p:cNvSpPr txBox="1"/>
+          <p:nvPr/>
+        </p:nvSpPr>
+        <p:spPr>
+          <a:xfrm>
+            <a:off x="4956048" y="1261872"/>
+            <a:ext cx="3566160" cy="320040"/>
+          </a:xfrm>
+          <a:prstGeom prst="rect">
+            <a:avLst/>
+          </a:prstGeom>
+          <a:noFill/>
+        </p:spPr>
+        <p:txBody>
+          <a:bodyPr wrap="square" lIns="0" rIns="0" tIns="18288" bIns="18288">
+            <a:spAutoFit/>
+          </a:bodyPr>
+          <a:lstStyle/>
+          <a:p>
+            <a:pPr algn="l"/>
+            <a:r>
+              <a:rPr sz="1250" b="1" i="0">
+                <a:solidFill>
+                  <a:srgbClr val="1A1A2E"/>
+                </a:solidFill>
+                <a:latin typeface="Calibri"/>
+              </a:rPr>
+              <a:t>Asset Number:</a:t>
+            </a:r>
+          </a:p>
+        </p:txBody>
+      </p:sp>
+      <p:sp>
+        <p:nvSpPr>
+          <p:cNvPr id="10" name="Rounded Rectangle 9"/>
+          <p:cNvSpPr/>
+          <p:nvPr/>
+        </p:nvSpPr>
+        <p:spPr>
+          <a:xfrm>
+            <a:off x="4956048" y="1618488"/>
+            <a:ext cx="3566160" cy="347472"/>
+          </a:xfrm>
+          <a:prstGeom prst="roundRect">
+            <a:avLst/>
+          </a:prstGeom>
+          <a:solidFill>
+            <a:srgbClr val="FFFFFF"/>
+          </a:solidFill>
+          <a:ln w="10160">
+            <a:solidFill>
+              <a:srgbClr val="CBD5E1"/>
+            </a:solidFill>
+          </a:ln>
+        </p:spPr>
+        <p:style>
+          <a:lnRef idx="1">
+            <a:schemeClr val="accent1"/>
+          </a:lnRef>
+          <a:fillRef idx="3">
+            <a:schemeClr val="accent1"/>
+          </a:fillRef>
+          <a:effectRef idx="2">
+            <a:schemeClr val="accent1"/>
+          </a:effectRef>
+          <a:fontRef idx="minor">
+            <a:schemeClr val="lt1"/>
+          </a:fontRef>
+        </p:style>
+        <p:txBody>
+          <a:bodyPr rtlCol="0" anchor="ctr"/>
+          <a:lstStyle/>
+          <a:p>
+            <a:pPr algn="ctr"/>
+          </a:p>
+        </p:txBody>
+      </p:sp>
+      <p:sp>
+        <p:nvSpPr>
+          <p:cNvPr id="11" name="TextBox 10"/>
+          <p:cNvSpPr txBox="1"/>
+          <p:nvPr/>
+        </p:nvSpPr>
+        <p:spPr>
+          <a:xfrm>
+            <a:off x="5065776" y="1618488"/>
+            <a:ext cx="3383280" cy="347472"/>
+          </a:xfrm>
+          <a:prstGeom prst="rect">
+            <a:avLst/>
+          </a:prstGeom>
+          <a:noFill/>
+        </p:spPr>
+        <p:txBody>
+          <a:bodyPr wrap="square" lIns="0" rIns="0" tIns="18288" bIns="18288">
+            <a:spAutoFit/>
+          </a:bodyPr>
+          <a:lstStyle/>
+          <a:p>
+            <a:pPr algn="l"/>
+            <a:r>
+              <a:rPr sz="1350" b="1" i="0">
+                <a:solidFill>
+                  <a:srgbClr val="1A1A2E"/>
+                </a:solidFill>
+                <a:latin typeface="Calibri"/>
+              </a:rPr>
+              <a:t>1042</a:t>
+            </a:r>
+          </a:p>
+        </p:txBody>
+      </p:sp>
+      <p:sp>
+        <p:nvSpPr>
+          <p:cNvPr id="12" name="TextBox 11"/>
+          <p:cNvSpPr txBox="1"/>
+          <p:nvPr/>
+        </p:nvSpPr>
+        <p:spPr>
+          <a:xfrm>
+            <a:off x="4956048" y="2029968"/>
+            <a:ext cx="3566160" cy="292608"/>
+          </a:xfrm>
+          <a:prstGeom prst="rect">
+            <a:avLst/>
+          </a:prstGeom>
+          <a:noFill/>
+        </p:spPr>
+        <p:txBody>
+          <a:bodyPr wrap="square" lIns="0" rIns="0" tIns="18288" bIns="18288">
+            <a:spAutoFit/>
+          </a:bodyPr>
+          <a:lstStyle/>
+          <a:p>
+            <a:pPr algn="l"/>
+            <a:r>
+              <a:rPr sz="1250" b="1" i="0">
+                <a:solidFill>
+                  <a:srgbClr val="1A1A2E"/>
+                </a:solidFill>
+                <a:latin typeface="Calibri"/>
+              </a:rPr>
+              <a:t>Type:</a:t>
+            </a:r>
+          </a:p>
+        </p:txBody>
+      </p:sp>
+      <p:sp>
+        <p:nvSpPr>
+          <p:cNvPr id="13" name="Rounded Rectangle 12"/>
+          <p:cNvSpPr/>
+          <p:nvPr/>
+        </p:nvSpPr>
+        <p:spPr>
+          <a:xfrm>
+            <a:off x="4956048" y="2359152"/>
+            <a:ext cx="3566160" cy="347472"/>
+          </a:xfrm>
+          <a:prstGeom prst="roundRect">
+            <a:avLst/>
+          </a:prstGeom>
+          <a:solidFill>
+            <a:srgbClr val="F0FDF4"/>
+          </a:solidFill>
+          <a:ln w="10160">
+            <a:solidFill>
+              <a:srgbClr val="86EFAC"/>
+            </a:solidFill>
+          </a:ln>
+        </p:spPr>
+        <p:style>
+          <a:lnRef idx="1">
+            <a:schemeClr val="accent1"/>
+          </a:lnRef>
+          <a:fillRef idx="3">
+            <a:schemeClr val="accent1"/>
+          </a:fillRef>
+          <a:effectRef idx="2">
+            <a:schemeClr val="accent1"/>
+          </a:effectRef>
+          <a:fontRef idx="minor">
+            <a:schemeClr val="lt1"/>
+          </a:fontRef>
+        </p:style>
+        <p:txBody>
+          <a:bodyPr rtlCol="0" anchor="ctr"/>
+          <a:lstStyle/>
+          <a:p>
+            <a:pPr algn="ctr"/>
+          </a:p>
+        </p:txBody>
+      </p:sp>
+      <p:sp>
+        <p:nvSpPr>
+          <p:cNvPr id="14" name="TextBox 13"/>
+          <p:cNvSpPr txBox="1"/>
+          <p:nvPr/>
+        </p:nvSpPr>
+        <p:spPr>
+          <a:xfrm>
+            <a:off x="5065776" y="2359152"/>
+            <a:ext cx="3383280" cy="347472"/>
+          </a:xfrm>
+          <a:prstGeom prst="rect">
+            <a:avLst/>
+          </a:prstGeom>
+          <a:noFill/>
+        </p:spPr>
+        <p:txBody>
+          <a:bodyPr wrap="square" lIns="0" rIns="0" tIns="18288" bIns="18288">
+            <a:spAutoFit/>
+          </a:bodyPr>
+          <a:lstStyle/>
+          <a:p>
+            <a:pPr algn="l"/>
+            <a:r>
+              <a:rPr sz="1250" b="0" i="0">
+                <a:solidFill>
+                  <a:srgbClr val="16A34A"/>
+                </a:solidFill>
+                <a:latin typeface="Segoe UI Emoji"/>
+              </a:rPr>
+              <a:t>✅  Laptop  (auto)</a:t>
+            </a:r>
+          </a:p>
+        </p:txBody>
+      </p:sp>
+      <p:sp>
+        <p:nvSpPr>
+          <p:cNvPr id="15" name="TextBox 14"/>
+          <p:cNvSpPr txBox="1"/>
+          <p:nvPr/>
+        </p:nvSpPr>
+        <p:spPr>
+          <a:xfrm>
+            <a:off x="4956048" y="2779776"/>
+            <a:ext cx="3566160" cy="292608"/>
+          </a:xfrm>
+          <a:prstGeom prst="rect">
+            <a:avLst/>
+          </a:prstGeom>
+          <a:noFill/>
+        </p:spPr>
+        <p:txBody>
+          <a:bodyPr wrap="square" lIns="0" rIns="0" tIns="18288" bIns="18288">
+            <a:spAutoFit/>
+          </a:bodyPr>
+          <a:lstStyle/>
+          <a:p>
+            <a:pPr algn="l"/>
+            <a:r>
+              <a:rPr sz="1250" b="1" i="0">
+                <a:solidFill>
+                  <a:srgbClr val="1A1A2E"/>
+                </a:solidFill>
+                <a:latin typeface="Calibri"/>
+              </a:rPr>
+              <a:t>Model:</a:t>
+            </a:r>
+          </a:p>
+        </p:txBody>
+      </p:sp>
+      <p:sp>
+        <p:nvSpPr>
+          <p:cNvPr id="16" name="Rounded Rectangle 15"/>
+          <p:cNvSpPr/>
+          <p:nvPr/>
+        </p:nvSpPr>
+        <p:spPr>
+          <a:xfrm>
+            <a:off x="4956048" y="3127248"/>
+            <a:ext cx="3566160" cy="347472"/>
+          </a:xfrm>
+          <a:prstGeom prst="roundRect">
+            <a:avLst/>
+          </a:prstGeom>
+          <a:solidFill>
+            <a:srgbClr val="F0FDF4"/>
+          </a:solidFill>
+          <a:ln w="10160">
+            <a:solidFill>
+              <a:srgbClr val="86EFAC"/>
+            </a:solidFill>
+          </a:ln>
+        </p:spPr>
+        <p:style>
+          <a:lnRef idx="1">
+            <a:schemeClr val="accent1"/>
+          </a:lnRef>
+          <a:fillRef idx="3">
+            <a:schemeClr val="accent1"/>
+          </a:fillRef>
+          <a:effectRef idx="2">
+            <a:schemeClr val="accent1"/>
+          </a:effectRef>
+          <a:fontRef idx="minor">
+            <a:schemeClr val="lt1"/>
+          </a:fontRef>
+        </p:style>
+        <p:txBody>
+          <a:bodyPr rtlCol="0" anchor="ctr"/>
+          <a:lstStyle/>
+          <a:p>
+            <a:pPr algn="ctr"/>
+          </a:p>
+        </p:txBody>
+      </p:sp>
+      <p:sp>
+        <p:nvSpPr>
+          <p:cNvPr id="17" name="TextBox 16"/>
+          <p:cNvSpPr txBox="1"/>
+          <p:nvPr/>
+        </p:nvSpPr>
+        <p:spPr>
+          <a:xfrm>
+            <a:off x="5065776" y="3127248"/>
+            <a:ext cx="3383280" cy="347472"/>
+          </a:xfrm>
+          <a:prstGeom prst="rect">
+            <a:avLst/>
+          </a:prstGeom>
+          <a:noFill/>
+        </p:spPr>
+        <p:txBody>
+          <a:bodyPr wrap="square" lIns="0" rIns="0" tIns="18288" bIns="18288">
+            <a:spAutoFit/>
+          </a:bodyPr>
+          <a:lstStyle/>
+          <a:p>
+            <a:pPr algn="l"/>
+            <a:r>
+              <a:rPr sz="1250" b="0" i="0">
+                <a:solidFill>
+                  <a:srgbClr val="16A34A"/>
+                </a:solidFill>
+                <a:latin typeface="Segoe UI Emoji"/>
+              </a:rPr>
+              <a:t>✅  Dell Latitude 5530  (auto)</a:t>
+            </a:r>
+          </a:p>
+        </p:txBody>
+      </p:sp>
+      <p:sp>
+        <p:nvSpPr>
+          <p:cNvPr id="18" name="TextBox 17"/>
+          <p:cNvSpPr txBox="1"/>
+          <p:nvPr/>
+        </p:nvSpPr>
+        <p:spPr>
+          <a:xfrm>
+            <a:off x="4754880" y="3977639"/>
+            <a:ext cx="3931920" cy="320040"/>
+          </a:xfrm>
+          <a:prstGeom prst="rect">
+            <a:avLst/>
+          </a:prstGeom>
+          <a:noFill/>
+        </p:spPr>
+        <p:txBody>
+          <a:bodyPr wrap="square" lIns="0" rIns="0" tIns="18288" bIns="18288">
+            <a:spAutoFit/>
+          </a:bodyPr>
+          <a:lstStyle/>
+          <a:p>
+            <a:pPr algn="ctr"/>
+            <a:r>
+              <a:rPr sz="1100" b="0" i="1">
+                <a:solidFill>
+                  <a:srgbClr val="64748B"/>
+                </a:solidFill>
+                <a:latin typeface="Calibri"/>
+              </a:rPr>
+              <a:t>Powered by asset_lookup.xlsx — editable anytime</a:t>
             </a:r>
           </a:p>
         </p:txBody>
@@ -9996,24 +10931,12 @@
         </p:blipFill>
         <p:spPr>
           <a:xfrm>
-            <a:off x="4617720" y="1188720"/>
-            <a:ext cx="4206240" cy="2898648"/>
-          </a:xfrm>
-          <a:prstGeom prst="rect">
-            <a:avLst/>
-          </a:prstGeom>
-          <a:ln w="9525">
-            <a:solidFill>
-              <a:srgbClr val="C8CDD2"/>
-            </a:solidFill>
-          </a:ln>
-          <a:effectLst>
-            <a:outerShdw blurRad="38100" dist="19050" dir="5400000" rotWithShape="0">
-              <a:srgbClr val="000000">
-                <a:alpha val="24000"/>
-              </a:srgbClr>
-            </a:outerShdw>
-          </a:effectLst>
+            <a:off x="457200" y="1388745"/>
+            <a:ext cx="8229600" cy="5673610"/>
+          </a:xfrm>
+          <a:prstGeom prst="rect">
+            <a:avLst/>
+          </a:prstGeom>
         </p:spPr>
       </p:pic>
     </p:spTree>
@@ -10128,8 +11051,8 @@
         </p:nvSpPr>
         <p:spPr>
           <a:xfrm>
-            <a:off x="502920" y="1051560"/>
-            <a:ext cx="3977640" cy="3383280"/>
+            <a:off x="1645920" y="1051560"/>
+            <a:ext cx="5852160" cy="3383280"/>
           </a:xfrm>
           <a:prstGeom prst="roundRect">
             <a:avLst/>
@@ -10171,8 +11094,8 @@
         </p:nvSpPr>
         <p:spPr>
           <a:xfrm>
-            <a:off x="662940" y="1188720"/>
-            <a:ext cx="3657600" cy="457200"/>
+            <a:off x="1828800" y="1207008"/>
+            <a:ext cx="5486400" cy="457200"/>
           </a:xfrm>
           <a:prstGeom prst="rect">
             <a:avLst/>
@@ -10206,8 +11129,8 @@
         </p:nvSpPr>
         <p:spPr>
           <a:xfrm>
-            <a:off x="1394460" y="1645920"/>
-            <a:ext cx="2194560" cy="777240"/>
+            <a:off x="3474720" y="1755648"/>
+            <a:ext cx="2194560" cy="914400"/>
           </a:xfrm>
           <a:prstGeom prst="roundRect">
             <a:avLst/>
@@ -10249,8 +11172,8 @@
         </p:nvSpPr>
         <p:spPr>
           <a:xfrm>
-            <a:off x="1394460" y="1645920"/>
-            <a:ext cx="2194560" cy="777240"/>
+            <a:off x="3474720" y="1755648"/>
+            <a:ext cx="2194560" cy="914400"/>
           </a:xfrm>
           <a:prstGeom prst="rect">
             <a:avLst/>
@@ -10284,8 +11207,8 @@
         </p:nvSpPr>
         <p:spPr>
           <a:xfrm>
-            <a:off x="662940" y="2560320"/>
-            <a:ext cx="3657600" cy="594360"/>
+            <a:off x="1828800" y="2816352"/>
+            <a:ext cx="5486400" cy="594360"/>
           </a:xfrm>
           <a:prstGeom prst="rect">
             <a:avLst/>
@@ -10331,8 +11254,8 @@
         </p:nvSpPr>
         <p:spPr>
           <a:xfrm>
-            <a:off x="868680" y="3246120"/>
-            <a:ext cx="3108960" cy="457200"/>
+            <a:off x="1920240" y="3520440"/>
+            <a:ext cx="2743200" cy="594360"/>
           </a:xfrm>
           <a:prstGeom prst="roundRect">
             <a:avLst/>
@@ -10376,8 +11299,8 @@
         </p:nvSpPr>
         <p:spPr>
           <a:xfrm>
-            <a:off x="960120" y="3246120"/>
-            <a:ext cx="2926080" cy="457200"/>
+            <a:off x="2011680" y="3520440"/>
+            <a:ext cx="2560320" cy="594360"/>
           </a:xfrm>
           <a:prstGeom prst="rect">
             <a:avLst/>
@@ -10411,8 +11334,8 @@
         </p:nvSpPr>
         <p:spPr>
           <a:xfrm>
-            <a:off x="868680" y="3794760"/>
-            <a:ext cx="3108960" cy="457200"/>
+            <a:off x="4846320" y="3520440"/>
+            <a:ext cx="2743200" cy="594360"/>
           </a:xfrm>
           <a:prstGeom prst="roundRect">
             <a:avLst/>
@@ -10456,8 +11379,8 @@
         </p:nvSpPr>
         <p:spPr>
           <a:xfrm>
-            <a:off x="960120" y="3794760"/>
-            <a:ext cx="2926080" cy="457200"/>
+            <a:off x="4937760" y="3520440"/>
+            <a:ext cx="2560320" cy="594360"/>
           </a:xfrm>
           <a:prstGeom prst="rect">
             <a:avLst/>
@@ -10499,24 +11422,12 @@
         </p:blipFill>
         <p:spPr>
           <a:xfrm>
-            <a:off x="4617720" y="1325880"/>
-            <a:ext cx="4206240" cy="2898648"/>
-          </a:xfrm>
-          <a:prstGeom prst="rect">
-            <a:avLst/>
-          </a:prstGeom>
-          <a:ln w="9525">
-            <a:solidFill>
-              <a:srgbClr val="C8CDD2"/>
-            </a:solidFill>
-          </a:ln>
-          <a:effectLst>
-            <a:outerShdw blurRad="38100" dist="19050" dir="5400000" rotWithShape="0">
-              <a:srgbClr val="000000">
-                <a:alpha val="24000"/>
-              </a:srgbClr>
-            </a:outerShdw>
-          </a:effectLst>
+            <a:off x="457200" y="1388745"/>
+            <a:ext cx="8229600" cy="5673610"/>
+          </a:xfrm>
+          <a:prstGeom prst="rect">
+            <a:avLst/>
+          </a:prstGeom>
         </p:spPr>
       </p:pic>
     </p:spTree>
@@ -11023,6 +11934,267 @@
           </a:p>
         </p:txBody>
       </p:sp>
+      <p:sp>
+        <p:nvSpPr>
+          <p:cNvPr id="14" name="Rounded Rectangle 13"/>
+          <p:cNvSpPr/>
+          <p:nvPr/>
+        </p:nvSpPr>
+        <p:spPr>
+          <a:xfrm>
+            <a:off x="4828032" y="1024128"/>
+            <a:ext cx="3858768" cy="3730752"/>
+          </a:xfrm>
+          <a:prstGeom prst="roundRect">
+            <a:avLst/>
+          </a:prstGeom>
+          <a:solidFill>
+            <a:srgbClr val="E6F3FC"/>
+          </a:solidFill>
+          <a:ln>
+            <a:noFill/>
+          </a:ln>
+        </p:spPr>
+        <p:style>
+          <a:lnRef idx="1">
+            <a:schemeClr val="accent1"/>
+          </a:lnRef>
+          <a:fillRef idx="3">
+            <a:schemeClr val="accent1"/>
+          </a:fillRef>
+          <a:effectRef idx="2">
+            <a:schemeClr val="accent1"/>
+          </a:effectRef>
+          <a:fontRef idx="minor">
+            <a:schemeClr val="lt1"/>
+          </a:fontRef>
+        </p:style>
+        <p:txBody>
+          <a:bodyPr rtlCol="0" anchor="ctr"/>
+          <a:lstStyle/>
+          <a:p>
+            <a:pPr algn="ctr"/>
+          </a:p>
+        </p:txBody>
+      </p:sp>
+      <p:sp>
+        <p:nvSpPr>
+          <p:cNvPr id="15" name="TextBox 14"/>
+          <p:cNvSpPr txBox="1"/>
+          <p:nvPr/>
+        </p:nvSpPr>
+        <p:spPr>
+          <a:xfrm>
+            <a:off x="5029200" y="1207008"/>
+            <a:ext cx="3474720" cy="384048"/>
+          </a:xfrm>
+          <a:prstGeom prst="rect">
+            <a:avLst/>
+          </a:prstGeom>
+          <a:noFill/>
+        </p:spPr>
+        <p:txBody>
+          <a:bodyPr wrap="square" lIns="0" rIns="0" tIns="18288" bIns="18288">
+            <a:spAutoFit/>
+          </a:bodyPr>
+          <a:lstStyle/>
+          <a:p>
+            <a:pPr algn="l"/>
+            <a:r>
+              <a:rPr sz="1450" b="1" i="0">
+                <a:solidFill>
+                  <a:srgbClr val="1A1A2E"/>
+                </a:solidFill>
+                <a:latin typeface="Calibri"/>
+              </a:rPr>
+              <a:t>Charts included:</a:t>
+            </a:r>
+          </a:p>
+        </p:txBody>
+      </p:sp>
+      <p:sp>
+        <p:nvSpPr>
+          <p:cNvPr id="16" name="TextBox 15"/>
+          <p:cNvSpPr txBox="1"/>
+          <p:nvPr/>
+        </p:nvSpPr>
+        <p:spPr>
+          <a:xfrm>
+            <a:off x="5029200" y="1719072"/>
+            <a:ext cx="3474720" cy="384048"/>
+          </a:xfrm>
+          <a:prstGeom prst="rect">
+            <a:avLst/>
+          </a:prstGeom>
+          <a:noFill/>
+        </p:spPr>
+        <p:txBody>
+          <a:bodyPr wrap="square" lIns="0" rIns="0" tIns="18288" bIns="18288">
+            <a:spAutoFit/>
+          </a:bodyPr>
+          <a:lstStyle/>
+          <a:p>
+            <a:pPr algn="l"/>
+            <a:r>
+              <a:rPr sz="1350" b="0" i="0">
+                <a:solidFill>
+                  <a:srgbClr val="1A1A2E"/>
+                </a:solidFill>
+                <a:latin typeface="Calibri"/>
+              </a:rPr>
+              <a:t>•  Status bar chart</a:t>
+            </a:r>
+          </a:p>
+        </p:txBody>
+      </p:sp>
+      <p:sp>
+        <p:nvSpPr>
+          <p:cNvPr id="17" name="TextBox 16"/>
+          <p:cNvSpPr txBox="1"/>
+          <p:nvPr/>
+        </p:nvSpPr>
+        <p:spPr>
+          <a:xfrm>
+            <a:off x="5029200" y="2194560"/>
+            <a:ext cx="3474720" cy="384048"/>
+          </a:xfrm>
+          <a:prstGeom prst="rect">
+            <a:avLst/>
+          </a:prstGeom>
+          <a:noFill/>
+        </p:spPr>
+        <p:txBody>
+          <a:bodyPr wrap="square" lIns="0" rIns="0" tIns="18288" bIns="18288">
+            <a:spAutoFit/>
+          </a:bodyPr>
+          <a:lstStyle/>
+          <a:p>
+            <a:pPr algn="l"/>
+            <a:r>
+              <a:rPr sz="1350" b="0" i="0">
+                <a:solidFill>
+                  <a:srgbClr val="1A1A2E"/>
+                </a:solidFill>
+                <a:latin typeface="Calibri"/>
+              </a:rPr>
+              <a:t>•  Per-engineer bar chart</a:t>
+            </a:r>
+          </a:p>
+        </p:txBody>
+      </p:sp>
+      <p:sp>
+        <p:nvSpPr>
+          <p:cNvPr id="18" name="TextBox 17"/>
+          <p:cNvSpPr txBox="1"/>
+          <p:nvPr/>
+        </p:nvSpPr>
+        <p:spPr>
+          <a:xfrm>
+            <a:off x="5029200" y="2670048"/>
+            <a:ext cx="3474720" cy="384048"/>
+          </a:xfrm>
+          <a:prstGeom prst="rect">
+            <a:avLst/>
+          </a:prstGeom>
+          <a:noFill/>
+        </p:spPr>
+        <p:txBody>
+          <a:bodyPr wrap="square" lIns="0" rIns="0" tIns="18288" bIns="18288">
+            <a:spAutoFit/>
+          </a:bodyPr>
+          <a:lstStyle/>
+          <a:p>
+            <a:pPr algn="l"/>
+            <a:r>
+              <a:rPr sz="1350" b="0" i="0">
+                <a:solidFill>
+                  <a:srgbClr val="1A1A2E"/>
+                </a:solidFill>
+                <a:latin typeface="Calibri"/>
+              </a:rPr>
+              <a:t>•  In vs Out pie chart</a:t>
+            </a:r>
+          </a:p>
+        </p:txBody>
+      </p:sp>
+      <p:sp>
+        <p:nvSpPr>
+          <p:cNvPr id="19" name="Rectangle 18"/>
+          <p:cNvSpPr/>
+          <p:nvPr/>
+        </p:nvSpPr>
+        <p:spPr>
+          <a:xfrm>
+            <a:off x="5029200" y="3218688"/>
+            <a:ext cx="3474720" cy="27432"/>
+          </a:xfrm>
+          <a:prstGeom prst="rect">
+            <a:avLst/>
+          </a:prstGeom>
+          <a:solidFill>
+            <a:srgbClr val="CBD5E1"/>
+          </a:solidFill>
+          <a:ln>
+            <a:noFill/>
+          </a:ln>
+        </p:spPr>
+        <p:style>
+          <a:lnRef idx="1">
+            <a:schemeClr val="accent1"/>
+          </a:lnRef>
+          <a:fillRef idx="3">
+            <a:schemeClr val="accent1"/>
+          </a:fillRef>
+          <a:effectRef idx="2">
+            <a:schemeClr val="accent1"/>
+          </a:effectRef>
+          <a:fontRef idx="minor">
+            <a:schemeClr val="lt1"/>
+          </a:fontRef>
+        </p:style>
+        <p:txBody>
+          <a:bodyPr rtlCol="0" anchor="ctr"/>
+          <a:lstStyle/>
+          <a:p>
+            <a:pPr algn="ctr"/>
+          </a:p>
+        </p:txBody>
+      </p:sp>
+      <p:sp>
+        <p:nvSpPr>
+          <p:cNvPr id="20" name="TextBox 19"/>
+          <p:cNvSpPr txBox="1"/>
+          <p:nvPr/>
+        </p:nvSpPr>
+        <p:spPr>
+          <a:xfrm>
+            <a:off x="5029200" y="3337560"/>
+            <a:ext cx="3474720" cy="347472"/>
+          </a:xfrm>
+          <a:prstGeom prst="rect">
+            <a:avLst/>
+          </a:prstGeom>
+          <a:noFill/>
+        </p:spPr>
+        <p:txBody>
+          <a:bodyPr wrap="square" lIns="0" rIns="0" tIns="18288" bIns="18288">
+            <a:spAutoFit/>
+          </a:bodyPr>
+          <a:lstStyle/>
+          <a:p>
+            <a:pPr algn="l"/>
+            <a:r>
+              <a:rPr sz="1200" b="0" i="1">
+                <a:solidFill>
+                  <a:srgbClr val="64748B"/>
+                </a:solidFill>
+                <a:latin typeface="Calibri"/>
+              </a:rPr>
+              <a:t>Includes the new Model column</a:t>
+            </a:r>
+          </a:p>
+        </p:txBody>
+      </p:sp>
       <p:pic>
         <p:nvPicPr>
           <p:cNvPr id="21" name="Picture 20" descr="06_storekeeper_history.png"/>
@@ -11039,24 +12211,12 @@
         </p:blipFill>
         <p:spPr>
           <a:xfrm>
-            <a:off x="4572000" y="1362456"/>
-            <a:ext cx="4297680" cy="2962656"/>
-          </a:xfrm>
-          <a:prstGeom prst="rect">
-            <a:avLst/>
-          </a:prstGeom>
-          <a:ln w="9525">
-            <a:solidFill>
-              <a:srgbClr val="C8CDD2"/>
-            </a:solidFill>
-          </a:ln>
-          <a:effectLst>
-            <a:outerShdw blurRad="38100" dist="19050" dir="5400000" rotWithShape="0">
-              <a:srgbClr val="000000">
-                <a:alpha val="24000"/>
-              </a:srgbClr>
-            </a:outerShdw>
-          </a:effectLst>
+            <a:off x="457200" y="1388745"/>
+            <a:ext cx="8229600" cy="5673610"/>
+          </a:xfrm>
+          <a:prstGeom prst="rect">
+            <a:avLst/>
+          </a:prstGeom>
         </p:spPr>
       </p:pic>
     </p:spTree>
@@ -11115,7 +12275,7 @@
                 </a:solidFill>
                 <a:latin typeface="Calibri"/>
               </a:rPr>
-              <a:t>Key Features</a:t>
+              <a:t>Admin Has Full Control</a:t>
             </a:r>
           </a:p>
         </p:txBody>
@@ -11276,7 +12436,7 @@
               <a:rPr sz="1600" b="0" i="0">
                 <a:latin typeface="Segoe UI Emoji"/>
               </a:rPr>
-              <a:t>📝</a:t>
+              <a:t>🔐</a:t>
             </a:r>
           </a:p>
         </p:txBody>
@@ -11311,7 +12471,7 @@
                 </a:solidFill>
                 <a:latin typeface="Calibri"/>
               </a:rPr>
-              <a:t>Auto-Fill</a:t>
+              <a:t>Change Password</a:t>
             </a:r>
           </a:p>
         </p:txBody>
@@ -11346,7 +12506,7 @@
                 </a:solidFill>
                 <a:latin typeface="Calibri"/>
               </a:rPr>
-              <a:t>Type asset or serial,</a:t>
+              <a:t>SHA-256 protected.</a:t>
             </a:r>
           </a:p>
           <a:p>
@@ -11358,7 +12518,7 @@
                 </a:solidFill>
                 <a:latin typeface="Calibri"/>
               </a:rPr>
-              <a:t>type &amp; model fill in.</a:t>
+              <a:t>Update anytime from</a:t>
             </a:r>
           </a:p>
           <a:p>
@@ -11370,7 +12530,7 @@
                 </a:solidFill>
                 <a:latin typeface="Calibri"/>
               </a:rPr>
-              <a:t/>
+              <a:t>the server GUI.</a:t>
             </a:r>
           </a:p>
         </p:txBody>
@@ -11488,7 +12648,7 @@
               <a:rPr sz="1600" b="0" i="0">
                 <a:latin typeface="Segoe UI Emoji"/>
               </a:rPr>
-              <a:t>🛡</a:t>
+              <a:t>🌐</a:t>
             </a:r>
           </a:p>
         </p:txBody>
@@ -11523,7 +12683,7 @@
                 </a:solidFill>
                 <a:latin typeface="Calibri"/>
               </a:rPr>
-              <a:t>Duplicate Guard</a:t>
+              <a:t>Change Host / Port</a:t>
             </a:r>
           </a:p>
         </p:txBody>
@@ -11558,7 +12718,7 @@
                 </a:solidFill>
                 <a:latin typeface="Calibri"/>
               </a:rPr>
-              <a:t>Server blocks</a:t>
+              <a:t>Move to any port.</a:t>
             </a:r>
           </a:p>
           <a:p>
@@ -11570,7 +12730,7 @@
                 </a:solidFill>
                 <a:latin typeface="Calibri"/>
               </a:rPr>
-              <a:t>re-submission (409).</a:t>
+              <a:t>Default is 80. Saved to</a:t>
             </a:r>
           </a:p>
           <a:p>
@@ -11582,7 +12742,7 @@
                 </a:solidFill>
                 <a:latin typeface="Calibri"/>
               </a:rPr>
-              <a:t/>
+              <a:t>config, applied on restart.</a:t>
             </a:r>
           </a:p>
         </p:txBody>
@@ -11700,7 +12860,7 @@
               <a:rPr sz="1600" b="0" i="0">
                 <a:latin typeface="Segoe UI Emoji"/>
               </a:rPr>
-              <a:t>📊</a:t>
+              <a:t>📋</a:t>
             </a:r>
           </a:p>
         </p:txBody>
@@ -11735,7 +12895,7 @@
                 </a:solidFill>
                 <a:latin typeface="Calibri"/>
               </a:rPr>
-              <a:t>Excel Export</a:t>
+              <a:t>Update Lookup File</a:t>
             </a:r>
           </a:p>
         </p:txBody>
@@ -11770,7 +12930,7 @@
                 </a:solidFill>
                 <a:latin typeface="Calibri"/>
               </a:rPr>
-              <a:t>Color-coded history,</a:t>
+              <a:t>Edit asset_lookup.xlsx directly.</a:t>
             </a:r>
           </a:p>
           <a:p>
@@ -11782,7 +12942,7 @@
                 </a:solidFill>
                 <a:latin typeface="Calibri"/>
               </a:rPr>
-              <a:t>summary + charts.</a:t>
+              <a:t>Changes apply immediately,</a:t>
             </a:r>
           </a:p>
           <a:p>
@@ -11794,7 +12954,7 @@
                 </a:solidFill>
                 <a:latin typeface="Calibri"/>
               </a:rPr>
-              <a:t/>
+              <a:t>no restart needed.</a:t>
             </a:r>
           </a:p>
         </p:txBody>
@@ -11912,7 +13072,7 @@
               <a:rPr sz="1600" b="0" i="0">
                 <a:latin typeface="Segoe UI Emoji"/>
               </a:rPr>
-              <a:t>🔐</a:t>
+              <a:t>🗑</a:t>
             </a:r>
           </a:p>
         </p:txBody>
@@ -11947,7 +13107,7 @@
                 </a:solidFill>
                 <a:latin typeface="Calibri"/>
               </a:rPr>
-              <a:t>Admin &amp; Security</a:t>
+              <a:t>Clear All Records</a:t>
             </a:r>
           </a:p>
         </p:txBody>
@@ -11982,7 +13142,7 @@
                 </a:solidFill>
                 <a:latin typeface="Calibri"/>
               </a:rPr>
-              <a:t>Password, port, SSL,</a:t>
+              <a:t>Delete all records from the database.</a:t>
             </a:r>
           </a:p>
           <a:p>
@@ -11994,7 +13154,7 @@
                 </a:solidFill>
                 <a:latin typeface="Calibri"/>
               </a:rPr>
-              <a:t>clear records.</a:t>
+              <a:t>Admin password + confirmation required.</a:t>
             </a:r>
           </a:p>
           <a:p>
@@ -12007,6 +13167,1802 @@
                 <a:latin typeface="Calibri"/>
               </a:rPr>
               <a:t/>
+            </a:r>
+          </a:p>
+        </p:txBody>
+      </p:sp>
+    </p:spTree>
+  </p:cSld>
+  <p:clrMapOvr>
+    <a:masterClrMapping/>
+  </p:clrMapOvr>
+</p:sld>
+</file>
+
+<file path=ppt/slides/slide9.xml><?xml version="1.0" encoding="utf-8"?>
+<p:sld xmlns:a="http://schemas.openxmlformats.org/drawingml/2006/main" xmlns:p="http://schemas.openxmlformats.org/presentationml/2006/main" xmlns:r="http://schemas.openxmlformats.org/officeDocument/2006/relationships">
+  <p:cSld>
+    <p:bg>
+      <p:bgPr>
+        <a:solidFill>
+          <a:srgbClr val="0F2137"/>
+        </a:solidFill>
+        <a:effectLst/>
+      </p:bgPr>
+    </p:bg>
+    <p:spTree>
+      <p:nvGrpSpPr>
+        <p:cNvPr id="1" name=""/>
+        <p:cNvGrpSpPr/>
+        <p:nvPr/>
+      </p:nvGrpSpPr>
+      <p:grpSpPr/>
+      <p:sp>
+        <p:nvSpPr>
+          <p:cNvPr id="2" name="TextBox 1"/>
+          <p:cNvSpPr txBox="1"/>
+          <p:nvPr/>
+        </p:nvSpPr>
+        <p:spPr>
+          <a:xfrm>
+            <a:off x="502920" y="228600"/>
+            <a:ext cx="8229600" cy="594360"/>
+          </a:xfrm>
+          <a:prstGeom prst="rect">
+            <a:avLst/>
+          </a:prstGeom>
+          <a:noFill/>
+        </p:spPr>
+        <p:txBody>
+          <a:bodyPr wrap="square" lIns="0" rIns="0" tIns="18288" bIns="18288">
+            <a:spAutoFit/>
+          </a:bodyPr>
+          <a:lstStyle/>
+          <a:p>
+            <a:pPr algn="l"/>
+            <a:r>
+              <a:rPr sz="3000" b="1" i="0">
+                <a:solidFill>
+                  <a:srgbClr val="FFFFFF"/>
+                </a:solidFill>
+                <a:latin typeface="Calibri"/>
+              </a:rPr>
+              <a:t>What's New</a:t>
+            </a:r>
+          </a:p>
+        </p:txBody>
+      </p:sp>
+      <p:sp>
+        <p:nvSpPr>
+          <p:cNvPr id="3" name="Rectangle 2"/>
+          <p:cNvSpPr/>
+          <p:nvPr/>
+        </p:nvSpPr>
+        <p:spPr>
+          <a:xfrm>
+            <a:off x="502920" y="868680"/>
+            <a:ext cx="8138160" cy="27432"/>
+          </a:xfrm>
+          <a:prstGeom prst="rect">
+            <a:avLst/>
+          </a:prstGeom>
+          <a:solidFill>
+            <a:srgbClr val="1E4A7A"/>
+          </a:solidFill>
+          <a:ln>
+            <a:noFill/>
+          </a:ln>
+        </p:spPr>
+        <p:style>
+          <a:lnRef idx="1">
+            <a:schemeClr val="accent1"/>
+          </a:lnRef>
+          <a:fillRef idx="3">
+            <a:schemeClr val="accent1"/>
+          </a:fillRef>
+          <a:effectRef idx="2">
+            <a:schemeClr val="accent1"/>
+          </a:effectRef>
+          <a:fontRef idx="minor">
+            <a:schemeClr val="lt1"/>
+          </a:fontRef>
+        </p:style>
+        <p:txBody>
+          <a:bodyPr rtlCol="0" anchor="ctr"/>
+          <a:lstStyle/>
+          <a:p>
+            <a:pPr algn="ctr"/>
+          </a:p>
+        </p:txBody>
+      </p:sp>
+      <p:sp>
+        <p:nvSpPr>
+          <p:cNvPr id="4" name="Rounded Rectangle 3"/>
+          <p:cNvSpPr/>
+          <p:nvPr/>
+        </p:nvSpPr>
+        <p:spPr>
+          <a:xfrm>
+            <a:off x="502920" y="1005840"/>
+            <a:ext cx="4023360" cy="1143000"/>
+          </a:xfrm>
+          <a:prstGeom prst="roundRect">
+            <a:avLst/>
+          </a:prstGeom>
+          <a:solidFill>
+            <a:srgbClr val="173455"/>
+          </a:solidFill>
+          <a:ln>
+            <a:noFill/>
+          </a:ln>
+        </p:spPr>
+        <p:style>
+          <a:lnRef idx="1">
+            <a:schemeClr val="accent1"/>
+          </a:lnRef>
+          <a:fillRef idx="3">
+            <a:schemeClr val="accent1"/>
+          </a:fillRef>
+          <a:effectRef idx="2">
+            <a:schemeClr val="accent1"/>
+          </a:effectRef>
+          <a:fontRef idx="minor">
+            <a:schemeClr val="lt1"/>
+          </a:fontRef>
+        </p:style>
+        <p:txBody>
+          <a:bodyPr rtlCol="0" anchor="ctr"/>
+          <a:lstStyle/>
+          <a:p>
+            <a:pPr algn="ctr"/>
+          </a:p>
+        </p:txBody>
+      </p:sp>
+      <p:sp>
+        <p:nvSpPr>
+          <p:cNvPr id="5" name="Oval 4"/>
+          <p:cNvSpPr/>
+          <p:nvPr/>
+        </p:nvSpPr>
+        <p:spPr>
+          <a:xfrm>
+            <a:off x="667512" y="1353312"/>
+            <a:ext cx="438912" cy="438912"/>
+          </a:xfrm>
+          <a:prstGeom prst="ellipse">
+            <a:avLst/>
+          </a:prstGeom>
+          <a:solidFill>
+            <a:srgbClr val="0078D4"/>
+          </a:solidFill>
+          <a:ln>
+            <a:noFill/>
+          </a:ln>
+        </p:spPr>
+        <p:style>
+          <a:lnRef idx="1">
+            <a:schemeClr val="accent1"/>
+          </a:lnRef>
+          <a:fillRef idx="3">
+            <a:schemeClr val="accent1"/>
+          </a:fillRef>
+          <a:effectRef idx="2">
+            <a:schemeClr val="accent1"/>
+          </a:effectRef>
+          <a:fontRef idx="minor">
+            <a:schemeClr val="lt1"/>
+          </a:fontRef>
+        </p:style>
+        <p:txBody>
+          <a:bodyPr rtlCol="0" anchor="ctr"/>
+          <a:lstStyle/>
+          <a:p>
+            <a:pPr algn="ctr"/>
+          </a:p>
+        </p:txBody>
+      </p:sp>
+      <p:sp>
+        <p:nvSpPr>
+          <p:cNvPr id="6" name="TextBox 5"/>
+          <p:cNvSpPr txBox="1"/>
+          <p:nvPr/>
+        </p:nvSpPr>
+        <p:spPr>
+          <a:xfrm>
+            <a:off x="667512" y="1344168"/>
+            <a:ext cx="438912" cy="438912"/>
+          </a:xfrm>
+          <a:prstGeom prst="rect">
+            <a:avLst/>
+          </a:prstGeom>
+          <a:noFill/>
+        </p:spPr>
+        <p:txBody>
+          <a:bodyPr wrap="square" lIns="0" rIns="0" tIns="18288" bIns="18288">
+            <a:spAutoFit/>
+          </a:bodyPr>
+          <a:lstStyle/>
+          <a:p>
+            <a:pPr algn="ctr"/>
+            <a:r>
+              <a:rPr sz="1400" b="0" i="0">
+                <a:latin typeface="Segoe UI Emoji"/>
+              </a:rPr>
+              <a:t>🆕</a:t>
+            </a:r>
+          </a:p>
+        </p:txBody>
+      </p:sp>
+      <p:sp>
+        <p:nvSpPr>
+          <p:cNvPr id="7" name="TextBox 6"/>
+          <p:cNvSpPr txBox="1"/>
+          <p:nvPr/>
+        </p:nvSpPr>
+        <p:spPr>
+          <a:xfrm>
+            <a:off x="1234440" y="1097280"/>
+            <a:ext cx="3154680" cy="384048"/>
+          </a:xfrm>
+          <a:prstGeom prst="rect">
+            <a:avLst/>
+          </a:prstGeom>
+          <a:noFill/>
+        </p:spPr>
+        <p:txBody>
+          <a:bodyPr wrap="square" lIns="0" rIns="0" tIns="18288" bIns="18288">
+            <a:spAutoFit/>
+          </a:bodyPr>
+          <a:lstStyle/>
+          <a:p>
+            <a:pPr algn="l"/>
+            <a:r>
+              <a:rPr sz="1350" b="1" i="0">
+                <a:solidFill>
+                  <a:srgbClr val="FFFFFF"/>
+                </a:solidFill>
+                <a:latin typeface="Calibri"/>
+              </a:rPr>
+              <a:t>Asset Model Field</a:t>
+            </a:r>
+          </a:p>
+        </p:txBody>
+      </p:sp>
+      <p:sp>
+        <p:nvSpPr>
+          <p:cNvPr id="8" name="TextBox 7"/>
+          <p:cNvSpPr txBox="1"/>
+          <p:nvPr/>
+        </p:nvSpPr>
+        <p:spPr>
+          <a:xfrm>
+            <a:off x="1234440" y="1508760"/>
+            <a:ext cx="3154680" cy="530352"/>
+          </a:xfrm>
+          <a:prstGeom prst="rect">
+            <a:avLst/>
+          </a:prstGeom>
+          <a:noFill/>
+        </p:spPr>
+        <p:txBody>
+          <a:bodyPr wrap="square" lIns="0" rIns="0" tIns="18288" bIns="18288">
+            <a:spAutoFit/>
+          </a:bodyPr>
+          <a:lstStyle/>
+          <a:p>
+            <a:pPr algn="l"/>
+            <a:r>
+              <a:rPr sz="1200" b="0" i="0">
+                <a:solidFill>
+                  <a:srgbClr val="A8C8E8"/>
+                </a:solidFill>
+                <a:latin typeface="Calibri"/>
+              </a:rPr>
+              <a:t>Stored, displayed, exported</a:t>
+            </a:r>
+          </a:p>
+        </p:txBody>
+      </p:sp>
+      <p:sp>
+        <p:nvSpPr>
+          <p:cNvPr id="9" name="Rounded Rectangle 8"/>
+          <p:cNvSpPr/>
+          <p:nvPr/>
+        </p:nvSpPr>
+        <p:spPr>
+          <a:xfrm>
+            <a:off x="4846320" y="1005840"/>
+            <a:ext cx="4023360" cy="1143000"/>
+          </a:xfrm>
+          <a:prstGeom prst="roundRect">
+            <a:avLst/>
+          </a:prstGeom>
+          <a:solidFill>
+            <a:srgbClr val="173455"/>
+          </a:solidFill>
+          <a:ln>
+            <a:noFill/>
+          </a:ln>
+        </p:spPr>
+        <p:style>
+          <a:lnRef idx="1">
+            <a:schemeClr val="accent1"/>
+          </a:lnRef>
+          <a:fillRef idx="3">
+            <a:schemeClr val="accent1"/>
+          </a:fillRef>
+          <a:effectRef idx="2">
+            <a:schemeClr val="accent1"/>
+          </a:effectRef>
+          <a:fontRef idx="minor">
+            <a:schemeClr val="lt1"/>
+          </a:fontRef>
+        </p:style>
+        <p:txBody>
+          <a:bodyPr rtlCol="0" anchor="ctr"/>
+          <a:lstStyle/>
+          <a:p>
+            <a:pPr algn="ctr"/>
+          </a:p>
+        </p:txBody>
+      </p:sp>
+      <p:sp>
+        <p:nvSpPr>
+          <p:cNvPr id="10" name="Oval 9"/>
+          <p:cNvSpPr/>
+          <p:nvPr/>
+        </p:nvSpPr>
+        <p:spPr>
+          <a:xfrm>
+            <a:off x="5010912" y="1353312"/>
+            <a:ext cx="438912" cy="438912"/>
+          </a:xfrm>
+          <a:prstGeom prst="ellipse">
+            <a:avLst/>
+          </a:prstGeom>
+          <a:solidFill>
+            <a:srgbClr val="0078D4"/>
+          </a:solidFill>
+          <a:ln>
+            <a:noFill/>
+          </a:ln>
+        </p:spPr>
+        <p:style>
+          <a:lnRef idx="1">
+            <a:schemeClr val="accent1"/>
+          </a:lnRef>
+          <a:fillRef idx="3">
+            <a:schemeClr val="accent1"/>
+          </a:fillRef>
+          <a:effectRef idx="2">
+            <a:schemeClr val="accent1"/>
+          </a:effectRef>
+          <a:fontRef idx="minor">
+            <a:schemeClr val="lt1"/>
+          </a:fontRef>
+        </p:style>
+        <p:txBody>
+          <a:bodyPr rtlCol="0" anchor="ctr"/>
+          <a:lstStyle/>
+          <a:p>
+            <a:pPr algn="ctr"/>
+          </a:p>
+        </p:txBody>
+      </p:sp>
+      <p:sp>
+        <p:nvSpPr>
+          <p:cNvPr id="11" name="TextBox 10"/>
+          <p:cNvSpPr txBox="1"/>
+          <p:nvPr/>
+        </p:nvSpPr>
+        <p:spPr>
+          <a:xfrm>
+            <a:off x="5010912" y="1344168"/>
+            <a:ext cx="438912" cy="438912"/>
+          </a:xfrm>
+          <a:prstGeom prst="rect">
+            <a:avLst/>
+          </a:prstGeom>
+          <a:noFill/>
+        </p:spPr>
+        <p:txBody>
+          <a:bodyPr wrap="square" lIns="0" rIns="0" tIns="18288" bIns="18288">
+            <a:spAutoFit/>
+          </a:bodyPr>
+          <a:lstStyle/>
+          <a:p>
+            <a:pPr algn="ctr"/>
+            <a:r>
+              <a:rPr sz="1400" b="0" i="0">
+                <a:latin typeface="Segoe UI Emoji"/>
+              </a:rPr>
+              <a:t>🛡️</a:t>
+            </a:r>
+          </a:p>
+        </p:txBody>
+      </p:sp>
+      <p:sp>
+        <p:nvSpPr>
+          <p:cNvPr id="12" name="TextBox 11"/>
+          <p:cNvSpPr txBox="1"/>
+          <p:nvPr/>
+        </p:nvSpPr>
+        <p:spPr>
+          <a:xfrm>
+            <a:off x="5577840" y="1097280"/>
+            <a:ext cx="3154680" cy="384048"/>
+          </a:xfrm>
+          <a:prstGeom prst="rect">
+            <a:avLst/>
+          </a:prstGeom>
+          <a:noFill/>
+        </p:spPr>
+        <p:txBody>
+          <a:bodyPr wrap="square" lIns="0" rIns="0" tIns="18288" bIns="18288">
+            <a:spAutoFit/>
+          </a:bodyPr>
+          <a:lstStyle/>
+          <a:p>
+            <a:pPr algn="l"/>
+            <a:r>
+              <a:rPr sz="1350" b="1" i="0">
+                <a:solidFill>
+                  <a:srgbClr val="FFFFFF"/>
+                </a:solidFill>
+                <a:latin typeface="Calibri"/>
+              </a:rPr>
+              <a:t>Duplicate Guard</a:t>
+            </a:r>
+          </a:p>
+        </p:txBody>
+      </p:sp>
+      <p:sp>
+        <p:nvSpPr>
+          <p:cNvPr id="13" name="TextBox 12"/>
+          <p:cNvSpPr txBox="1"/>
+          <p:nvPr/>
+        </p:nvSpPr>
+        <p:spPr>
+          <a:xfrm>
+            <a:off x="5577840" y="1508760"/>
+            <a:ext cx="3154680" cy="530352"/>
+          </a:xfrm>
+          <a:prstGeom prst="rect">
+            <a:avLst/>
+          </a:prstGeom>
+          <a:noFill/>
+        </p:spPr>
+        <p:txBody>
+          <a:bodyPr wrap="square" lIns="0" rIns="0" tIns="18288" bIns="18288">
+            <a:spAutoFit/>
+          </a:bodyPr>
+          <a:lstStyle/>
+          <a:p>
+            <a:pPr algn="l"/>
+            <a:r>
+              <a:rPr sz="1200" b="0" i="0">
+                <a:solidFill>
+                  <a:srgbClr val="A8C8E8"/>
+                </a:solidFill>
+                <a:latin typeface="Calibri"/>
+              </a:rPr>
+              <a:t>409 blocks re-submission</a:t>
+            </a:r>
+          </a:p>
+        </p:txBody>
+      </p:sp>
+      <p:sp>
+        <p:nvSpPr>
+          <p:cNvPr id="14" name="Rounded Rectangle 13"/>
+          <p:cNvSpPr/>
+          <p:nvPr/>
+        </p:nvSpPr>
+        <p:spPr>
+          <a:xfrm>
+            <a:off x="502920" y="2304288"/>
+            <a:ext cx="4023360" cy="1143000"/>
+          </a:xfrm>
+          <a:prstGeom prst="roundRect">
+            <a:avLst/>
+          </a:prstGeom>
+          <a:solidFill>
+            <a:srgbClr val="173455"/>
+          </a:solidFill>
+          <a:ln>
+            <a:noFill/>
+          </a:ln>
+        </p:spPr>
+        <p:style>
+          <a:lnRef idx="1">
+            <a:schemeClr val="accent1"/>
+          </a:lnRef>
+          <a:fillRef idx="3">
+            <a:schemeClr val="accent1"/>
+          </a:fillRef>
+          <a:effectRef idx="2">
+            <a:schemeClr val="accent1"/>
+          </a:effectRef>
+          <a:fontRef idx="minor">
+            <a:schemeClr val="lt1"/>
+          </a:fontRef>
+        </p:style>
+        <p:txBody>
+          <a:bodyPr rtlCol="0" anchor="ctr"/>
+          <a:lstStyle/>
+          <a:p>
+            <a:pPr algn="ctr"/>
+          </a:p>
+        </p:txBody>
+      </p:sp>
+      <p:sp>
+        <p:nvSpPr>
+          <p:cNvPr id="15" name="Oval 14"/>
+          <p:cNvSpPr/>
+          <p:nvPr/>
+        </p:nvSpPr>
+        <p:spPr>
+          <a:xfrm>
+            <a:off x="667512" y="2651760"/>
+            <a:ext cx="438912" cy="438912"/>
+          </a:xfrm>
+          <a:prstGeom prst="ellipse">
+            <a:avLst/>
+          </a:prstGeom>
+          <a:solidFill>
+            <a:srgbClr val="0078D4"/>
+          </a:solidFill>
+          <a:ln>
+            <a:noFill/>
+          </a:ln>
+        </p:spPr>
+        <p:style>
+          <a:lnRef idx="1">
+            <a:schemeClr val="accent1"/>
+          </a:lnRef>
+          <a:fillRef idx="3">
+            <a:schemeClr val="accent1"/>
+          </a:fillRef>
+          <a:effectRef idx="2">
+            <a:schemeClr val="accent1"/>
+          </a:effectRef>
+          <a:fontRef idx="minor">
+            <a:schemeClr val="lt1"/>
+          </a:fontRef>
+        </p:style>
+        <p:txBody>
+          <a:bodyPr rtlCol="0" anchor="ctr"/>
+          <a:lstStyle/>
+          <a:p>
+            <a:pPr algn="ctr"/>
+          </a:p>
+        </p:txBody>
+      </p:sp>
+      <p:sp>
+        <p:nvSpPr>
+          <p:cNvPr id="16" name="TextBox 15"/>
+          <p:cNvSpPr txBox="1"/>
+          <p:nvPr/>
+        </p:nvSpPr>
+        <p:spPr>
+          <a:xfrm>
+            <a:off x="667512" y="2642616"/>
+            <a:ext cx="438912" cy="438912"/>
+          </a:xfrm>
+          <a:prstGeom prst="rect">
+            <a:avLst/>
+          </a:prstGeom>
+          <a:noFill/>
+        </p:spPr>
+        <p:txBody>
+          <a:bodyPr wrap="square" lIns="0" rIns="0" tIns="18288" bIns="18288">
+            <a:spAutoFit/>
+          </a:bodyPr>
+          <a:lstStyle/>
+          <a:p>
+            <a:pPr algn="ctr"/>
+            <a:r>
+              <a:rPr sz="1400" b="0" i="0">
+                <a:latin typeface="Segoe UI Emoji"/>
+              </a:rPr>
+              <a:t>📊</a:t>
+            </a:r>
+          </a:p>
+        </p:txBody>
+      </p:sp>
+      <p:sp>
+        <p:nvSpPr>
+          <p:cNvPr id="17" name="TextBox 16"/>
+          <p:cNvSpPr txBox="1"/>
+          <p:nvPr/>
+        </p:nvSpPr>
+        <p:spPr>
+          <a:xfrm>
+            <a:off x="1234440" y="2395728"/>
+            <a:ext cx="3154680" cy="384048"/>
+          </a:xfrm>
+          <a:prstGeom prst="rect">
+            <a:avLst/>
+          </a:prstGeom>
+          <a:noFill/>
+        </p:spPr>
+        <p:txBody>
+          <a:bodyPr wrap="square" lIns="0" rIns="0" tIns="18288" bIns="18288">
+            <a:spAutoFit/>
+          </a:bodyPr>
+          <a:lstStyle/>
+          <a:p>
+            <a:pPr algn="l"/>
+            <a:r>
+              <a:rPr sz="1350" b="1" i="0">
+                <a:solidFill>
+                  <a:srgbClr val="FFFFFF"/>
+                </a:solidFill>
+                <a:latin typeface="Calibri"/>
+              </a:rPr>
+              <a:t>Better Export</a:t>
+            </a:r>
+          </a:p>
+        </p:txBody>
+      </p:sp>
+      <p:sp>
+        <p:nvSpPr>
+          <p:cNvPr id="18" name="TextBox 17"/>
+          <p:cNvSpPr txBox="1"/>
+          <p:nvPr/>
+        </p:nvSpPr>
+        <p:spPr>
+          <a:xfrm>
+            <a:off x="1234440" y="2807208"/>
+            <a:ext cx="3154680" cy="530352"/>
+          </a:xfrm>
+          <a:prstGeom prst="rect">
+            <a:avLst/>
+          </a:prstGeom>
+          <a:noFill/>
+        </p:spPr>
+        <p:txBody>
+          <a:bodyPr wrap="square" lIns="0" rIns="0" tIns="18288" bIns="18288">
+            <a:spAutoFit/>
+          </a:bodyPr>
+          <a:lstStyle/>
+          <a:p>
+            <a:pPr algn="l"/>
+            <a:r>
+              <a:rPr sz="1200" b="0" i="0">
+                <a:solidFill>
+                  <a:srgbClr val="A8C8E8"/>
+                </a:solidFill>
+                <a:latin typeface="Calibri"/>
+              </a:rPr>
+              <a:t>3 charts in Summary sheet</a:t>
+            </a:r>
+          </a:p>
+        </p:txBody>
+      </p:sp>
+      <p:sp>
+        <p:nvSpPr>
+          <p:cNvPr id="19" name="Rounded Rectangle 18"/>
+          <p:cNvSpPr/>
+          <p:nvPr/>
+        </p:nvSpPr>
+        <p:spPr>
+          <a:xfrm>
+            <a:off x="4846320" y="2304288"/>
+            <a:ext cx="4023360" cy="1143000"/>
+          </a:xfrm>
+          <a:prstGeom prst="roundRect">
+            <a:avLst/>
+          </a:prstGeom>
+          <a:solidFill>
+            <a:srgbClr val="173455"/>
+          </a:solidFill>
+          <a:ln>
+            <a:noFill/>
+          </a:ln>
+        </p:spPr>
+        <p:style>
+          <a:lnRef idx="1">
+            <a:schemeClr val="accent1"/>
+          </a:lnRef>
+          <a:fillRef idx="3">
+            <a:schemeClr val="accent1"/>
+          </a:fillRef>
+          <a:effectRef idx="2">
+            <a:schemeClr val="accent1"/>
+          </a:effectRef>
+          <a:fontRef idx="minor">
+            <a:schemeClr val="lt1"/>
+          </a:fontRef>
+        </p:style>
+        <p:txBody>
+          <a:bodyPr rtlCol="0" anchor="ctr"/>
+          <a:lstStyle/>
+          <a:p>
+            <a:pPr algn="ctr"/>
+          </a:p>
+        </p:txBody>
+      </p:sp>
+      <p:sp>
+        <p:nvSpPr>
+          <p:cNvPr id="20" name="Oval 19"/>
+          <p:cNvSpPr/>
+          <p:nvPr/>
+        </p:nvSpPr>
+        <p:spPr>
+          <a:xfrm>
+            <a:off x="5010912" y="2651760"/>
+            <a:ext cx="438912" cy="438912"/>
+          </a:xfrm>
+          <a:prstGeom prst="ellipse">
+            <a:avLst/>
+          </a:prstGeom>
+          <a:solidFill>
+            <a:srgbClr val="0078D4"/>
+          </a:solidFill>
+          <a:ln>
+            <a:noFill/>
+          </a:ln>
+        </p:spPr>
+        <p:style>
+          <a:lnRef idx="1">
+            <a:schemeClr val="accent1"/>
+          </a:lnRef>
+          <a:fillRef idx="3">
+            <a:schemeClr val="accent1"/>
+          </a:fillRef>
+          <a:effectRef idx="2">
+            <a:schemeClr val="accent1"/>
+          </a:effectRef>
+          <a:fontRef idx="minor">
+            <a:schemeClr val="lt1"/>
+          </a:fontRef>
+        </p:style>
+        <p:txBody>
+          <a:bodyPr rtlCol="0" anchor="ctr"/>
+          <a:lstStyle/>
+          <a:p>
+            <a:pPr algn="ctr"/>
+          </a:p>
+        </p:txBody>
+      </p:sp>
+      <p:sp>
+        <p:nvSpPr>
+          <p:cNvPr id="21" name="TextBox 20"/>
+          <p:cNvSpPr txBox="1"/>
+          <p:nvPr/>
+        </p:nvSpPr>
+        <p:spPr>
+          <a:xfrm>
+            <a:off x="5010912" y="2642616"/>
+            <a:ext cx="438912" cy="438912"/>
+          </a:xfrm>
+          <a:prstGeom prst="rect">
+            <a:avLst/>
+          </a:prstGeom>
+          <a:noFill/>
+        </p:spPr>
+        <p:txBody>
+          <a:bodyPr wrap="square" lIns="0" rIns="0" tIns="18288" bIns="18288">
+            <a:spAutoFit/>
+          </a:bodyPr>
+          <a:lstStyle/>
+          <a:p>
+            <a:pPr algn="ctr"/>
+            <a:r>
+              <a:rPr sz="1400" b="0" i="0">
+                <a:latin typeface="Segoe UI Emoji"/>
+              </a:rPr>
+              <a:t>⚙️</a:t>
+            </a:r>
+          </a:p>
+        </p:txBody>
+      </p:sp>
+      <p:sp>
+        <p:nvSpPr>
+          <p:cNvPr id="22" name="TextBox 21"/>
+          <p:cNvSpPr txBox="1"/>
+          <p:nvPr/>
+        </p:nvSpPr>
+        <p:spPr>
+          <a:xfrm>
+            <a:off x="5577840" y="2395728"/>
+            <a:ext cx="3154680" cy="384048"/>
+          </a:xfrm>
+          <a:prstGeom prst="rect">
+            <a:avLst/>
+          </a:prstGeom>
+          <a:noFill/>
+        </p:spPr>
+        <p:txBody>
+          <a:bodyPr wrap="square" lIns="0" rIns="0" tIns="18288" bIns="18288">
+            <a:spAutoFit/>
+          </a:bodyPr>
+          <a:lstStyle/>
+          <a:p>
+            <a:pPr algn="l"/>
+            <a:r>
+              <a:rPr sz="1350" b="1" i="0">
+                <a:solidFill>
+                  <a:srgbClr val="FFFFFF"/>
+                </a:solidFill>
+                <a:latin typeface="Calibri"/>
+              </a:rPr>
+              <a:t>Port Config</a:t>
+            </a:r>
+          </a:p>
+        </p:txBody>
+      </p:sp>
+      <p:sp>
+        <p:nvSpPr>
+          <p:cNvPr id="23" name="TextBox 22"/>
+          <p:cNvSpPr txBox="1"/>
+          <p:nvPr/>
+        </p:nvSpPr>
+        <p:spPr>
+          <a:xfrm>
+            <a:off x="5577840" y="2807208"/>
+            <a:ext cx="3154680" cy="530352"/>
+          </a:xfrm>
+          <a:prstGeom prst="rect">
+            <a:avLst/>
+          </a:prstGeom>
+          <a:noFill/>
+        </p:spPr>
+        <p:txBody>
+          <a:bodyPr wrap="square" lIns="0" rIns="0" tIns="18288" bIns="18288">
+            <a:spAutoFit/>
+          </a:bodyPr>
+          <a:lstStyle/>
+          <a:p>
+            <a:pPr algn="l"/>
+            <a:r>
+              <a:rPr sz="1200" b="0" i="0">
+                <a:solidFill>
+                  <a:srgbClr val="A8C8E8"/>
+                </a:solidFill>
+                <a:latin typeface="Calibri"/>
+              </a:rPr>
+              <a:t>Change host/port via GUI</a:t>
+            </a:r>
+          </a:p>
+        </p:txBody>
+      </p:sp>
+      <p:sp>
+        <p:nvSpPr>
+          <p:cNvPr id="24" name="Rounded Rectangle 23"/>
+          <p:cNvSpPr/>
+          <p:nvPr/>
+        </p:nvSpPr>
+        <p:spPr>
+          <a:xfrm>
+            <a:off x="502920" y="3602736"/>
+            <a:ext cx="4023360" cy="1143000"/>
+          </a:xfrm>
+          <a:prstGeom prst="roundRect">
+            <a:avLst/>
+          </a:prstGeom>
+          <a:solidFill>
+            <a:srgbClr val="173455"/>
+          </a:solidFill>
+          <a:ln>
+            <a:noFill/>
+          </a:ln>
+        </p:spPr>
+        <p:style>
+          <a:lnRef idx="1">
+            <a:schemeClr val="accent1"/>
+          </a:lnRef>
+          <a:fillRef idx="3">
+            <a:schemeClr val="accent1"/>
+          </a:fillRef>
+          <a:effectRef idx="2">
+            <a:schemeClr val="accent1"/>
+          </a:effectRef>
+          <a:fontRef idx="minor">
+            <a:schemeClr val="lt1"/>
+          </a:fontRef>
+        </p:style>
+        <p:txBody>
+          <a:bodyPr rtlCol="0" anchor="ctr"/>
+          <a:lstStyle/>
+          <a:p>
+            <a:pPr algn="ctr"/>
+          </a:p>
+        </p:txBody>
+      </p:sp>
+      <p:sp>
+        <p:nvSpPr>
+          <p:cNvPr id="25" name="Oval 24"/>
+          <p:cNvSpPr/>
+          <p:nvPr/>
+        </p:nvSpPr>
+        <p:spPr>
+          <a:xfrm>
+            <a:off x="667512" y="3950207"/>
+            <a:ext cx="438912" cy="438912"/>
+          </a:xfrm>
+          <a:prstGeom prst="ellipse">
+            <a:avLst/>
+          </a:prstGeom>
+          <a:solidFill>
+            <a:srgbClr val="0078D4"/>
+          </a:solidFill>
+          <a:ln>
+            <a:noFill/>
+          </a:ln>
+        </p:spPr>
+        <p:style>
+          <a:lnRef idx="1">
+            <a:schemeClr val="accent1"/>
+          </a:lnRef>
+          <a:fillRef idx="3">
+            <a:schemeClr val="accent1"/>
+          </a:fillRef>
+          <a:effectRef idx="2">
+            <a:schemeClr val="accent1"/>
+          </a:effectRef>
+          <a:fontRef idx="minor">
+            <a:schemeClr val="lt1"/>
+          </a:fontRef>
+        </p:style>
+        <p:txBody>
+          <a:bodyPr rtlCol="0" anchor="ctr"/>
+          <a:lstStyle/>
+          <a:p>
+            <a:pPr algn="ctr"/>
+          </a:p>
+        </p:txBody>
+      </p:sp>
+      <p:sp>
+        <p:nvSpPr>
+          <p:cNvPr id="26" name="TextBox 25"/>
+          <p:cNvSpPr txBox="1"/>
+          <p:nvPr/>
+        </p:nvSpPr>
+        <p:spPr>
+          <a:xfrm>
+            <a:off x="667512" y="3941063"/>
+            <a:ext cx="438912" cy="438912"/>
+          </a:xfrm>
+          <a:prstGeom prst="rect">
+            <a:avLst/>
+          </a:prstGeom>
+          <a:noFill/>
+        </p:spPr>
+        <p:txBody>
+          <a:bodyPr wrap="square" lIns="0" rIns="0" tIns="18288" bIns="18288">
+            <a:spAutoFit/>
+          </a:bodyPr>
+          <a:lstStyle/>
+          <a:p>
+            <a:pPr algn="ctr"/>
+            <a:r>
+              <a:rPr sz="1400" b="0" i="0">
+                <a:latin typeface="Segoe UI Emoji"/>
+              </a:rPr>
+              <a:t>📱</a:t>
+            </a:r>
+          </a:p>
+        </p:txBody>
+      </p:sp>
+      <p:sp>
+        <p:nvSpPr>
+          <p:cNvPr id="27" name="TextBox 26"/>
+          <p:cNvSpPr txBox="1"/>
+          <p:nvPr/>
+        </p:nvSpPr>
+        <p:spPr>
+          <a:xfrm>
+            <a:off x="1234440" y="3694176"/>
+            <a:ext cx="3154680" cy="384048"/>
+          </a:xfrm>
+          <a:prstGeom prst="rect">
+            <a:avLst/>
+          </a:prstGeom>
+          <a:noFill/>
+        </p:spPr>
+        <p:txBody>
+          <a:bodyPr wrap="square" lIns="0" rIns="0" tIns="18288" bIns="18288">
+            <a:spAutoFit/>
+          </a:bodyPr>
+          <a:lstStyle/>
+          <a:p>
+            <a:pPr algn="l"/>
+            <a:r>
+              <a:rPr sz="1350" b="1" i="0">
+                <a:solidFill>
+                  <a:srgbClr val="FFFFFF"/>
+                </a:solidFill>
+                <a:latin typeface="Calibri"/>
+              </a:rPr>
+              <a:t>4 New Types</a:t>
+            </a:r>
+          </a:p>
+        </p:txBody>
+      </p:sp>
+      <p:sp>
+        <p:nvSpPr>
+          <p:cNvPr id="28" name="TextBox 27"/>
+          <p:cNvSpPr txBox="1"/>
+          <p:nvPr/>
+        </p:nvSpPr>
+        <p:spPr>
+          <a:xfrm>
+            <a:off x="1234440" y="4105656"/>
+            <a:ext cx="3154680" cy="530352"/>
+          </a:xfrm>
+          <a:prstGeom prst="rect">
+            <a:avLst/>
+          </a:prstGeom>
+          <a:noFill/>
+        </p:spPr>
+        <p:txBody>
+          <a:bodyPr wrap="square" lIns="0" rIns="0" tIns="18288" bIns="18288">
+            <a:spAutoFit/>
+          </a:bodyPr>
+          <a:lstStyle/>
+          <a:p>
+            <a:pPr algn="l"/>
+            <a:r>
+              <a:rPr sz="1200" b="0" i="0">
+                <a:solidFill>
+                  <a:srgbClr val="A8C8E8"/>
+                </a:solidFill>
+                <a:latin typeface="Calibri"/>
+              </a:rPr>
+              <a:t>Cisco Phone, Printer, Scanner, Switch</a:t>
+            </a:r>
+          </a:p>
+        </p:txBody>
+      </p:sp>
+      <p:sp>
+        <p:nvSpPr>
+          <p:cNvPr id="29" name="Rounded Rectangle 28"/>
+          <p:cNvSpPr/>
+          <p:nvPr/>
+        </p:nvSpPr>
+        <p:spPr>
+          <a:xfrm>
+            <a:off x="4846320" y="3602736"/>
+            <a:ext cx="4023360" cy="1143000"/>
+          </a:xfrm>
+          <a:prstGeom prst="roundRect">
+            <a:avLst/>
+          </a:prstGeom>
+          <a:solidFill>
+            <a:srgbClr val="173455"/>
+          </a:solidFill>
+          <a:ln>
+            <a:noFill/>
+          </a:ln>
+        </p:spPr>
+        <p:style>
+          <a:lnRef idx="1">
+            <a:schemeClr val="accent1"/>
+          </a:lnRef>
+          <a:fillRef idx="3">
+            <a:schemeClr val="accent1"/>
+          </a:fillRef>
+          <a:effectRef idx="2">
+            <a:schemeClr val="accent1"/>
+          </a:effectRef>
+          <a:fontRef idx="minor">
+            <a:schemeClr val="lt1"/>
+          </a:fontRef>
+        </p:style>
+        <p:txBody>
+          <a:bodyPr rtlCol="0" anchor="ctr"/>
+          <a:lstStyle/>
+          <a:p>
+            <a:pPr algn="ctr"/>
+          </a:p>
+        </p:txBody>
+      </p:sp>
+      <p:sp>
+        <p:nvSpPr>
+          <p:cNvPr id="30" name="Oval 29"/>
+          <p:cNvSpPr/>
+          <p:nvPr/>
+        </p:nvSpPr>
+        <p:spPr>
+          <a:xfrm>
+            <a:off x="5010912" y="3950207"/>
+            <a:ext cx="438912" cy="438912"/>
+          </a:xfrm>
+          <a:prstGeom prst="ellipse">
+            <a:avLst/>
+          </a:prstGeom>
+          <a:solidFill>
+            <a:srgbClr val="0078D4"/>
+          </a:solidFill>
+          <a:ln>
+            <a:noFill/>
+          </a:ln>
+        </p:spPr>
+        <p:style>
+          <a:lnRef idx="1">
+            <a:schemeClr val="accent1"/>
+          </a:lnRef>
+          <a:fillRef idx="3">
+            <a:schemeClr val="accent1"/>
+          </a:fillRef>
+          <a:effectRef idx="2">
+            <a:schemeClr val="accent1"/>
+          </a:effectRef>
+          <a:fontRef idx="minor">
+            <a:schemeClr val="lt1"/>
+          </a:fontRef>
+        </p:style>
+        <p:txBody>
+          <a:bodyPr rtlCol="0" anchor="ctr"/>
+          <a:lstStyle/>
+          <a:p>
+            <a:pPr algn="ctr"/>
+          </a:p>
+        </p:txBody>
+      </p:sp>
+      <p:sp>
+        <p:nvSpPr>
+          <p:cNvPr id="31" name="TextBox 30"/>
+          <p:cNvSpPr txBox="1"/>
+          <p:nvPr/>
+        </p:nvSpPr>
+        <p:spPr>
+          <a:xfrm>
+            <a:off x="5010912" y="3941063"/>
+            <a:ext cx="438912" cy="438912"/>
+          </a:xfrm>
+          <a:prstGeom prst="rect">
+            <a:avLst/>
+          </a:prstGeom>
+          <a:noFill/>
+        </p:spPr>
+        <p:txBody>
+          <a:bodyPr wrap="square" lIns="0" rIns="0" tIns="18288" bIns="18288">
+            <a:spAutoFit/>
+          </a:bodyPr>
+          <a:lstStyle/>
+          <a:p>
+            <a:pPr algn="ctr"/>
+            <a:r>
+              <a:rPr sz="1400" b="0" i="0">
+                <a:latin typeface="Segoe UI Emoji"/>
+              </a:rPr>
+              <a:t>⚡</a:t>
+            </a:r>
+          </a:p>
+        </p:txBody>
+      </p:sp>
+      <p:sp>
+        <p:nvSpPr>
+          <p:cNvPr id="32" name="TextBox 31"/>
+          <p:cNvSpPr txBox="1"/>
+          <p:nvPr/>
+        </p:nvSpPr>
+        <p:spPr>
+          <a:xfrm>
+            <a:off x="5577840" y="3694176"/>
+            <a:ext cx="3154680" cy="384048"/>
+          </a:xfrm>
+          <a:prstGeom prst="rect">
+            <a:avLst/>
+          </a:prstGeom>
+          <a:noFill/>
+        </p:spPr>
+        <p:txBody>
+          <a:bodyPr wrap="square" lIns="0" rIns="0" tIns="18288" bIns="18288">
+            <a:spAutoFit/>
+          </a:bodyPr>
+          <a:lstStyle/>
+          <a:p>
+            <a:pPr algn="l"/>
+            <a:r>
+              <a:rPr sz="1350" b="1" i="0">
+                <a:solidFill>
+                  <a:srgbClr val="FFFFFF"/>
+                </a:solidFill>
+                <a:latin typeface="Calibri"/>
+              </a:rPr>
+              <a:t>Windows Service</a:t>
+            </a:r>
+          </a:p>
+        </p:txBody>
+      </p:sp>
+      <p:sp>
+        <p:nvSpPr>
+          <p:cNvPr id="33" name="TextBox 32"/>
+          <p:cNvSpPr txBox="1"/>
+          <p:nvPr/>
+        </p:nvSpPr>
+        <p:spPr>
+          <a:xfrm>
+            <a:off x="5577840" y="4105656"/>
+            <a:ext cx="3154680" cy="530352"/>
+          </a:xfrm>
+          <a:prstGeom prst="rect">
+            <a:avLst/>
+          </a:prstGeom>
+          <a:noFill/>
+        </p:spPr>
+        <p:txBody>
+          <a:bodyPr wrap="square" lIns="0" rIns="0" tIns="18288" bIns="18288">
+            <a:spAutoFit/>
+          </a:bodyPr>
+          <a:lstStyle/>
+          <a:p>
+            <a:pPr algn="l"/>
+            <a:r>
+              <a:rPr sz="1200" b="0" i="0">
+                <a:solidFill>
+                  <a:srgbClr val="A8C8E8"/>
+                </a:solidFill>
+                <a:latin typeface="Calibri"/>
+              </a:rPr>
+              <a:t>Starts at boot. No login needed.</a:t>
+            </a:r>
+          </a:p>
+        </p:txBody>
+      </p:sp>
+      <p:sp>
+        <p:nvSpPr>
+          <p:cNvPr id="24" name="Rounded Rectangle 23"/>
+          <p:cNvSpPr/>
+          <p:nvPr/>
+        </p:nvSpPr>
+        <p:spPr>
+          <a:xfrm>
+            <a:off x="502920" y="4901184"/>
+            <a:ext cx="4023360" cy="1143000"/>
+          </a:xfrm>
+          <a:prstGeom prst="roundRect">
+            <a:avLst/>
+          </a:prstGeom>
+          <a:solidFill>
+            <a:srgbClr val="173455"/>
+          </a:solidFill>
+          <a:ln>
+            <a:noFill/>
+          </a:ln>
+        </p:spPr>
+        <p:style>
+          <a:lnRef idx="1">
+            <a:schemeClr val="accent1"/>
+          </a:lnRef>
+          <a:fillRef idx="3">
+            <a:schemeClr val="accent1"/>
+          </a:fillRef>
+          <a:effectRef idx="2">
+            <a:schemeClr val="accent1"/>
+          </a:effectRef>
+          <a:fontRef idx="minor">
+            <a:schemeClr val="lt1"/>
+          </a:fontRef>
+        </p:style>
+        <p:txBody>
+          <a:bodyPr rtlCol="0" anchor="ctr"/>
+          <a:lstStyle/>
+          <a:p>
+            <a:pPr algn="ctr"/>
+          </a:p>
+        </p:txBody>
+      </p:sp>
+      <p:sp>
+        <p:nvSpPr>
+          <p:cNvPr id="25" name="Oval 24"/>
+          <p:cNvSpPr/>
+          <p:nvPr/>
+        </p:nvSpPr>
+        <p:spPr>
+          <a:xfrm>
+            <a:off x="667512" y="5248655"/>
+            <a:ext cx="438912" cy="438912"/>
+          </a:xfrm>
+          <a:prstGeom prst="ellipse">
+            <a:avLst/>
+          </a:prstGeom>
+          <a:solidFill>
+            <a:srgbClr val="0078D4"/>
+          </a:solidFill>
+          <a:ln>
+            <a:noFill/>
+          </a:ln>
+        </p:spPr>
+        <p:style>
+          <a:lnRef idx="1">
+            <a:schemeClr val="accent1"/>
+          </a:lnRef>
+          <a:fillRef idx="3">
+            <a:schemeClr val="accent1"/>
+          </a:fillRef>
+          <a:effectRef idx="2">
+            <a:schemeClr val="accent1"/>
+          </a:effectRef>
+          <a:fontRef idx="minor">
+            <a:schemeClr val="lt1"/>
+          </a:fontRef>
+        </p:style>
+        <p:txBody>
+          <a:bodyPr rtlCol="0" anchor="ctr"/>
+          <a:lstStyle/>
+          <a:p>
+            <a:pPr algn="ctr"/>
+          </a:p>
+        </p:txBody>
+      </p:sp>
+      <p:sp>
+        <p:nvSpPr>
+          <p:cNvPr id="26" name="TextBox 25"/>
+          <p:cNvSpPr txBox="1"/>
+          <p:nvPr/>
+        </p:nvSpPr>
+        <p:spPr>
+          <a:xfrm>
+            <a:off x="667512" y="5239511"/>
+            <a:ext cx="438912" cy="438912"/>
+          </a:xfrm>
+          <a:prstGeom prst="rect">
+            <a:avLst/>
+          </a:prstGeom>
+          <a:noFill/>
+        </p:spPr>
+        <p:txBody>
+          <a:bodyPr wrap="square" lIns="0" rIns="0" tIns="18288" bIns="18288">
+            <a:spAutoFit/>
+          </a:bodyPr>
+          <a:lstStyle/>
+          <a:p>
+            <a:pPr algn="ctr"/>
+            <a:r>
+              <a:rPr sz="1400" b="0" i="0">
+                <a:latin typeface="Segoe UI Emoji"/>
+              </a:rPr>
+              <a:t>🔒</a:t>
+            </a:r>
+          </a:p>
+        </p:txBody>
+      </p:sp>
+      <p:sp>
+        <p:nvSpPr>
+          <p:cNvPr id="27" name="TextBox 26"/>
+          <p:cNvSpPr txBox="1"/>
+          <p:nvPr/>
+        </p:nvSpPr>
+        <p:spPr>
+          <a:xfrm>
+            <a:off x="1234440" y="4992624"/>
+            <a:ext cx="3154680" cy="384048"/>
+          </a:xfrm>
+          <a:prstGeom prst="rect">
+            <a:avLst/>
+          </a:prstGeom>
+          <a:noFill/>
+        </p:spPr>
+        <p:txBody>
+          <a:bodyPr wrap="square" lIns="0" rIns="0" tIns="18288" bIns="18288">
+            <a:spAutoFit/>
+          </a:bodyPr>
+          <a:lstStyle/>
+          <a:p>
+            <a:pPr algn="l"/>
+            <a:r>
+              <a:rPr sz="1350" b="1" i="0">
+                <a:solidFill>
+                  <a:srgbClr val="FFFFFF"/>
+                </a:solidFill>
+                <a:latin typeface="Calibri"/>
+              </a:rPr>
+              <a:t>SSL Certificate</a:t>
+            </a:r>
+          </a:p>
+        </p:txBody>
+      </p:sp>
+      <p:sp>
+        <p:nvSpPr>
+          <p:cNvPr id="28" name="TextBox 27"/>
+          <p:cNvSpPr txBox="1"/>
+          <p:nvPr/>
+        </p:nvSpPr>
+        <p:spPr>
+          <a:xfrm>
+            <a:off x="1234440" y="5404104"/>
+            <a:ext cx="3154680" cy="530352"/>
+          </a:xfrm>
+          <a:prstGeom prst="rect">
+            <a:avLst/>
+          </a:prstGeom>
+          <a:noFill/>
+        </p:spPr>
+        <p:txBody>
+          <a:bodyPr wrap="square" lIns="0" rIns="0" tIns="18288" bIns="18288">
+            <a:spAutoFit/>
+          </a:bodyPr>
+          <a:lstStyle/>
+          <a:p>
+            <a:pPr algn="l"/>
+            <a:r>
+              <a:rPr sz="1200" b="0" i="0">
+                <a:solidFill>
+                  <a:srgbClr val="A8C8E8"/>
+                </a:solidFill>
+                <a:latin typeface="Calibri"/>
+              </a:rPr>
+              <a:t>HTTPS encryption on port 8081</a:t>
+            </a:r>
+          </a:p>
+        </p:txBody>
+      </p:sp>
+      <p:sp>
+        <p:nvSpPr>
+          <p:cNvPr id="29" name="Rounded Rectangle 28"/>
+          <p:cNvSpPr/>
+          <p:nvPr/>
+        </p:nvSpPr>
+        <p:spPr>
+          <a:xfrm>
+            <a:off x="4846320" y="4901184"/>
+            <a:ext cx="4023360" cy="1143000"/>
+          </a:xfrm>
+          <a:prstGeom prst="roundRect">
+            <a:avLst/>
+          </a:prstGeom>
+          <a:solidFill>
+            <a:srgbClr val="173455"/>
+          </a:solidFill>
+          <a:ln>
+            <a:noFill/>
+          </a:ln>
+        </p:spPr>
+        <p:style>
+          <a:lnRef idx="1">
+            <a:schemeClr val="accent1"/>
+          </a:lnRef>
+          <a:fillRef idx="3">
+            <a:schemeClr val="accent1"/>
+          </a:fillRef>
+          <a:effectRef idx="2">
+            <a:schemeClr val="accent1"/>
+          </a:effectRef>
+          <a:fontRef idx="minor">
+            <a:schemeClr val="lt1"/>
+          </a:fontRef>
+        </p:style>
+        <p:txBody>
+          <a:bodyPr rtlCol="0" anchor="ctr"/>
+          <a:lstStyle/>
+          <a:p>
+            <a:pPr algn="ctr"/>
+          </a:p>
+        </p:txBody>
+      </p:sp>
+      <p:sp>
+        <p:nvSpPr>
+          <p:cNvPr id="30" name="Oval 29"/>
+          <p:cNvSpPr/>
+          <p:nvPr/>
+        </p:nvSpPr>
+        <p:spPr>
+          <a:xfrm>
+            <a:off x="5010912" y="5248655"/>
+            <a:ext cx="438912" cy="438912"/>
+          </a:xfrm>
+          <a:prstGeom prst="ellipse">
+            <a:avLst/>
+          </a:prstGeom>
+          <a:solidFill>
+            <a:srgbClr val="0078D4"/>
+          </a:solidFill>
+          <a:ln>
+            <a:noFill/>
+          </a:ln>
+        </p:spPr>
+        <p:style>
+          <a:lnRef idx="1">
+            <a:schemeClr val="accent1"/>
+          </a:lnRef>
+          <a:fillRef idx="3">
+            <a:schemeClr val="accent1"/>
+          </a:fillRef>
+          <a:effectRef idx="2">
+            <a:schemeClr val="accent1"/>
+          </a:effectRef>
+          <a:fontRef idx="minor">
+            <a:schemeClr val="lt1"/>
+          </a:fontRef>
+        </p:style>
+        <p:txBody>
+          <a:bodyPr rtlCol="0" anchor="ctr"/>
+          <a:lstStyle/>
+          <a:p>
+            <a:pPr algn="ctr"/>
+          </a:p>
+        </p:txBody>
+      </p:sp>
+      <p:sp>
+        <p:nvSpPr>
+          <p:cNvPr id="31" name="TextBox 30"/>
+          <p:cNvSpPr txBox="1"/>
+          <p:nvPr/>
+        </p:nvSpPr>
+        <p:spPr>
+          <a:xfrm>
+            <a:off x="5010912" y="5239511"/>
+            <a:ext cx="438912" cy="438912"/>
+          </a:xfrm>
+          <a:prstGeom prst="rect">
+            <a:avLst/>
+          </a:prstGeom>
+          <a:noFill/>
+        </p:spPr>
+        <p:txBody>
+          <a:bodyPr wrap="square" lIns="0" rIns="0" tIns="18288" bIns="18288">
+            <a:spAutoFit/>
+          </a:bodyPr>
+          <a:lstStyle/>
+          <a:p>
+            <a:pPr algn="ctr"/>
+            <a:r>
+              <a:rPr sz="1400" b="0" i="0">
+                <a:latin typeface="Segoe UI Emoji"/>
+              </a:rPr>
+              <a:t>🗑</a:t>
+            </a:r>
+          </a:p>
+        </p:txBody>
+      </p:sp>
+      <p:sp>
+        <p:nvSpPr>
+          <p:cNvPr id="32" name="TextBox 31"/>
+          <p:cNvSpPr txBox="1"/>
+          <p:nvPr/>
+        </p:nvSpPr>
+        <p:spPr>
+          <a:xfrm>
+            <a:off x="5577840" y="4992624"/>
+            <a:ext cx="3154680" cy="384048"/>
+          </a:xfrm>
+          <a:prstGeom prst="rect">
+            <a:avLst/>
+          </a:prstGeom>
+          <a:noFill/>
+        </p:spPr>
+        <p:txBody>
+          <a:bodyPr wrap="square" lIns="0" rIns="0" tIns="18288" bIns="18288">
+            <a:spAutoFit/>
+          </a:bodyPr>
+          <a:lstStyle/>
+          <a:p>
+            <a:pPr algn="l"/>
+            <a:r>
+              <a:rPr sz="1350" b="1" i="0">
+                <a:solidFill>
+                  <a:srgbClr val="FFFFFF"/>
+                </a:solidFill>
+                <a:latin typeface="Calibri"/>
+              </a:rPr>
+              <a:t>Clear All Records</a:t>
+            </a:r>
+          </a:p>
+        </p:txBody>
+      </p:sp>
+      <p:sp>
+        <p:nvSpPr>
+          <p:cNvPr id="33" name="TextBox 32"/>
+          <p:cNvSpPr txBox="1"/>
+          <p:nvPr/>
+        </p:nvSpPr>
+        <p:spPr>
+          <a:xfrm>
+            <a:off x="5577840" y="5404104"/>
+            <a:ext cx="3154680" cy="530352"/>
+          </a:xfrm>
+          <a:prstGeom prst="rect">
+            <a:avLst/>
+          </a:prstGeom>
+          <a:noFill/>
+        </p:spPr>
+        <p:txBody>
+          <a:bodyPr wrap="square" lIns="0" rIns="0" tIns="18288" bIns="18288">
+            <a:spAutoFit/>
+          </a:bodyPr>
+          <a:lstStyle/>
+          <a:p>
+            <a:pPr algn="l"/>
+            <a:r>
+              <a:rPr sz="1200" b="0" i="0">
+                <a:solidFill>
+                  <a:srgbClr val="A8C8E8"/>
+                </a:solidFill>
+                <a:latin typeface="Calibri"/>
+              </a:rPr>
+              <a:t>Admin-protected database wipe</a:t>
+            </a:r>
+          </a:p>
+        </p:txBody>
+      </p:sp>
+      <p:sp>
+        <p:nvSpPr>
+          <p:cNvPr id="50" name="Rounded Rectangle 49"/>
+          <p:cNvSpPr/>
+          <p:nvPr/>
+        </p:nvSpPr>
+        <p:spPr>
+          <a:xfrm>
+            <a:off x="502920" y="6130000"/>
+            <a:ext cx="8138160" cy="500000"/>
+          </a:xfrm>
+          <a:prstGeom prst="roundRect">
+            <a:avLst/>
+          </a:prstGeom>
+          <a:solidFill>
+            <a:srgbClr val="173455"/>
+          </a:solidFill>
+          <a:ln>
+            <a:noFill/>
+          </a:ln>
+        </p:spPr>
+        <p:style>
+          <a:lnRef idx="1">
+            <a:schemeClr val="accent1"/>
+          </a:lnRef>
+          <a:fillRef idx="3">
+            <a:schemeClr val="accent1"/>
+          </a:fillRef>
+          <a:effectRef idx="2">
+            <a:schemeClr val="accent1"/>
+          </a:effectRef>
+          <a:fontRef idx="minor">
+            <a:schemeClr val="lt1"/>
+          </a:fontRef>
+        </p:style>
+        <p:txBody>
+          <a:bodyPr rtlCol="0" anchor="ctr"/>
+          <a:lstStyle/>
+          <a:p>
+            <a:pPr algn="ctr"/>
+          </a:p>
+        </p:txBody>
+      </p:sp>
+      <p:sp>
+        <p:nvSpPr>
+          <p:cNvPr id="51" name="Oval 50"/>
+          <p:cNvSpPr/>
+          <p:nvPr/>
+        </p:nvSpPr>
+        <p:spPr>
+          <a:xfrm>
+            <a:off x="667512" y="6312656"/>
+            <a:ext cx="438912" cy="438912"/>
+          </a:xfrm>
+          <a:prstGeom prst="ellipse">
+            <a:avLst/>
+          </a:prstGeom>
+          <a:solidFill>
+            <a:srgbClr val="0078D4"/>
+          </a:solidFill>
+          <a:ln>
+            <a:noFill/>
+          </a:ln>
+        </p:spPr>
+        <p:style>
+          <a:lnRef idx="1">
+            <a:schemeClr val="accent1"/>
+          </a:lnRef>
+          <a:fillRef idx="3">
+            <a:schemeClr val="accent1"/>
+          </a:fillRef>
+          <a:effectRef idx="2">
+            <a:schemeClr val="accent1"/>
+          </a:effectRef>
+          <a:fontRef idx="minor">
+            <a:schemeClr val="lt1"/>
+          </a:fontRef>
+        </p:style>
+        <p:txBody>
+          <a:bodyPr rtlCol="0" anchor="ctr"/>
+          <a:lstStyle/>
+          <a:p>
+            <a:pPr algn="ctr"/>
+          </a:p>
+        </p:txBody>
+      </p:sp>
+      <p:sp>
+        <p:nvSpPr>
+          <p:cNvPr id="52" name="TextBox 51"/>
+          <p:cNvSpPr txBox="1"/>
+          <p:nvPr/>
+        </p:nvSpPr>
+        <p:spPr>
+          <a:xfrm>
+            <a:off x="667512" y="6303512"/>
+            <a:ext cx="438912" cy="438912"/>
+          </a:xfrm>
+          <a:prstGeom prst="rect">
+            <a:avLst/>
+          </a:prstGeom>
+          <a:noFill/>
+        </p:spPr>
+        <p:txBody>
+          <a:bodyPr wrap="square" lIns="0" rIns="0" tIns="18288" bIns="18288">
+            <a:spAutoFit/>
+          </a:bodyPr>
+          <a:lstStyle/>
+          <a:p>
+            <a:pPr algn="ctr"/>
+            <a:r>
+              <a:rPr sz="1400" b="0" i="0">
+                <a:latin typeface="Segoe UI Emoji"/>
+              </a:rPr>
+              <a:t>🖥️</a:t>
+            </a:r>
+          </a:p>
+        </p:txBody>
+      </p:sp>
+      <p:sp>
+        <p:nvSpPr>
+          <p:cNvPr id="53" name="TextBox 52"/>
+          <p:cNvSpPr txBox="1"/>
+          <p:nvPr/>
+        </p:nvSpPr>
+        <p:spPr>
+          <a:xfrm>
+            <a:off x="1234440" y="6155440"/>
+            <a:ext cx="7148760" cy="384048"/>
+          </a:xfrm>
+          <a:prstGeom prst="rect">
+            <a:avLst/>
+          </a:prstGeom>
+          <a:noFill/>
+        </p:spPr>
+        <p:txBody>
+          <a:bodyPr wrap="square" lIns="0" rIns="0" tIns="18288" bIns="18288">
+            <a:spAutoFit/>
+          </a:bodyPr>
+          <a:lstStyle/>
+          <a:p>
+            <a:pPr algn="l"/>
+            <a:r>
+              <a:rPr sz="1350" b="1" i="0">
+                <a:solidFill>
+                  <a:srgbClr val="FFFFFF"/>
+                </a:solidFill>
+                <a:latin typeface="Calibri"/>
+              </a:rPr>
+              <a:t>System Tray</a:t>
+            </a:r>
+          </a:p>
+        </p:txBody>
+      </p:sp>
+      <p:sp>
+        <p:nvSpPr>
+          <p:cNvPr id="54" name="TextBox 53"/>
+          <p:cNvSpPr txBox="1"/>
+          <p:nvPr/>
+        </p:nvSpPr>
+        <p:spPr>
+          <a:xfrm>
+            <a:off x="1234440" y="6400000"/>
+            <a:ext cx="7148760" cy="230352"/>
+          </a:xfrm>
+          <a:prstGeom prst="rect">
+            <a:avLst/>
+          </a:prstGeom>
+          <a:noFill/>
+        </p:spPr>
+        <p:txBody>
+          <a:bodyPr wrap="square" lIns="0" rIns="0" tIns="18288" bIns="18288">
+            <a:spAutoFit/>
+          </a:bodyPr>
+          <a:lstStyle/>
+          <a:p>
+            <a:pPr algn="l"/>
+            <a:r>
+              <a:rPr sz="1200" b="0" i="0">
+                <a:solidFill>
+                  <a:srgbClr val="A8C8E8"/>
+                </a:solidFill>
+                <a:latin typeface="Calibri"/>
+              </a:rPr>
+              <a:t>Server minimises to tray — click X to hide, right-click to show or exit</a:t>
             </a:r>
           </a:p>
         </p:txBody>

</xml_diff>